<commit_message>
Complete protocol-frozen DoRA study for AIRI 2026
</commit_message>
<xml_diff>
--- a/poster/Lapin_Vladislav_DoRA_AIRI_2026.pptx
+++ b/poster/Lapin_Vladislav_DoRA_AIRI_2026.pptx
@@ -2,13 +2,13 @@
 <file path=ppt/presentation.xml><?xml version="1.0" encoding="utf-8"?>
 <p:presentation xmlns:p="http://schemas.openxmlformats.org/presentationml/2006/main">
   <p:sldMasterIdLst>
-    <p:sldMasterId xmlns:r="http://schemas.openxmlformats.org/officeDocument/2006/relationships" id="2147483648" r:id="R91ee16d8a1814b64"/>
+    <p:sldMasterId xmlns:r="http://schemas.openxmlformats.org/officeDocument/2006/relationships" id="2147483648" r:id="R9cf5abe7ca3243d4"/>
   </p:sldMasterIdLst>
   <p:notesMasterIdLst>
-    <p:notesMasterId xmlns:r="http://schemas.openxmlformats.org/officeDocument/2006/relationships" r:id="R3b107342d5ea400c"/>
+    <p:notesMasterId xmlns:r="http://schemas.openxmlformats.org/officeDocument/2006/relationships" r:id="Re5e9fe7dfca34cea"/>
   </p:notesMasterIdLst>
   <p:sldIdLst>
-    <p:sldId xmlns:r="http://schemas.openxmlformats.org/officeDocument/2006/relationships" id="256" r:id="Rf10289a5fba04b4a"/>
+    <p:sldId xmlns:r="http://schemas.openxmlformats.org/officeDocument/2006/relationships" id="256" r:id="R6cee9e0473404e54"/>
   </p:sldIdLst>
   <p:sldSz cx="21383625" cy="30275213"/>
   <p:notesSz cx="6858000" cy="9144000"/>
@@ -590,7 +590,7 @@
           <p:nvPr/>
         </p:nvPicPr>
         <p:blipFill>
-          <a:blip xmlns:r="http://schemas.openxmlformats.org/officeDocument/2006/relationships" xmlns:a="http://schemas.openxmlformats.org/drawingml/2006/main" r:embed="Ra301741397e94bfa"/>
+          <a:blip xmlns:r="http://schemas.openxmlformats.org/officeDocument/2006/relationships" xmlns:a="http://schemas.openxmlformats.org/drawingml/2006/main" r:embed="R10657e7a6d7348a1"/>
           <a:stretch xmlns:a="http://schemas.openxmlformats.org/drawingml/2006/main">
             <a:fillRect l="0" t="0" r="0" b="0"/>
           </a:stretch>
@@ -614,7 +614,7 @@
           <p:nvPr/>
         </p:nvPicPr>
         <p:blipFill>
-          <a:blip xmlns:r="http://schemas.openxmlformats.org/officeDocument/2006/relationships" xmlns:a="http://schemas.openxmlformats.org/drawingml/2006/main" r:embed="R8e73e9fb4a964b77"/>
+          <a:blip xmlns:r="http://schemas.openxmlformats.org/officeDocument/2006/relationships" xmlns:a="http://schemas.openxmlformats.org/drawingml/2006/main" r:embed="Rd03fe83c58aa4aac"/>
           <a:stretch xmlns:a="http://schemas.openxmlformats.org/drawingml/2006/main">
             <a:fillRect l="0" t="0" r="0" b="0"/>
           </a:stretch>
@@ -684,7 +684,7 @@
           <p:nvPr/>
         </p:nvPicPr>
         <p:blipFill>
-          <a:blip xmlns:r="http://schemas.openxmlformats.org/officeDocument/2006/relationships" xmlns:a="http://schemas.openxmlformats.org/drawingml/2006/main" r:embed="R0eb19099dd294f0e"/>
+          <a:blip xmlns:r="http://schemas.openxmlformats.org/officeDocument/2006/relationships" xmlns:a="http://schemas.openxmlformats.org/drawingml/2006/main" r:embed="Rc68a4f66c9c64fb0"/>
           <a:stretch xmlns:a="http://schemas.openxmlformats.org/drawingml/2006/main">
             <a:fillRect l="0" t="0" r="0" b="0"/>
           </a:stretch>
@@ -708,7 +708,7 @@
           <p:nvPr/>
         </p:nvPicPr>
         <p:blipFill>
-          <a:blip xmlns:r="http://schemas.openxmlformats.org/officeDocument/2006/relationships" xmlns:a="http://schemas.openxmlformats.org/drawingml/2006/main" r:embed="R2d6388a814424445"/>
+          <a:blip xmlns:r="http://schemas.openxmlformats.org/officeDocument/2006/relationships" xmlns:a="http://schemas.openxmlformats.org/drawingml/2006/main" r:embed="Rc44284c420694238"/>
           <a:stretch xmlns:a="http://schemas.openxmlformats.org/drawingml/2006/main">
             <a:fillRect l="0" t="0" r="0" b="0"/>
           </a:stretch>
@@ -875,7 +875,7 @@
   </p:cSld>
   <p:clrMap bg1="lt1" tx1="dk1" bg2="lt2" tx2="dk2" accent1="accent1" accent2="accent2" accent3="accent3" accent4="accent4" accent5="accent5" accent6="accent6" hlink="hlink" folHlink="folHlink"/>
   <p:sldLayoutIdLst>
-    <p:sldLayoutId xmlns:r="http://schemas.openxmlformats.org/officeDocument/2006/relationships" id="2147483649" r:id="Rbb3d70efb3734051"/>
+    <p:sldLayoutId xmlns:r="http://schemas.openxmlformats.org/officeDocument/2006/relationships" id="2147483649" r:id="R9f163b2d76364c59"/>
   </p:sldLayoutIdLst>
   <p:txStyles>
     <p:titleStyle>
@@ -1435,40 +1435,67 @@
         </p:nvSpPr>
         <p:spPr>
           <a:xfrm xmlns:a="http://schemas.openxmlformats.org/drawingml/2006/main">
-            <a:off x="1511812" y="2430030"/>
-            <a:ext cx="18360000" cy="1246495"/>
+            <a:off x="1511808" y="2133600"/>
+            <a:ext cx="18360009" cy="1695450"/>
           </a:xfrm>
         </p:spPr>
         <p:txBody>
           <a:bodyPr xmlns:a="http://schemas.openxmlformats.org/drawingml/2006/main" wrap="square" lIns="0" tIns="0" rIns="0" bIns="0" anchor="ctr">
-            <a:normAutofit fontScale="100000"/>
+            <a:noAutofit/>
           </a:bodyPr>
           <a:lstStyle xmlns:a="http://schemas.openxmlformats.org/drawingml/2006/main"/>
           <a:p xmlns:a="http://schemas.openxmlformats.org/drawingml/2006/main">
-            <a:pPr algn="l">
-              <a:lnSpc>
-                <a:spcPct val="92000"/>
-              </a:lnSpc>
-              <a:buNone/>
-              <a:defRPr sz="5400" b="0">
-                <a:solidFill>
-                  <a:srgbClr val="111111"/>
-                </a:solidFill>
-                <a:latin typeface="Arial"/>
-                <a:ea typeface="Arial"/>
-                <a:cs typeface="Arial"/>
-              </a:defRPr>
-            </a:pPr>
-            <a:r>
-              <a:rPr sz="5400" b="0">
-                <a:solidFill>
-                  <a:srgbClr val="111111"/>
-                </a:solidFill>
-                <a:latin typeface="Arial"/>
-                <a:ea typeface="Arial"/>
-                <a:cs typeface="Arial"/>
-              </a:rPr>
-              <a:t>DoRA vs LoRA: когда декомпозиция весов помогает?</a:t>
+            <a:pPr algn="ctr">
+              <a:lnSpc>
+                <a:spcPct val="94000"/>
+              </a:lnSpc>
+              <a:buNone/>
+              <a:defRPr sz="4950" b="0">
+                <a:solidFill>
+                  <a:srgbClr val="101820"/>
+                </a:solidFill>
+                <a:latin typeface="Arial"/>
+                <a:ea typeface="Arial"/>
+                <a:cs typeface="Arial"/>
+              </a:defRPr>
+            </a:pPr>
+            <a:r>
+              <a:rPr sz="4950" b="0">
+                <a:solidFill>
+                  <a:srgbClr val="101820"/>
+                </a:solidFill>
+                <a:latin typeface="Arial"/>
+                <a:ea typeface="Arial"/>
+                <a:cs typeface="Arial"/>
+              </a:rPr>
+              <a:t>When does DoRA help?</a:t>
+            </a:r>
+          </a:p>
+          <a:p xmlns:a="http://schemas.openxmlformats.org/drawingml/2006/main">
+            <a:pPr algn="ctr">
+              <a:lnSpc>
+                <a:spcPct val="94000"/>
+              </a:lnSpc>
+              <a:buNone/>
+              <a:defRPr sz="4950" b="0">
+                <a:solidFill>
+                  <a:srgbClr val="101820"/>
+                </a:solidFill>
+                <a:latin typeface="Arial"/>
+                <a:ea typeface="Arial"/>
+                <a:cs typeface="Arial"/>
+              </a:defRPr>
+            </a:pPr>
+            <a:r>
+              <a:rPr sz="4950" b="0">
+                <a:solidFill>
+                  <a:srgbClr val="101820"/>
+                </a:solidFill>
+                <a:latin typeface="Arial"/>
+                <a:ea typeface="Arial"/>
+                <a:cs typeface="Arial"/>
+              </a:rPr>
+              <a:t>Geometry, budgets, and confirmatory few-shot adaptation</a:t>
             </a:r>
           </a:p>
         </p:txBody>
@@ -1489,8 +1516,8 @@
         </p:nvSpPr>
         <p:spPr>
           <a:xfrm xmlns:a="http://schemas.openxmlformats.org/drawingml/2006/main">
-            <a:off x="4594660" y="4258828"/>
-            <a:ext cx="12194304" cy="497434"/>
+            <a:off x="3642170" y="4171950"/>
+            <a:ext cx="14099286" cy="514350"/>
           </a:xfrm>
           <a:prstGeom xmlns:a="http://schemas.openxmlformats.org/drawingml/2006/main" prst="rect">
             <a:avLst/>
@@ -1498,7 +1525,7 @@
         </p:spPr>
         <p:txBody>
           <a:bodyPr xmlns:a="http://schemas.openxmlformats.org/drawingml/2006/main" vert="horz" wrap="square" lIns="0" tIns="0" rIns="0" bIns="0" anchor="ctr">
-            <a:normAutofit fontScale="100000"/>
+            <a:noAutofit/>
           </a:bodyPr>
           <a:lstStyle xmlns:a="http://schemas.openxmlformats.org/drawingml/2006/main">
             <a:lvl1pPr algn="ctr">
@@ -1522,25 +1549,25 @@
                 <a:spcPct val="102000"/>
               </a:lnSpc>
               <a:buNone/>
-              <a:defRPr sz="3200" b="0">
-                <a:solidFill>
-                  <a:srgbClr val="5B6268"/>
-                </a:solidFill>
-                <a:latin typeface="Arial"/>
-                <a:ea typeface="Arial"/>
-                <a:cs typeface="Arial"/>
-              </a:defRPr>
-            </a:pPr>
-            <a:r>
-              <a:rPr sz="3200" b="0">
-                <a:solidFill>
-                  <a:srgbClr val="5B6268"/>
-                </a:solidFill>
-                <a:latin typeface="Arial"/>
-                <a:ea typeface="Arial"/>
-                <a:cs typeface="Arial"/>
-              </a:rPr>
-              <a:t>Владислав Лапин · МФТИ ФПМИ / AI360</a:t>
+              <a:defRPr sz="2550" b="0">
+                <a:solidFill>
+                  <a:srgbClr val="5F6870"/>
+                </a:solidFill>
+                <a:latin typeface="Arial"/>
+                <a:ea typeface="Arial"/>
+                <a:cs typeface="Arial"/>
+              </a:defRPr>
+            </a:pPr>
+            <a:r>
+              <a:rPr sz="2550" b="0">
+                <a:solidFill>
+                  <a:srgbClr val="5F6870"/>
+                </a:solidFill>
+                <a:latin typeface="Arial"/>
+                <a:ea typeface="Arial"/>
+                <a:cs typeface="Arial"/>
+              </a:rPr>
+              <a:t>Vladislav Lapin  ·  MIPT FPMI / AI360  ·  AIRI Summer School 2026</a:t>
             </a:r>
           </a:p>
         </p:txBody>
@@ -1561,8 +1588,8 @@
         </p:nvSpPr>
         <p:spPr>
           <a:xfrm xmlns:a="http://schemas.openxmlformats.org/drawingml/2006/main">
-            <a:off x="11540382" y="10942257"/>
-            <a:ext cx="8328874" cy="1477328"/>
+            <a:off x="11540395" y="7029450"/>
+            <a:ext cx="8328851" cy="685800"/>
           </a:xfrm>
           <a:prstGeom xmlns:a="http://schemas.openxmlformats.org/drawingml/2006/main" prst="rect">
             <a:avLst/>
@@ -1570,7 +1597,7 @@
         </p:spPr>
         <p:txBody>
           <a:bodyPr xmlns:a="http://schemas.openxmlformats.org/drawingml/2006/main" vert="horz" wrap="square" lIns="0" tIns="0" rIns="0" bIns="0" anchor="ctr">
-            <a:normAutofit fontScale="100000"/>
+            <a:noAutofit/>
           </a:bodyPr>
           <a:lstStyle xmlns:a="http://schemas.openxmlformats.org/drawingml/2006/main">
             <a:lvl1pPr algn="ctr">
@@ -1594,25 +1621,25 @@
                 <a:spcPct val="94000"/>
               </a:lnSpc>
               <a:buNone/>
-              <a:defRPr sz="4800" b="0">
-                <a:solidFill>
-                  <a:srgbClr val="111111"/>
-                </a:solidFill>
-                <a:latin typeface="Arial"/>
-                <a:ea typeface="Arial"/>
-                <a:cs typeface="Arial"/>
-              </a:defRPr>
-            </a:pPr>
-            <a:r>
-              <a:rPr sz="4800" b="0">
-                <a:solidFill>
-                  <a:srgbClr val="111111"/>
-                </a:solidFill>
-                <a:latin typeface="Arial"/>
-                <a:ea typeface="Arial"/>
-                <a:cs typeface="Arial"/>
-              </a:rPr>
-              <a:t>Главный результат</a:t>
+              <a:defRPr sz="3750" b="1">
+                <a:solidFill>
+                  <a:srgbClr val="008A80"/>
+                </a:solidFill>
+                <a:latin typeface="Arial"/>
+                <a:ea typeface="Arial"/>
+                <a:cs typeface="Arial"/>
+              </a:defRPr>
+            </a:pPr>
+            <a:r>
+              <a:rPr sz="3750" b="1">
+                <a:solidFill>
+                  <a:srgbClr val="008A80"/>
+                </a:solidFill>
+                <a:latin typeface="Arial"/>
+                <a:ea typeface="Arial"/>
+                <a:cs typeface="Arial"/>
+              </a:rPr>
+              <a:t>+1.06 pp MLP  ·  +0.92 pp CNN</a:t>
             </a:r>
           </a:p>
         </p:txBody>
@@ -1693,8 +1720,8 @@
         </p:nvSpPr>
         <p:spPr>
           <a:xfrm xmlns:a="http://schemas.openxmlformats.org/drawingml/2006/main">
-            <a:off x="11542938" y="12833810"/>
-            <a:ext cx="8328874" cy="32098107"/>
+            <a:off x="11542966" y="7848600"/>
+            <a:ext cx="8328851" cy="1190625"/>
           </a:xfrm>
           <a:prstGeom xmlns:a="http://schemas.openxmlformats.org/drawingml/2006/main" prst="rect">
             <a:avLst/>
@@ -1702,7 +1729,7 @@
         </p:spPr>
         <p:txBody>
           <a:bodyPr xmlns:a="http://schemas.openxmlformats.org/drawingml/2006/main" vert="horz" wrap="square" lIns="0" tIns="0" rIns="0" bIns="0" anchor="t">
-            <a:normAutofit fontScale="100000"/>
+            <a:noAutofit/>
           </a:bodyPr>
           <a:lstStyle xmlns:a="http://schemas.openxmlformats.org/drawingml/2006/main">
             <a:lvl1pPr algn="ctr">
@@ -1723,124 +1750,86 @@
           <a:p xmlns:a="http://schemas.openxmlformats.org/drawingml/2006/main">
             <a:pPr marL="24" indent="-14" algn="l">
               <a:lnSpc>
-                <a:spcPct val="96000"/>
+                <a:spcPct val="106000"/>
               </a:lnSpc>
               <a:spcAft>
                 <a:spcPts val="7"/>
               </a:spcAft>
               <a:buNone/>
-              <a:defRPr sz="2288" b="0">
-                <a:solidFill>
-                  <a:srgbClr val="111111"/>
-                </a:solidFill>
-                <a:latin typeface="Arial"/>
-                <a:ea typeface="Arial"/>
-                <a:cs typeface="Arial"/>
-              </a:defRPr>
-            </a:pPr>
-            <a:r>
-              <a:rPr sz="2288" b="0">
-                <a:solidFill>
-                  <a:srgbClr val="111111"/>
-                </a:solidFill>
-                <a:latin typeface="Arial"/>
-                <a:ea typeface="Arial"/>
-                <a:cs typeface="Arial"/>
-              </a:rPr>
-              <a:t>Синтетика, r=4, γ=.8: </a:t>
-            </a:r>
-            <a:r>
-              <a:rPr sz="2288" b="0">
-                <a:solidFill>
-                  <a:srgbClr val="111111"/>
-                </a:solidFill>
-                <a:latin typeface="Arial"/>
-                <a:ea typeface="Arial"/>
-                <a:cs typeface="Arial"/>
-              </a:rPr>
-              <a:t>LoRA oracle error = 0.2923; DoRA ≤ 1.5×10⁻⁷. При γ=0 обе ошибки ≈0.</a:t>
-            </a:r>
-          </a:p>
-          <a:p xmlns:a="http://schemas.openxmlformats.org/drawingml/2006/main">
-            <a:pPr marL="24" indent="-14" algn="l">
-              <a:lnSpc>
-                <a:spcPct val="96000"/>
-              </a:lnSpc>
-              <a:spcAft>
-                <a:spcPts val="7"/>
-              </a:spcAft>
-              <a:buNone/>
-              <a:defRPr sz="2288" b="0">
-                <a:solidFill>
-                  <a:srgbClr val="111111"/>
-                </a:solidFill>
-                <a:latin typeface="Arial"/>
-                <a:ea typeface="Arial"/>
-                <a:cs typeface="Arial"/>
-              </a:defRPr>
-            </a:pPr>
-            <a:r>
-              <a:rPr sz="2288" b="0">
-                <a:solidFill>
-                  <a:srgbClr val="111111"/>
-                </a:solidFill>
-                <a:latin typeface="Arial"/>
-                <a:ea typeface="Arial"/>
-                <a:cs typeface="Arial"/>
-              </a:rPr>
-              <a:t>Реальные shifts, r=4: </a:t>
-            </a:r>
-            <a:r>
-              <a:rPr sz="2288" b="0">
-                <a:solidFill>
-                  <a:srgbClr val="111111"/>
-                </a:solidFill>
-                <a:latin typeface="Arial"/>
-                <a:ea typeface="Arial"/>
-                <a:cs typeface="Arial"/>
-              </a:rPr>
-              <a:t>DoRA−LoRA = +0.33 pp contrast, +0.67 pp rotation, +1.39 pp mixed; CI &gt; 0 для rotation и mixed.</a:t>
-            </a:r>
-          </a:p>
-          <a:p xmlns:a="http://schemas.openxmlformats.org/drawingml/2006/main">
-            <a:pPr marL="24" indent="-14" algn="l">
-              <a:lnSpc>
-                <a:spcPct val="96000"/>
-              </a:lnSpc>
-              <a:spcAft>
-                <a:spcPts val="7"/>
-              </a:spcAft>
-              <a:buNone/>
-              <a:defRPr sz="2288" b="0">
-                <a:solidFill>
-                  <a:srgbClr val="111111"/>
-                </a:solidFill>
-                <a:latin typeface="Arial"/>
-                <a:ea typeface="Arial"/>
-                <a:cs typeface="Arial"/>
-              </a:defRPr>
-            </a:pPr>
-            <a:r>
-              <a:rPr sz="2288" b="0">
-                <a:solidFill>
-                  <a:srgbClr val="111111"/>
-                </a:solidFill>
-                <a:latin typeface="Arial"/>
-                <a:ea typeface="Arial"/>
-                <a:cs typeface="Arial"/>
-              </a:rPr>
-              <a:t>Контрпример: </a:t>
-            </a:r>
-            <a:r>
-              <a:rPr sz="2288" b="0">
-                <a:solidFill>
-                  <a:srgbClr val="111111"/>
-                </a:solidFill>
-                <a:latin typeface="Arial"/>
-                <a:ea typeface="Arial"/>
-                <a:cs typeface="Arial"/>
-              </a:rPr>
-              <a:t>rotation r=8 - LoRA 94.61%, DoRA 94.22%. Универсального превосходства нет.</a:t>
+              <a:defRPr sz="2025" b="0">
+                <a:solidFill>
+                  <a:srgbClr val="101820"/>
+                </a:solidFill>
+                <a:latin typeface="Arial"/>
+                <a:ea typeface="Arial"/>
+                <a:cs typeface="Arial"/>
+              </a:defRPr>
+            </a:pPr>
+            <a:r>
+              <a:rPr sz="2025" b="1">
+                <a:solidFill>
+                  <a:srgbClr val="101820"/>
+                </a:solidFill>
+                <a:latin typeface="Arial"/>
+                <a:ea typeface="Arial"/>
+                <a:cs typeface="Arial"/>
+              </a:rPr>
+              <a:t>15/20</a:t>
+            </a:r>
+            <a:r>
+              <a:rPr sz="2025" b="0">
+                <a:solidFill>
+                  <a:srgbClr val="101820"/>
+                </a:solidFill>
+                <a:latin typeface="Arial"/>
+                <a:ea typeface="Arial"/>
+                <a:cs typeface="Arial"/>
+              </a:rPr>
+              <a:t> MLP seeds and </a:t>
+            </a:r>
+            <a:r>
+              <a:rPr sz="2025" b="1">
+                <a:solidFill>
+                  <a:srgbClr val="101820"/>
+                </a:solidFill>
+                <a:latin typeface="Arial"/>
+                <a:ea typeface="Arial"/>
+                <a:cs typeface="Arial"/>
+              </a:rPr>
+              <a:t>8/10</a:t>
+            </a:r>
+            <a:r>
+              <a:rPr sz="2025" b="0">
+                <a:solidFill>
+                  <a:srgbClr val="101820"/>
+                </a:solidFill>
+                <a:latin typeface="Arial"/>
+                <a:ea typeface="Arial"/>
+                <a:cs typeface="Arial"/>
+              </a:rPr>
+              <a:t> CNN seeds favored DoRA. The unadjusted 95% CI excludes zero for CNN, not MLP; </a:t>
+            </a:r>
+            <a:r>
+              <a:rPr sz="2025" b="1">
+                <a:solidFill>
+                  <a:srgbClr val="101820"/>
+                </a:solidFill>
+                <a:latin typeface="Arial"/>
+                <a:ea typeface="Arial"/>
+                <a:cs typeface="Arial"/>
+              </a:rPr>
+              <a:t>Holm-adjusted</a:t>
+            </a:r>
+            <a:r>
+              <a:rPr sz="2025" b="0">
+                <a:solidFill>
+                  <a:srgbClr val="101820"/>
+                </a:solidFill>
+                <a:latin typeface="Arial"/>
+                <a:ea typeface="Arial"/>
+                <a:cs typeface="Arial"/>
+              </a:rPr>
+              <a:t> comparison families remain inconclusive.</a:t>
             </a:r>
           </a:p>
         </p:txBody>
@@ -1861,16 +1850,16 @@
         </p:nvSpPr>
         <p:spPr>
           <a:xfrm xmlns:a="http://schemas.openxmlformats.org/drawingml/2006/main">
-            <a:off x="11540382" y="20773642"/>
-            <a:ext cx="8328874" cy="310896"/>
+            <a:off x="11540395" y="21878925"/>
+            <a:ext cx="8328851" cy="295275"/>
           </a:xfrm>
           <a:prstGeom xmlns:a="http://schemas.openxmlformats.org/drawingml/2006/main" prst="rect">
             <a:avLst/>
           </a:prstGeom>
         </p:spPr>
         <p:txBody>
-          <a:bodyPr xmlns:a="http://schemas.openxmlformats.org/drawingml/2006/main" vert="horz" wrap="square" lIns="0" tIns="0" rIns="0" bIns="0" anchor="ctr">
-            <a:normAutofit fontScale="100000"/>
+          <a:bodyPr xmlns:a="http://schemas.openxmlformats.org/drawingml/2006/main" vert="horz" wrap="square" lIns="0" tIns="0" rIns="0" bIns="0" anchor="t">
+            <a:noAutofit/>
           </a:bodyPr>
           <a:lstStyle xmlns:a="http://schemas.openxmlformats.org/drawingml/2006/main">
             <a:lvl1pPr algn="ctr">
@@ -1894,25 +1883,25 @@
                 <a:spcPct val="102000"/>
               </a:lnSpc>
               <a:buNone/>
-              <a:defRPr sz="2000" b="0">
-                <a:solidFill>
-                  <a:srgbClr val="5B6268"/>
-                </a:solidFill>
-                <a:latin typeface="Arial"/>
-                <a:ea typeface="Arial"/>
-                <a:cs typeface="Arial"/>
-              </a:defRPr>
-            </a:pPr>
-            <a:r>
-              <a:rPr sz="2000" b="0">
-                <a:solidFill>
-                  <a:srgbClr val="5B6268"/>
-                </a:solidFill>
-                <a:latin typeface="Arial"/>
-                <a:ea typeface="Arial"/>
-                <a:cs typeface="Arial"/>
-              </a:rPr>
-              <a:t>Рис. 2. Capacity gap и paired test gain; среднее ± 95% CI, 5 seeds.</a:t>
+              <a:defRPr sz="1500" b="0">
+                <a:solidFill>
+                  <a:srgbClr val="5F6870"/>
+                </a:solidFill>
+                <a:latin typeface="Arial"/>
+                <a:ea typeface="Arial"/>
+                <a:cs typeface="Arial"/>
+              </a:defRPr>
+            </a:pPr>
+            <a:r>
+              <a:rPr sz="1500" b="0">
+                <a:solidFill>
+                  <a:srgbClr val="5F6870"/>
+                </a:solidFill>
+                <a:latin typeface="Arial"/>
+                <a:ea typeface="Arial"/>
+                <a:cs typeface="Arial"/>
+              </a:rPr>
+              <a:t>Figure 2. Replication → data regime → capacity / optimization diagnostic.</a:t>
             </a:r>
           </a:p>
         </p:txBody>
@@ -1933,16 +1922,16 @@
         </p:nvSpPr>
         <p:spPr>
           <a:xfrm xmlns:a="http://schemas.openxmlformats.org/drawingml/2006/main">
-            <a:off x="1512323" y="6653687"/>
-            <a:ext cx="8328874" cy="738664"/>
+            <a:off x="1512284" y="6572250"/>
+            <a:ext cx="8328851" cy="590550"/>
           </a:xfrm>
           <a:prstGeom xmlns:a="http://schemas.openxmlformats.org/drawingml/2006/main" prst="rect">
             <a:avLst/>
           </a:prstGeom>
         </p:spPr>
         <p:txBody>
-          <a:bodyPr xmlns:a="http://schemas.openxmlformats.org/drawingml/2006/main" vert="horz" wrap="square" lIns="0" tIns="0" rIns="0" bIns="0" anchor="ctr">
-            <a:normAutofit fontScale="100000"/>
+          <a:bodyPr xmlns:a="http://schemas.openxmlformats.org/drawingml/2006/main" vert="horz" wrap="square" lIns="0" tIns="0" rIns="0" bIns="0" anchor="t">
+            <a:noAutofit/>
           </a:bodyPr>
           <a:lstStyle xmlns:a="http://schemas.openxmlformats.org/drawingml/2006/main">
             <a:lvl1pPr algn="ctr">
@@ -1966,25 +1955,25 @@
                 <a:spcPct val="94000"/>
               </a:lnSpc>
               <a:buNone/>
-              <a:defRPr sz="4800" b="0">
-                <a:solidFill>
-                  <a:srgbClr val="111111"/>
-                </a:solidFill>
-                <a:latin typeface="Arial"/>
-                <a:ea typeface="Arial"/>
-                <a:cs typeface="Arial"/>
-              </a:defRPr>
-            </a:pPr>
-            <a:r>
-              <a:rPr sz="4800" b="0">
-                <a:solidFill>
-                  <a:srgbClr val="111111"/>
-                </a:solidFill>
-                <a:latin typeface="Arial"/>
-                <a:ea typeface="Arial"/>
-                <a:cs typeface="Arial"/>
-              </a:rPr>
-              <a:t>Мотивация</a:t>
+              <a:defRPr sz="3225" b="0">
+                <a:solidFill>
+                  <a:srgbClr val="101820"/>
+                </a:solidFill>
+                <a:latin typeface="Arial"/>
+                <a:ea typeface="Arial"/>
+                <a:cs typeface="Arial"/>
+              </a:defRPr>
+            </a:pPr>
+            <a:r>
+              <a:rPr sz="3225" b="0">
+                <a:solidFill>
+                  <a:srgbClr val="101820"/>
+                </a:solidFill>
+                <a:latin typeface="Arial"/>
+                <a:ea typeface="Arial"/>
+                <a:cs typeface="Arial"/>
+              </a:rPr>
+              <a:t>Why separate magnitude from direction?</a:t>
             </a:r>
           </a:p>
         </p:txBody>
@@ -2065,8 +2054,8 @@
         </p:nvSpPr>
         <p:spPr>
           <a:xfrm xmlns:a="http://schemas.openxmlformats.org/drawingml/2006/main">
-            <a:off x="1509767" y="7624916"/>
-            <a:ext cx="8328874" cy="41973627"/>
+            <a:off x="1509808" y="7400925"/>
+            <a:ext cx="8328851" cy="3752850"/>
           </a:xfrm>
           <a:prstGeom xmlns:a="http://schemas.openxmlformats.org/drawingml/2006/main" prst="rect">
             <a:avLst/>
@@ -2074,7 +2063,7 @@
         </p:spPr>
         <p:txBody>
           <a:bodyPr xmlns:a="http://schemas.openxmlformats.org/drawingml/2006/main" vert="horz" wrap="square" lIns="0" tIns="0" rIns="0" bIns="0" anchor="t">
-            <a:normAutofit fontScale="100000"/>
+            <a:noAutofit/>
           </a:bodyPr>
           <a:lstStyle xmlns:a="http://schemas.openxmlformats.org/drawingml/2006/main">
             <a:lvl1pPr algn="ctr">
@@ -2095,42 +2084,31 @@
           <a:p xmlns:a="http://schemas.openxmlformats.org/drawingml/2006/main">
             <a:pPr marL="24" indent="-14" algn="l">
               <a:lnSpc>
-                <a:spcPct val="100000"/>
+                <a:spcPct val="108000"/>
               </a:lnSpc>
               <a:spcAft>
                 <a:spcPts val="7"/>
               </a:spcAft>
               <a:buNone/>
-              <a:defRPr sz="2400" b="0">
-                <a:solidFill>
-                  <a:srgbClr val="111111"/>
-                </a:solidFill>
-                <a:latin typeface="Arial"/>
-                <a:ea typeface="Arial"/>
-                <a:cs typeface="Arial"/>
-              </a:defRPr>
-            </a:pPr>
-            <a:r>
-              <a:rPr sz="2400" b="0">
-                <a:solidFill>
-                  <a:srgbClr val="111111"/>
-                </a:solidFill>
-                <a:latin typeface="Arial"/>
-                <a:ea typeface="Arial"/>
-                <a:cs typeface="Arial"/>
-              </a:rPr>
-              <a:t>Full fine-tuning </a:t>
-            </a:r>
-            <a:r>
-              <a:rPr sz="2400" b="0">
-                <a:solidFill>
-                  <a:srgbClr val="111111"/>
-                </a:solidFill>
-                <a:latin typeface="Arial"/>
-                <a:ea typeface="Arial"/>
-                <a:cs typeface="Arial"/>
-              </a:rPr>
-              <a:t>точен, но обновляет все параметры. LoRA дешевле, однако одна low-rank поправка одновременно меняет норму и направление строк W.</a:t>
+              <a:defRPr sz="2100" b="0">
+                <a:solidFill>
+                  <a:srgbClr val="101820"/>
+                </a:solidFill>
+                <a:latin typeface="Arial"/>
+                <a:ea typeface="Arial"/>
+                <a:cs typeface="Arial"/>
+              </a:defRPr>
+            </a:pPr>
+            <a:r>
+              <a:rPr sz="2100" b="0">
+                <a:solidFill>
+                  <a:srgbClr val="101820"/>
+                </a:solidFill>
+                <a:latin typeface="Arial"/>
+                <a:ea typeface="Arial"/>
+                <a:cs typeface="Arial"/>
+              </a:rPr>
+              <a:t>LoRA adds a low-rank update BA, coupling row direction and row norm. DoRA writes W = m ⊙ (W₀ + BA) / ‖W₀ + BA‖₂, so BA controls direction while m controls row scale.</a:t>
             </a:r>
           </a:p>
           <a:p xmlns:a="http://schemas.openxmlformats.org/drawingml/2006/main">
@@ -2160,59 +2138,48 @@
                 <a:ea typeface="Arial"/>
                 <a:cs typeface="Arial"/>
               </a:rPr>
-              <a:t>DoRA </a:t>
-            </a:r>
-            <a:r>
-              <a:rPr sz="2400" b="0">
-                <a:solidFill>
-                  <a:srgbClr val="111111"/>
-                </a:solidFill>
-                <a:latin typeface="Arial"/>
-                <a:ea typeface="Arial"/>
-                <a:cs typeface="Arial"/>
-              </a:rPr>
-              <a:t>задаёт Ŵ = m ⊙ V / ‖V‖₂, где V = W₀ + BA: BA отвечает за направление, m - за масштаб каждой строки.</a:t>
+              <a:t/>
             </a:r>
           </a:p>
           <a:p xmlns:a="http://schemas.openxmlformats.org/drawingml/2006/main">
             <a:pPr marL="24" indent="-14" algn="l">
               <a:lnSpc>
-                <a:spcPct val="100000"/>
+                <a:spcPct val="108000"/>
               </a:lnSpc>
               <a:spcAft>
                 <a:spcPts val="7"/>
               </a:spcAft>
               <a:buNone/>
-              <a:defRPr sz="2400" b="0">
-                <a:solidFill>
-                  <a:srgbClr val="111111"/>
-                </a:solidFill>
-                <a:latin typeface="Arial"/>
-                <a:ea typeface="Arial"/>
-                <a:cs typeface="Arial"/>
-              </a:defRPr>
-            </a:pPr>
-            <a:r>
-              <a:rPr sz="2400" b="0">
-                <a:solidFill>
-                  <a:srgbClr val="111111"/>
-                </a:solidFill>
-                <a:latin typeface="Arial"/>
-                <a:ea typeface="Arial"/>
-                <a:cs typeface="Arial"/>
-              </a:rPr>
-              <a:t>Исследовательский вопрос: </a:t>
-            </a:r>
-            <a:r>
-              <a:rPr sz="2400" b="0">
-                <a:solidFill>
-                  <a:srgbClr val="111111"/>
-                </a:solidFill>
-                <a:latin typeface="Arial"/>
-                <a:ea typeface="Arial"/>
-                <a:cs typeface="Arial"/>
-              </a:rPr>
-              <a:t>когда дополнительные magnitude-параметры действительно дают преимущество, а когда LoRA достаточно?</a:t>
+              <a:defRPr sz="2100" b="0">
+                <a:solidFill>
+                  <a:srgbClr val="101820"/>
+                </a:solidFill>
+                <a:latin typeface="Arial"/>
+                <a:ea typeface="Arial"/>
+                <a:cs typeface="Arial"/>
+              </a:defRPr>
+            </a:pPr>
+            <a:r>
+              <a:rPr sz="2100" b="1">
+                <a:solidFill>
+                  <a:srgbClr val="101820"/>
+                </a:solidFill>
+                <a:latin typeface="Arial"/>
+                <a:ea typeface="Arial"/>
+                <a:cs typeface="Arial"/>
+              </a:rPr>
+              <a:t>Research question:</a:t>
+            </a:r>
+            <a:r>
+              <a:rPr sz="2100" b="0">
+                <a:solidFill>
+                  <a:srgbClr val="101820"/>
+                </a:solidFill>
+                <a:latin typeface="Arial"/>
+                <a:ea typeface="Arial"/>
+                <a:cs typeface="Arial"/>
+              </a:rPr>
+              <a:t> does this extra degree of freedom improve target adaptation after fair selection, budget controls, and negative controls?</a:t>
             </a:r>
           </a:p>
         </p:txBody>
@@ -2233,16 +2200,16 @@
         </p:nvSpPr>
         <p:spPr>
           <a:xfrm xmlns:a="http://schemas.openxmlformats.org/drawingml/2006/main">
-            <a:off x="1509767" y="17166206"/>
-            <a:ext cx="8328874" cy="621792"/>
+            <a:off x="1509808" y="17106900"/>
+            <a:ext cx="8328851" cy="419100"/>
           </a:xfrm>
           <a:prstGeom xmlns:a="http://schemas.openxmlformats.org/drawingml/2006/main" prst="rect">
             <a:avLst/>
           </a:prstGeom>
         </p:spPr>
         <p:txBody>
-          <a:bodyPr xmlns:a="http://schemas.openxmlformats.org/drawingml/2006/main" vert="horz" wrap="square" lIns="0" tIns="0" rIns="0" bIns="0" anchor="ctr">
-            <a:normAutofit fontScale="100000"/>
+          <a:bodyPr xmlns:a="http://schemas.openxmlformats.org/drawingml/2006/main" vert="horz" wrap="square" lIns="0" tIns="0" rIns="0" bIns="0" anchor="t">
+            <a:noAutofit/>
           </a:bodyPr>
           <a:lstStyle xmlns:a="http://schemas.openxmlformats.org/drawingml/2006/main">
             <a:lvl1pPr algn="ctr">
@@ -2266,25 +2233,25 @@
                 <a:spcPct val="102000"/>
               </a:lnSpc>
               <a:buNone/>
-              <a:defRPr sz="2000" b="0">
-                <a:solidFill>
-                  <a:srgbClr val="5B6268"/>
-                </a:solidFill>
-                <a:latin typeface="Arial"/>
-                <a:ea typeface="Arial"/>
-                <a:cs typeface="Arial"/>
-              </a:defRPr>
-            </a:pPr>
-            <a:r>
-              <a:rPr sz="2000" b="0">
-                <a:solidFill>
-                  <a:srgbClr val="5B6268"/>
-                </a:solidFill>
-                <a:latin typeface="Arial"/>
-                <a:ea typeface="Arial"/>
-                <a:cs typeface="Arial"/>
-              </a:rPr>
-              <a:t>Рис. 1. LoRA связывает масштаб и направление; DoRA разделяет их явно.</a:t>
+              <a:defRPr sz="1650" b="0">
+                <a:solidFill>
+                  <a:srgbClr val="5F6870"/>
+                </a:solidFill>
+                <a:latin typeface="Arial"/>
+                <a:ea typeface="Arial"/>
+                <a:cs typeface="Arial"/>
+              </a:defRPr>
+            </a:pPr>
+            <a:r>
+              <a:rPr sz="1650" b="0">
+                <a:solidFill>
+                  <a:srgbClr val="5F6870"/>
+                </a:solidFill>
+                <a:latin typeface="Arial"/>
+                <a:ea typeface="Arial"/>
+                <a:cs typeface="Arial"/>
+              </a:rPr>
+              <a:t>Figure 1. LoRA couples scale and direction; DoRA models row scale explicitly.</a:t>
             </a:r>
           </a:p>
         </p:txBody>
@@ -2305,16 +2272,16 @@
         </p:nvSpPr>
         <p:spPr>
           <a:xfrm xmlns:a="http://schemas.openxmlformats.org/drawingml/2006/main">
-            <a:off x="1509767" y="18111914"/>
-            <a:ext cx="8328874" cy="738664"/>
+            <a:off x="1509808" y="17859375"/>
+            <a:ext cx="8328851" cy="590550"/>
           </a:xfrm>
           <a:prstGeom xmlns:a="http://schemas.openxmlformats.org/drawingml/2006/main" prst="rect">
             <a:avLst/>
           </a:prstGeom>
         </p:spPr>
         <p:txBody>
-          <a:bodyPr xmlns:a="http://schemas.openxmlformats.org/drawingml/2006/main" vert="horz" wrap="square" lIns="0" tIns="0" rIns="0" bIns="0" anchor="ctr">
-            <a:normAutofit fontScale="100000"/>
+          <a:bodyPr xmlns:a="http://schemas.openxmlformats.org/drawingml/2006/main" vert="horz" wrap="square" lIns="0" tIns="0" rIns="0" bIns="0" anchor="t">
+            <a:noAutofit/>
           </a:bodyPr>
           <a:lstStyle xmlns:a="http://schemas.openxmlformats.org/drawingml/2006/main">
             <a:lvl1pPr algn="ctr">
@@ -2338,25 +2305,25 @@
                 <a:spcPct val="94000"/>
               </a:lnSpc>
               <a:buNone/>
-              <a:defRPr sz="4800" b="0">
-                <a:solidFill>
-                  <a:srgbClr val="111111"/>
-                </a:solidFill>
-                <a:latin typeface="Arial"/>
-                <a:ea typeface="Arial"/>
-                <a:cs typeface="Arial"/>
-              </a:defRPr>
-            </a:pPr>
-            <a:r>
-              <a:rPr sz="4800" b="0">
-                <a:solidFill>
-                  <a:srgbClr val="111111"/>
-                </a:solidFill>
-                <a:latin typeface="Arial"/>
-                <a:ea typeface="Arial"/>
-                <a:cs typeface="Arial"/>
-              </a:rPr>
-              <a:t>Гипотезы и метрики</a:t>
+              <a:defRPr sz="3225" b="0">
+                <a:solidFill>
+                  <a:srgbClr val="101820"/>
+                </a:solidFill>
+                <a:latin typeface="Arial"/>
+                <a:ea typeface="Arial"/>
+                <a:cs typeface="Arial"/>
+              </a:defRPr>
+            </a:pPr>
+            <a:r>
+              <a:rPr sz="3225" b="0">
+                <a:solidFill>
+                  <a:srgbClr val="101820"/>
+                </a:solidFill>
+                <a:latin typeface="Arial"/>
+                <a:ea typeface="Arial"/>
+                <a:cs typeface="Arial"/>
+              </a:rPr>
+              <a:t>Frozen protocol before confirmatory testing</a:t>
             </a:r>
           </a:p>
         </p:txBody>
@@ -2377,8 +2344,8 @@
         </p:nvSpPr>
         <p:spPr>
           <a:xfrm xmlns:a="http://schemas.openxmlformats.org/drawingml/2006/main">
-            <a:off x="1509767" y="19092852"/>
-            <a:ext cx="8328874" cy="39504747"/>
+            <a:off x="1509808" y="18630900"/>
+            <a:ext cx="8328851" cy="3771900"/>
           </a:xfrm>
           <a:prstGeom xmlns:a="http://schemas.openxmlformats.org/drawingml/2006/main" prst="rect">
             <a:avLst/>
@@ -2386,7 +2353,7 @@
         </p:spPr>
         <p:txBody>
           <a:bodyPr xmlns:a="http://schemas.openxmlformats.org/drawingml/2006/main" vert="horz" wrap="square" lIns="0" tIns="0" rIns="0" bIns="0" anchor="t">
-            <a:normAutofit fontScale="100000"/>
+            <a:noAutofit/>
           </a:bodyPr>
           <a:lstStyle xmlns:a="http://schemas.openxmlformats.org/drawingml/2006/main">
             <a:lvl1pPr algn="ctr">
@@ -2407,165 +2374,206 @@
           <a:p xmlns:a="http://schemas.openxmlformats.org/drawingml/2006/main">
             <a:pPr marL="24" indent="-14" algn="l">
               <a:lnSpc>
-                <a:spcPct val="99000"/>
+                <a:spcPct val="106000"/>
               </a:lnSpc>
               <a:spcAft>
                 <a:spcPts val="7"/>
               </a:spcAft>
               <a:buNone/>
-              <a:defRPr sz="2363" b="0">
-                <a:solidFill>
-                  <a:srgbClr val="111111"/>
-                </a:solidFill>
-                <a:latin typeface="Arial"/>
-                <a:ea typeface="Arial"/>
-                <a:cs typeface="Arial"/>
-              </a:defRPr>
-            </a:pPr>
-            <a:r>
-              <a:rPr sz="2363" b="0">
-                <a:solidFill>
-                  <a:srgbClr val="111111"/>
-                </a:solidFill>
-                <a:latin typeface="Arial"/>
-                <a:ea typeface="Arial"/>
-                <a:cs typeface="Arial"/>
-              </a:rPr>
-              <a:t>H1 · аддитивный target (γ = 0): </a:t>
-            </a:r>
-            <a:r>
-              <a:rPr sz="2363" b="0">
-                <a:solidFill>
-                  <a:srgbClr val="111111"/>
-                </a:solidFill>
-                <a:latin typeface="Arial"/>
-                <a:ea typeface="Arial"/>
-                <a:cs typeface="Arial"/>
-              </a:rPr>
-              <a:t>при rank ≥ 4 методы должны совпасть.</a:t>
+              <a:defRPr sz="2025" b="0">
+                <a:solidFill>
+                  <a:srgbClr val="101820"/>
+                </a:solidFill>
+                <a:latin typeface="Arial"/>
+                <a:ea typeface="Arial"/>
+                <a:cs typeface="Arial"/>
+              </a:defRPr>
+            </a:pPr>
+            <a:r>
+              <a:rPr sz="2025" b="1">
+                <a:solidFill>
+                  <a:srgbClr val="101820"/>
+                </a:solidFill>
+                <a:latin typeface="Arial"/>
+                <a:ea typeface="Arial"/>
+                <a:cs typeface="Arial"/>
+              </a:rPr>
+              <a:t>Pilot only</a:t>
+            </a:r>
+            <a:r>
+              <a:rPr sz="2025" b="0">
+                <a:solidFill>
+                  <a:srgbClr val="101820"/>
+                </a:solidFill>
+                <a:latin typeface="Arial"/>
+                <a:ea typeface="Arial"/>
+                <a:cs typeface="Arial"/>
+              </a:rPr>
+              <a:t> (validation): learning rate, early stopping, and rank allocation.</a:t>
             </a:r>
           </a:p>
           <a:p xmlns:a="http://schemas.openxmlformats.org/drawingml/2006/main">
             <a:pPr marL="24" indent="-14" algn="l">
               <a:lnSpc>
-                <a:spcPct val="99000"/>
+                <a:spcPct val="106000"/>
               </a:lnSpc>
               <a:spcAft>
                 <a:spcPts val="7"/>
               </a:spcAft>
               <a:buNone/>
-              <a:defRPr sz="2363" b="0">
-                <a:solidFill>
-                  <a:srgbClr val="111111"/>
-                </a:solidFill>
-                <a:latin typeface="Arial"/>
-                <a:ea typeface="Arial"/>
-                <a:cs typeface="Arial"/>
-              </a:defRPr>
-            </a:pPr>
-            <a:r>
-              <a:rPr sz="2363" b="0">
-                <a:solidFill>
-                  <a:srgbClr val="111111"/>
-                </a:solidFill>
-                <a:latin typeface="Arial"/>
-                <a:ea typeface="Arial"/>
-                <a:cs typeface="Arial"/>
-              </a:rPr>
-              <a:t>H2 · неоднородный row scaling (γ &gt; 0): </a:t>
-            </a:r>
-            <a:r>
-              <a:rPr sz="2363" b="0">
-                <a:solidFill>
-                  <a:srgbClr val="111111"/>
-                </a:solidFill>
-                <a:latin typeface="Arial"/>
-                <a:ea typeface="Arial"/>
-                <a:cs typeface="Arial"/>
-              </a:rPr>
-              <a:t>разрыв ёмкости LoRA растёт; DoRA сохраняет точность.</a:t>
+              <a:defRPr sz="2025" b="0">
+                <a:solidFill>
+                  <a:srgbClr val="101820"/>
+                </a:solidFill>
+                <a:latin typeface="Arial"/>
+                <a:ea typeface="Arial"/>
+                <a:cs typeface="Arial"/>
+              </a:defRPr>
+            </a:pPr>
+            <a:r>
+              <a:rPr sz="2025" b="1">
+                <a:solidFill>
+                  <a:srgbClr val="101820"/>
+                </a:solidFill>
+                <a:latin typeface="Arial"/>
+                <a:ea typeface="Arial"/>
+                <a:cs typeface="Arial"/>
+              </a:rPr>
+              <a:t>Confirmatory:</a:t>
+            </a:r>
+            <a:r>
+              <a:rPr sz="2025" b="0">
+                <a:solidFill>
+                  <a:srgbClr val="101820"/>
+                </a:solidFill>
+                <a:latin typeface="Arial"/>
+                <a:ea typeface="Arial"/>
+                <a:cs typeface="Arial"/>
+              </a:rPr>
+              <a:t> 20 paired MLP seeds + 10 paired CNN seeds; 3 shifts; 9 pre-declared primary comparisons with Holm correction.</a:t>
             </a:r>
           </a:p>
           <a:p xmlns:a="http://schemas.openxmlformats.org/drawingml/2006/main">
             <a:pPr marL="24" indent="-14" algn="l">
               <a:lnSpc>
-                <a:spcPct val="99000"/>
+                <a:spcPct val="106000"/>
               </a:lnSpc>
               <a:spcAft>
                 <a:spcPts val="7"/>
               </a:spcAft>
               <a:buNone/>
-              <a:defRPr sz="2363" b="0">
-                <a:solidFill>
-                  <a:srgbClr val="111111"/>
-                </a:solidFill>
-                <a:latin typeface="Arial"/>
-                <a:ea typeface="Arial"/>
-                <a:cs typeface="Arial"/>
-              </a:defRPr>
-            </a:pPr>
-            <a:r>
-              <a:rPr sz="2363" b="0">
-                <a:solidFill>
-                  <a:srgbClr val="111111"/>
-                </a:solidFill>
-                <a:latin typeface="Arial"/>
-                <a:ea typeface="Arial"/>
-                <a:cs typeface="Arial"/>
-              </a:rPr>
-              <a:t>H3 · реальные shifts: </a:t>
-            </a:r>
-            <a:r>
-              <a:rPr sz="2363" b="0">
-                <a:solidFill>
-                  <a:srgbClr val="111111"/>
-                </a:solidFill>
-                <a:latin typeface="Arial"/>
-                <a:ea typeface="Arial"/>
-                <a:cs typeface="Arial"/>
-              </a:rPr>
-              <a:t>выигрыш будет умеренным и зависимым от геометрии сдвига.</a:t>
+              <a:defRPr sz="2025" b="0">
+                <a:solidFill>
+                  <a:srgbClr val="101820"/>
+                </a:solidFill>
+                <a:latin typeface="Arial"/>
+                <a:ea typeface="Arial"/>
+                <a:cs typeface="Arial"/>
+              </a:defRPr>
+            </a:pPr>
+            <a:r>
+              <a:rPr sz="2025" b="1">
+                <a:solidFill>
+                  <a:srgbClr val="101820"/>
+                </a:solidFill>
+                <a:latin typeface="Arial"/>
+                <a:ea typeface="Arial"/>
+                <a:cs typeface="Arial"/>
+              </a:rPr>
+              <a:t>Baselines:</a:t>
+            </a:r>
+            <a:r>
+              <a:rPr sz="2025" b="0">
+                <a:solidFill>
+                  <a:srgbClr val="101820"/>
+                </a:solidFill>
+                <a:latin typeface="Arial"/>
+                <a:ea typeface="Arial"/>
+                <a:cs typeface="Arial"/>
+              </a:rPr>
+              <a:t> frozen, magnitude-only, LoRA, LoRA+, matched-budget LoRA, budgeted DoRA, and full fine-tuning.</a:t>
             </a:r>
           </a:p>
           <a:p xmlns:a="http://schemas.openxmlformats.org/drawingml/2006/main">
             <a:pPr algn="l">
               <a:lnSpc>
-                <a:spcPct val="99000"/>
+                <a:spcPct val="106000"/>
               </a:lnSpc>
               <a:spcAft>
                 <a:spcPts val="0"/>
               </a:spcAft>
               <a:buNone/>
-              <a:defRPr sz="2363" b="0">
-                <a:solidFill>
-                  <a:srgbClr val="111111"/>
-                </a:solidFill>
-                <a:latin typeface="Arial"/>
-                <a:ea typeface="Arial"/>
-                <a:cs typeface="Arial"/>
-              </a:defRPr>
-            </a:pPr>
-            <a:r>
-              <a:rPr sz="2363" b="0">
-                <a:solidFill>
-                  <a:srgbClr val="111111"/>
-                </a:solidFill>
-                <a:latin typeface="Arial"/>
-                <a:ea typeface="Arial"/>
-                <a:cs typeface="Arial"/>
-              </a:rPr>
-              <a:t>Метрики: </a:t>
-            </a:r>
-            <a:r>
-              <a:rPr sz="2363" b="0">
-                <a:solidFill>
-                  <a:srgbClr val="111111"/>
-                </a:solidFill>
-                <a:latin typeface="Arial"/>
-                <a:ea typeface="Arial"/>
-                <a:cs typeface="Arial"/>
-              </a:rPr>
-              <a:t>relative Frobenius error; test accuracy; paired DoRA−LoRA с 95% t-CI; число trainable parameters.</a:t>
+              <a:defRPr sz="2025" b="0">
+                <a:solidFill>
+                  <a:srgbClr val="101820"/>
+                </a:solidFill>
+                <a:latin typeface="Arial"/>
+                <a:ea typeface="Arial"/>
+                <a:cs typeface="Arial"/>
+              </a:defRPr>
+            </a:pPr>
+            <a:r>
+              <a:rPr sz="2025" b="1">
+                <a:solidFill>
+                  <a:srgbClr val="101820"/>
+                </a:solidFill>
+                <a:latin typeface="Arial"/>
+                <a:ea typeface="Arial"/>
+                <a:cs typeface="Arial"/>
+              </a:rPr>
+              <a:t>Robustness:</a:t>
+            </a:r>
+            <a:r>
+              <a:rPr sz="2025" b="0">
+                <a:solidFill>
+                  <a:srgbClr val="101820"/>
+                </a:solidFill>
+                <a:latin typeface="Arial"/>
+                <a:ea typeface="Arial"/>
+                <a:cs typeface="Arial"/>
+              </a:rPr>
+              <a:t> 4 nested data regimes; 10 synthetic targets × 5 initializations.</a:t>
+            </a:r>
+          </a:p>
+          <a:p xmlns:a="http://schemas.openxmlformats.org/drawingml/2006/main">
+            <a:pPr algn="l">
+              <a:lnSpc>
+                <a:spcPct val="106000"/>
+              </a:lnSpc>
+              <a:spcAft>
+                <a:spcPts val="0"/>
+              </a:spcAft>
+              <a:buNone/>
+              <a:defRPr sz="2025" b="0">
+                <a:solidFill>
+                  <a:srgbClr val="101820"/>
+                </a:solidFill>
+                <a:latin typeface="Arial"/>
+                <a:ea typeface="Arial"/>
+                <a:cs typeface="Arial"/>
+              </a:defRPr>
+            </a:pPr>
+            <a:r>
+              <a:rPr sz="2025" b="1">
+                <a:solidFill>
+                  <a:srgbClr val="101820"/>
+                </a:solidFill>
+                <a:latin typeface="Arial"/>
+                <a:ea typeface="Arial"/>
+                <a:cs typeface="Arial"/>
+              </a:rPr>
+              <a:t>1,960</a:t>
+            </a:r>
+            <a:r>
+              <a:rPr sz="2025" b="0">
+                <a:solidFill>
+                  <a:srgbClr val="101820"/>
+                </a:solidFill>
+                <a:latin typeface="Arial"/>
+                <a:ea typeface="Arial"/>
+                <a:cs typeface="Arial"/>
+              </a:rPr>
+              <a:t> saved result rows; 1,840 independent training / optimization jobs.</a:t>
             </a:r>
           </a:p>
         </p:txBody>
@@ -2586,16 +2594,16 @@
         </p:nvSpPr>
         <p:spPr>
           <a:xfrm xmlns:a="http://schemas.openxmlformats.org/drawingml/2006/main">
-            <a:off x="1511812" y="22938553"/>
-            <a:ext cx="8328874" cy="738664"/>
+            <a:off x="1511808" y="22764750"/>
+            <a:ext cx="8328851" cy="590550"/>
           </a:xfrm>
           <a:prstGeom xmlns:a="http://schemas.openxmlformats.org/drawingml/2006/main" prst="rect">
             <a:avLst/>
           </a:prstGeom>
         </p:spPr>
         <p:txBody>
-          <a:bodyPr xmlns:a="http://schemas.openxmlformats.org/drawingml/2006/main" vert="horz" wrap="square" lIns="0" tIns="0" rIns="0" bIns="0" anchor="ctr">
-            <a:normAutofit fontScale="100000"/>
+          <a:bodyPr xmlns:a="http://schemas.openxmlformats.org/drawingml/2006/main" vert="horz" wrap="square" lIns="0" tIns="0" rIns="0" bIns="0" anchor="t">
+            <a:noAutofit/>
           </a:bodyPr>
           <a:lstStyle xmlns:a="http://schemas.openxmlformats.org/drawingml/2006/main">
             <a:lvl1pPr algn="ctr">
@@ -2619,25 +2627,25 @@
                 <a:spcPct val="94000"/>
               </a:lnSpc>
               <a:buNone/>
-              <a:defRPr sz="4800" b="0">
-                <a:solidFill>
-                  <a:srgbClr val="111111"/>
-                </a:solidFill>
-                <a:latin typeface="Arial"/>
-                <a:ea typeface="Arial"/>
-                <a:cs typeface="Arial"/>
-              </a:defRPr>
-            </a:pPr>
-            <a:r>
-              <a:rPr sz="4800" b="0">
-                <a:solidFill>
-                  <a:srgbClr val="111111"/>
-                </a:solidFill>
-                <a:latin typeface="Arial"/>
-                <a:ea typeface="Arial"/>
-                <a:cs typeface="Arial"/>
-              </a:rPr>
-              <a:t>Протокол</a:t>
+              <a:defRPr sz="3225" b="0">
+                <a:solidFill>
+                  <a:srgbClr val="101820"/>
+                </a:solidFill>
+                <a:latin typeface="Arial"/>
+                <a:ea typeface="Arial"/>
+                <a:cs typeface="Arial"/>
+              </a:defRPr>
+            </a:pPr>
+            <a:r>
+              <a:rPr sz="3225" b="0">
+                <a:solidFill>
+                  <a:srgbClr val="101820"/>
+                </a:solidFill>
+                <a:latin typeface="Arial"/>
+                <a:ea typeface="Arial"/>
+                <a:cs typeface="Arial"/>
+              </a:rPr>
+              <a:t>Negative controls prevent a victory-only story</a:t>
             </a:r>
           </a:p>
         </p:txBody>
@@ -2658,8 +2666,8 @@
         </p:nvSpPr>
         <p:spPr>
           <a:xfrm xmlns:a="http://schemas.openxmlformats.org/drawingml/2006/main">
-            <a:off x="1509767" y="23952775"/>
-            <a:ext cx="8328874" cy="35801427"/>
+            <a:off x="1509808" y="23574375"/>
+            <a:ext cx="8328851" cy="3829050"/>
           </a:xfrm>
           <a:prstGeom xmlns:a="http://schemas.openxmlformats.org/drawingml/2006/main" prst="rect">
             <a:avLst/>
@@ -2667,7 +2675,7 @@
         </p:spPr>
         <p:txBody>
           <a:bodyPr xmlns:a="http://schemas.openxmlformats.org/drawingml/2006/main" vert="horz" wrap="square" lIns="0" tIns="0" rIns="0" bIns="0" anchor="t">
-            <a:normAutofit fontScale="100000"/>
+            <a:noAutofit/>
           </a:bodyPr>
           <a:lstStyle xmlns:a="http://schemas.openxmlformats.org/drawingml/2006/main">
             <a:lvl1pPr algn="ctr">
@@ -2688,94 +2696,135 @@
           <a:p xmlns:a="http://schemas.openxmlformats.org/drawingml/2006/main">
             <a:pPr marL="24" indent="-14" algn="l">
               <a:lnSpc>
-                <a:spcPct val="98000"/>
+                <a:spcPct val="108000"/>
               </a:lnSpc>
               <a:spcAft>
                 <a:spcPts val="7"/>
               </a:spcAft>
               <a:buNone/>
-              <a:defRPr sz="2325" b="0">
-                <a:solidFill>
-                  <a:srgbClr val="111111"/>
-                </a:solidFill>
-                <a:latin typeface="Arial"/>
-                <a:ea typeface="Arial"/>
-                <a:cs typeface="Arial"/>
-              </a:defRPr>
-            </a:pPr>
-            <a:r>
-              <a:rPr sz="2325" b="0">
-                <a:solidFill>
-                  <a:srgbClr val="111111"/>
-                </a:solidFill>
-                <a:latin typeface="Arial"/>
-                <a:ea typeface="Arial"/>
-                <a:cs typeface="Arial"/>
-              </a:rPr>
-              <a:t>Capacity test: </a:t>
-            </a:r>
-            <a:r>
-              <a:rPr sz="2325" b="0">
-                <a:solidFill>
-                  <a:srgbClr val="111111"/>
-                </a:solidFill>
-                <a:latin typeface="Arial"/>
-                <a:ea typeface="Arial"/>
-                <a:cs typeface="Arial"/>
-              </a:rPr>
-              <a:t>W★ = diag(1 + γz)(W₀ + Δr=4); γ = 0…0.8, ranks 1/2/4/8, 10 seeds. LoRA - точный SVD oracle.</a:t>
+              <a:defRPr sz="2025" b="0">
+                <a:solidFill>
+                  <a:srgbClr val="101820"/>
+                </a:solidFill>
+                <a:latin typeface="Arial"/>
+                <a:ea typeface="Arial"/>
+                <a:cs typeface="Arial"/>
+              </a:defRPr>
+            </a:pPr>
+            <a:r>
+              <a:rPr sz="2025" b="1">
+                <a:solidFill>
+                  <a:srgbClr val="101820"/>
+                </a:solidFill>
+                <a:latin typeface="Arial"/>
+                <a:ea typeface="Arial"/>
+                <a:cs typeface="Arial"/>
+              </a:rPr>
+              <a:t>Contrast (MLP):</a:t>
+            </a:r>
+            <a:r>
+              <a:rPr sz="2025" b="0">
+                <a:solidFill>
+                  <a:srgbClr val="101820"/>
+                </a:solidFill>
+                <a:latin typeface="Arial"/>
+                <a:ea typeface="Arial"/>
+                <a:cs typeface="Arial"/>
+              </a:rPr>
+              <a:t> magnitude-only 96.90% &gt; DoRA 95.18%.</a:t>
             </a:r>
           </a:p>
           <a:p xmlns:a="http://schemas.openxmlformats.org/drawingml/2006/main">
             <a:pPr marL="24" indent="-14" algn="l">
               <a:lnSpc>
-                <a:spcPct val="98000"/>
+                <a:spcPct val="108000"/>
               </a:lnSpc>
               <a:spcAft>
                 <a:spcPts val="7"/>
               </a:spcAft>
               <a:buNone/>
-              <a:defRPr sz="2325" b="0">
-                <a:solidFill>
-                  <a:srgbClr val="111111"/>
-                </a:solidFill>
-                <a:latin typeface="Arial"/>
-                <a:ea typeface="Arial"/>
-                <a:cs typeface="Arial"/>
-              </a:defRPr>
-            </a:pPr>
-            <a:r>
-              <a:rPr sz="2325" b="0">
-                <a:solidFill>
-                  <a:srgbClr val="111111"/>
-                </a:solidFill>
-                <a:latin typeface="Arial"/>
-                <a:ea typeface="Arial"/>
-                <a:cs typeface="Arial"/>
-              </a:rPr>
-              <a:t>Real-data test: </a:t>
-            </a:r>
-            <a:r>
-              <a:rPr sz="2325" b="0">
-                <a:solidFill>
-                  <a:srgbClr val="111111"/>
-                </a:solidFill>
-                <a:latin typeface="Arial"/>
-                <a:ea typeface="Arial"/>
-                <a:cs typeface="Arial"/>
-              </a:rPr>
-              <a:t>Digits; MLP 64→128→64→10; 400 адаптационных примеров; contrast, rotation и mixed; 5 paired seeds.</a:t>
+              <a:defRPr sz="2025" b="0">
+                <a:solidFill>
+                  <a:srgbClr val="101820"/>
+                </a:solidFill>
+                <a:latin typeface="Arial"/>
+                <a:ea typeface="Arial"/>
+                <a:cs typeface="Arial"/>
+              </a:defRPr>
+            </a:pPr>
+            <a:r>
+              <a:rPr sz="2025" b="1">
+                <a:solidFill>
+                  <a:srgbClr val="101820"/>
+                </a:solidFill>
+                <a:latin typeface="Arial"/>
+                <a:ea typeface="Arial"/>
+                <a:cs typeface="Arial"/>
+              </a:rPr>
+              <a:t>Rotation (MLP):</a:t>
+            </a:r>
+            <a:r>
+              <a:rPr sz="2025" b="0">
+                <a:solidFill>
+                  <a:srgbClr val="101820"/>
+                </a:solidFill>
+                <a:latin typeface="Arial"/>
+                <a:ea typeface="Arial"/>
+                <a:cs typeface="Arial"/>
+              </a:rPr>
+              <a:t> matched-budget LoRA = DoRA = 93.89%.</a:t>
             </a:r>
           </a:p>
           <a:p xmlns:a="http://schemas.openxmlformats.org/drawingml/2006/main">
             <a:pPr marL="24" indent="-14" algn="l">
               <a:lnSpc>
-                <a:spcPct val="98000"/>
+                <a:spcPct val="108000"/>
               </a:lnSpc>
               <a:spcAft>
                 <a:spcPts val="7"/>
               </a:spcAft>
               <a:buNone/>
+              <a:defRPr sz="2025" b="0">
+                <a:solidFill>
+                  <a:srgbClr val="101820"/>
+                </a:solidFill>
+                <a:latin typeface="Arial"/>
+                <a:ea typeface="Arial"/>
+                <a:cs typeface="Arial"/>
+              </a:defRPr>
+            </a:pPr>
+            <a:r>
+              <a:rPr sz="2025" b="1">
+                <a:solidFill>
+                  <a:srgbClr val="101820"/>
+                </a:solidFill>
+                <a:latin typeface="Arial"/>
+                <a:ea typeface="Arial"/>
+                <a:cs typeface="Arial"/>
+              </a:rPr>
+              <a:t>Mixed (MLP):</a:t>
+            </a:r>
+            <a:r>
+              <a:rPr sz="2025" b="0">
+                <a:solidFill>
+                  <a:srgbClr val="101820"/>
+                </a:solidFill>
+                <a:latin typeface="Arial"/>
+                <a:ea typeface="Arial"/>
+                <a:cs typeface="Arial"/>
+              </a:rPr>
+              <a:t> matching the parameter budget reduces the DoRA gap to +0.53 pp; its CI crosses zero.</a:t>
+            </a:r>
+          </a:p>
+          <a:p xmlns:a="http://schemas.openxmlformats.org/drawingml/2006/main">
+            <a:pPr marL="24" indent="-14" algn="l">
+              <a:lnSpc>
+                <a:spcPct val="98000"/>
+              </a:lnSpc>
+              <a:spcAft>
+                <a:spcPts val="7"/>
+              </a:spcAft>
+              <a:buNone/>
               <a:defRPr sz="2325" b="0">
                 <a:solidFill>
                   <a:srgbClr val="111111"/>
@@ -2794,18 +2843,48 @@
                 <a:ea typeface="Arial"/>
                 <a:cs typeface="Arial"/>
               </a:rPr>
-              <a:t>Без утечки: </a:t>
-            </a:r>
-            <a:r>
-              <a:rPr sz="2325" b="0">
-                <a:solidFill>
-                  <a:srgbClr val="111111"/>
-                </a:solidFill>
-                <a:latin typeface="Arial"/>
-                <a:ea typeface="Arial"/>
-                <a:cs typeface="Arial"/>
-              </a:rPr>
-              <a:t>LR и early stopping выбирались по validation; test применён один раз. Контроли: frozen, magnitude-only, full FT.</a:t>
+              <a:t/>
+            </a:r>
+          </a:p>
+          <a:p xmlns:a="http://schemas.openxmlformats.org/drawingml/2006/main">
+            <a:pPr marL="24" indent="-14" algn="l">
+              <a:lnSpc>
+                <a:spcPct val="108000"/>
+              </a:lnSpc>
+              <a:spcAft>
+                <a:spcPts val="7"/>
+              </a:spcAft>
+              <a:buNone/>
+              <a:defRPr sz="2025" b="0">
+                <a:solidFill>
+                  <a:srgbClr val="101820"/>
+                </a:solidFill>
+                <a:latin typeface="Arial"/>
+                <a:ea typeface="Arial"/>
+                <a:cs typeface="Arial"/>
+              </a:defRPr>
+            </a:pPr>
+            <a:r>
+              <a:rPr sz="2025" b="1">
+                <a:solidFill>
+                  <a:srgbClr val="101820"/>
+                </a:solidFill>
+                <a:latin typeface="Arial"/>
+                <a:ea typeface="Arial"/>
+                <a:cs typeface="Arial"/>
+              </a:rPr>
+              <a:t>Scope:</a:t>
+            </a:r>
+            <a:r>
+              <a:rPr sz="2025" b="0">
+                <a:solidFill>
+                  <a:srgbClr val="101820"/>
+                </a:solidFill>
+                <a:latin typeface="Arial"/>
+                <a:ea typeface="Arial"/>
+                <a:cs typeface="Arial"/>
+              </a:rPr>
+              <a:t> Digits, one fixed pretrained base per architecture, and one target split already seen during exploratory work. This is a controlled mechanism study, not an LLM-scale benchmark.</a:t>
             </a:r>
           </a:p>
         </p:txBody>
@@ -2826,16 +2905,16 @@
         </p:nvSpPr>
         <p:spPr>
           <a:xfrm xmlns:a="http://schemas.openxmlformats.org/drawingml/2006/main">
-            <a:off x="11542427" y="21671044"/>
-            <a:ext cx="8328874" cy="738664"/>
+            <a:off x="11542395" y="23241000"/>
+            <a:ext cx="8328851" cy="552450"/>
           </a:xfrm>
           <a:prstGeom xmlns:a="http://schemas.openxmlformats.org/drawingml/2006/main" prst="rect">
             <a:avLst/>
           </a:prstGeom>
         </p:spPr>
         <p:txBody>
-          <a:bodyPr xmlns:a="http://schemas.openxmlformats.org/drawingml/2006/main" vert="horz" wrap="square" lIns="0" tIns="0" rIns="0" bIns="0" anchor="ctr">
-            <a:normAutofit fontScale="100000"/>
+          <a:bodyPr xmlns:a="http://schemas.openxmlformats.org/drawingml/2006/main" vert="horz" wrap="square" lIns="0" tIns="0" rIns="0" bIns="0" anchor="t">
+            <a:noAutofit/>
           </a:bodyPr>
           <a:lstStyle xmlns:a="http://schemas.openxmlformats.org/drawingml/2006/main">
             <a:lvl1pPr algn="ctr">
@@ -2859,25 +2938,25 @@
                 <a:spcPct val="94000"/>
               </a:lnSpc>
               <a:buNone/>
-              <a:defRPr sz="4800" b="0">
-                <a:solidFill>
-                  <a:srgbClr val="111111"/>
-                </a:solidFill>
-                <a:latin typeface="Arial"/>
-                <a:ea typeface="Arial"/>
-                <a:cs typeface="Arial"/>
-              </a:defRPr>
-            </a:pPr>
-            <a:r>
-              <a:rPr sz="4800" b="0">
-                <a:solidFill>
-                  <a:srgbClr val="111111"/>
-                </a:solidFill>
-                <a:latin typeface="Arial"/>
-                <a:ea typeface="Arial"/>
-                <a:cs typeface="Arial"/>
-              </a:rPr>
-              <a:t>Практический вывод</a:t>
+              <a:defRPr sz="3225" b="0">
+                <a:solidFill>
+                  <a:srgbClr val="101820"/>
+                </a:solidFill>
+                <a:latin typeface="Arial"/>
+                <a:ea typeface="Arial"/>
+                <a:cs typeface="Arial"/>
+              </a:defRPr>
+            </a:pPr>
+            <a:r>
+              <a:rPr sz="3225" b="0">
+                <a:solidFill>
+                  <a:srgbClr val="101820"/>
+                </a:solidFill>
+                <a:latin typeface="Arial"/>
+                <a:ea typeface="Arial"/>
+                <a:cs typeface="Arial"/>
+              </a:rPr>
+              <a:t>What survived the controls</a:t>
             </a:r>
           </a:p>
         </p:txBody>
@@ -2898,8 +2977,8 @@
         </p:nvSpPr>
         <p:spPr>
           <a:xfrm xmlns:a="http://schemas.openxmlformats.org/drawingml/2006/main">
-            <a:off x="11540382" y="22767227"/>
-            <a:ext cx="8328874" cy="53085365"/>
+            <a:off x="11540395" y="23955375"/>
+            <a:ext cx="8328851" cy="3495675"/>
           </a:xfrm>
           <a:prstGeom xmlns:a="http://schemas.openxmlformats.org/drawingml/2006/main" prst="rect">
             <a:avLst/>
@@ -2907,7 +2986,7 @@
         </p:spPr>
         <p:txBody>
           <a:bodyPr xmlns:a="http://schemas.openxmlformats.org/drawingml/2006/main" vert="horz" wrap="square" lIns="0" tIns="0" rIns="0" bIns="0" anchor="t">
-            <a:normAutofit fontScale="100000"/>
+            <a:noAutofit/>
           </a:bodyPr>
           <a:lstStyle xmlns:a="http://schemas.openxmlformats.org/drawingml/2006/main">
             <a:lvl1pPr algn="ctr">
@@ -2928,247 +3007,209 @@
           <a:p xmlns:a="http://schemas.openxmlformats.org/drawingml/2006/main">
             <a:pPr marL="24" indent="-14" algn="l">
               <a:lnSpc>
-                <a:spcPct val="96000"/>
+                <a:spcPct val="104000"/>
               </a:lnSpc>
               <a:spcAft>
                 <a:spcPts val="7"/>
               </a:spcAft>
               <a:buNone/>
-              <a:defRPr sz="2228" b="0">
-                <a:solidFill>
-                  <a:srgbClr val="111111"/>
-                </a:solidFill>
-                <a:latin typeface="Arial"/>
-                <a:ea typeface="Arial"/>
-                <a:cs typeface="Arial"/>
-              </a:defRPr>
-            </a:pPr>
-            <a:r>
-              <a:rPr sz="2228" b="0">
-                <a:solidFill>
-                  <a:srgbClr val="111111"/>
-                </a:solidFill>
-                <a:latin typeface="Arial"/>
-                <a:ea typeface="Arial"/>
-                <a:cs typeface="Arial"/>
-              </a:rPr>
-              <a:t>Mixed, r=4: </a:t>
-            </a:r>
-            <a:r>
-              <a:rPr sz="2228" b="0">
-                <a:solidFill>
-                  <a:srgbClr val="111111"/>
-                </a:solidFill>
-                <a:latin typeface="Arial"/>
-                <a:ea typeface="Arial"/>
-                <a:cs typeface="Arial"/>
-              </a:rPr>
-              <a:t>Frozen 50.83 · m-only 65.89 · LoRA 73.33 · DoRA 74.72 · Full FT 73.33%.</a:t>
+              <a:defRPr sz="1875" b="0">
+                <a:solidFill>
+                  <a:srgbClr val="101820"/>
+                </a:solidFill>
+                <a:latin typeface="Arial"/>
+                <a:ea typeface="Arial"/>
+                <a:cs typeface="Arial"/>
+              </a:defRPr>
+            </a:pPr>
+            <a:r>
+              <a:rPr sz="1875" b="0">
+                <a:solidFill>
+                  <a:srgbClr val="101820"/>
+                </a:solidFill>
+                <a:latin typeface="Arial"/>
+                <a:ea typeface="Arial"/>
+                <a:cs typeface="Arial"/>
+              </a:rPr>
+              <a:t>- </a:t>
+            </a:r>
+            <a:r>
+              <a:rPr sz="1875" b="1">
+                <a:solidFill>
+                  <a:srgbClr val="101820"/>
+                </a:solidFill>
+                <a:latin typeface="Arial"/>
+                <a:ea typeface="Arial"/>
+                <a:cs typeface="Arial"/>
+              </a:rPr>
+              <a:t>Mixed-shift DoRA</a:t>
+            </a:r>
+            <a:r>
+              <a:rPr sz="1875" b="0">
+                <a:solidFill>
+                  <a:srgbClr val="101820"/>
+                </a:solidFill>
+                <a:latin typeface="Arial"/>
+                <a:ea typeface="Arial"/>
+                <a:cs typeface="Arial"/>
+              </a:rPr>
+              <a:t> reaches 75.22% on MLP and 80.53% on CNN - near full FT (75.17%, 80.67%) with only ~12-15% as many trainable parameters.</a:t>
             </a:r>
           </a:p>
           <a:p xmlns:a="http://schemas.openxmlformats.org/drawingml/2006/main">
             <a:pPr marL="24" indent="-14" algn="l">
               <a:lnSpc>
-                <a:spcPct val="96000"/>
+                <a:spcPct val="104000"/>
               </a:lnSpc>
               <a:spcAft>
                 <a:spcPts val="7"/>
               </a:spcAft>
               <a:buNone/>
-              <a:defRPr sz="2228" b="0">
-                <a:solidFill>
-                  <a:srgbClr val="111111"/>
-                </a:solidFill>
-                <a:latin typeface="Arial"/>
-                <a:ea typeface="Arial"/>
-                <a:cs typeface="Arial"/>
-              </a:defRPr>
-            </a:pPr>
-            <a:r>
-              <a:rPr sz="2228" b="0">
-                <a:solidFill>
-                  <a:srgbClr val="111111"/>
-                </a:solidFill>
-                <a:latin typeface="Arial"/>
-                <a:ea typeface="Arial"/>
-                <a:cs typeface="Arial"/>
-              </a:rPr>
-              <a:t>Mixed, r=8: </a:t>
-            </a:r>
-            <a:r>
-              <a:rPr sz="2228" b="0">
-                <a:solidFill>
-                  <a:srgbClr val="111111"/>
-                </a:solidFill>
-                <a:latin typeface="Arial"/>
-                <a:ea typeface="Arial"/>
-                <a:cs typeface="Arial"/>
-              </a:rPr>
-              <a:t>DoRA 77.33% против LoRA 75.44%.</a:t>
+              <a:defRPr sz="1875" b="0">
+                <a:solidFill>
+                  <a:srgbClr val="101820"/>
+                </a:solidFill>
+                <a:latin typeface="Arial"/>
+                <a:ea typeface="Arial"/>
+                <a:cs typeface="Arial"/>
+              </a:defRPr>
+            </a:pPr>
+            <a:r>
+              <a:rPr sz="1875" b="0">
+                <a:solidFill>
+                  <a:srgbClr val="101820"/>
+                </a:solidFill>
+                <a:latin typeface="Arial"/>
+                <a:ea typeface="Arial"/>
+                <a:cs typeface="Arial"/>
+              </a:rPr>
+              <a:t>- </a:t>
+            </a:r>
+            <a:r>
+              <a:rPr sz="1875" b="1">
+                <a:solidFill>
+                  <a:srgbClr val="101820"/>
+                </a:solidFill>
+                <a:latin typeface="Arial"/>
+                <a:ea typeface="Arial"/>
+                <a:cs typeface="Arial"/>
+              </a:rPr>
+              <a:t>Matched-budget LoRA</a:t>
+            </a:r>
+            <a:r>
+              <a:rPr sz="1875" b="0">
+                <a:solidFill>
+                  <a:srgbClr val="101820"/>
+                </a:solidFill>
+                <a:latin typeface="Arial"/>
+                <a:ea typeface="Arial"/>
+                <a:cs typeface="Arial"/>
+              </a:rPr>
+              <a:t> narrows the MLP gap to +0.53 pp; budgeted DoRA still gains +0.82 pp over uniform LoRA.</a:t>
             </a:r>
           </a:p>
           <a:p xmlns:a="http://schemas.openxmlformats.org/drawingml/2006/main">
             <a:pPr marL="24" indent="-14" algn="l">
               <a:lnSpc>
-                <a:spcPct val="96000"/>
+                <a:spcPct val="104000"/>
               </a:lnSpc>
               <a:spcAft>
                 <a:spcPts val="7"/>
               </a:spcAft>
               <a:buNone/>
-              <a:defRPr sz="2228" b="0">
-                <a:solidFill>
-                  <a:srgbClr val="111111"/>
-                </a:solidFill>
-                <a:latin typeface="Arial"/>
-                <a:ea typeface="Arial"/>
-                <a:cs typeface="Arial"/>
-              </a:defRPr>
-            </a:pPr>
-            <a:r>
-              <a:rPr sz="2228" b="0">
-                <a:solidFill>
-                  <a:srgbClr val="111111"/>
-                </a:solidFill>
-                <a:latin typeface="Arial"/>
-                <a:ea typeface="Arial"/>
-                <a:cs typeface="Arial"/>
-              </a:rPr>
-              <a:t>Бюджет r=4: </a:t>
-            </a:r>
-            <a:r>
-              <a:rPr sz="2228" b="0">
-                <a:solidFill>
-                  <a:srgbClr val="111111"/>
-                </a:solidFill>
-                <a:latin typeface="Arial"/>
-                <a:ea typeface="Arial"/>
-                <a:cs typeface="Arial"/>
-              </a:rPr>
-              <a:t>DoRA 2,034; LoRA 1,832 (+11%); full FT 17,226 trainable parameters.</a:t>
+              <a:defRPr sz="1875" b="0">
+                <a:solidFill>
+                  <a:srgbClr val="101820"/>
+                </a:solidFill>
+                <a:latin typeface="Arial"/>
+                <a:ea typeface="Arial"/>
+                <a:cs typeface="Arial"/>
+              </a:defRPr>
+            </a:pPr>
+            <a:r>
+              <a:rPr sz="1875" b="0">
+                <a:solidFill>
+                  <a:srgbClr val="101820"/>
+                </a:solidFill>
+                <a:latin typeface="Arial"/>
+                <a:ea typeface="Arial"/>
+                <a:cs typeface="Arial"/>
+              </a:rPr>
+              <a:t>- </a:t>
+            </a:r>
+            <a:r>
+              <a:rPr sz="1875" b="1">
+                <a:solidFill>
+                  <a:srgbClr val="101820"/>
+                </a:solidFill>
+                <a:latin typeface="Arial"/>
+                <a:ea typeface="Arial"/>
+                <a:cs typeface="Arial"/>
+              </a:rPr>
+              <a:t>At γ=.8</a:t>
+            </a:r>
+            <a:r>
+              <a:rPr sz="1875" b="0">
+                <a:solidFill>
+                  <a:srgbClr val="101820"/>
+                </a:solidFill>
+                <a:latin typeface="Arial"/>
+                <a:ea typeface="Arial"/>
+                <a:cs typeface="Arial"/>
+              </a:rPr>
+              <a:t>, DoRA is representationally exact; training converges below 10⁻³ in 44/50 runs. LoRA's best possible mean error is 0.289.</a:t>
             </a:r>
           </a:p>
           <a:p xmlns:a="http://schemas.openxmlformats.org/drawingml/2006/main">
             <a:pPr marL="24" indent="-14" algn="l">
               <a:lnSpc>
-                <a:spcPct val="96000"/>
+                <a:spcPct val="104000"/>
               </a:lnSpc>
               <a:spcAft>
                 <a:spcPts val="7"/>
               </a:spcAft>
               <a:buNone/>
-              <a:defRPr sz="2228" b="0">
-                <a:solidFill>
-                  <a:srgbClr val="111111"/>
-                </a:solidFill>
-                <a:latin typeface="Arial"/>
-                <a:ea typeface="Arial"/>
-                <a:cs typeface="Arial"/>
-              </a:defRPr>
-            </a:pPr>
-            <a:r>
-              <a:rPr sz="2228" b="0">
-                <a:solidFill>
-                  <a:srgbClr val="111111"/>
-                </a:solidFill>
-                <a:latin typeface="Arial"/>
-                <a:ea typeface="Arial"/>
-                <a:cs typeface="Arial"/>
-              </a:rPr>
-              <a:t>Validation-selected mixed: </a:t>
-            </a:r>
-            <a:r>
-              <a:rPr sz="2228" b="0">
-                <a:solidFill>
-                  <a:srgbClr val="111111"/>
-                </a:solidFill>
-                <a:latin typeface="Arial"/>
-                <a:ea typeface="Arial"/>
-                <a:cs typeface="Arial"/>
-              </a:rPr>
-              <a:t>DoRA 76.72 · LoRA 75.28 · full FT 73.33%.</a:t>
-            </a:r>
-          </a:p>
-          <a:p xmlns:a="http://schemas.openxmlformats.org/drawingml/2006/main">
-            <a:pPr algn="l">
-              <a:lnSpc>
-                <a:spcPct val="96000"/>
-              </a:lnSpc>
-              <a:spcAft>
-                <a:spcPts val="7"/>
-              </a:spcAft>
-              <a:buNone/>
-              <a:defRPr sz="2228" b="0">
-                <a:solidFill>
-                  <a:srgbClr val="111111"/>
-                </a:solidFill>
-                <a:latin typeface="Arial"/>
-                <a:ea typeface="Arial"/>
-                <a:cs typeface="Arial"/>
-              </a:defRPr>
-            </a:pPr>
-            <a:r>
-              <a:rPr sz="2228" b="0">
-                <a:solidFill>
-                  <a:srgbClr val="111111"/>
-                </a:solidFill>
-                <a:latin typeface="Arial"/>
-                <a:ea typeface="Arial"/>
-                <a:cs typeface="Arial"/>
-              </a:rPr>
-              <a:t>Итог: </a:t>
-            </a:r>
-            <a:r>
-              <a:rPr sz="2228" b="0">
-                <a:solidFill>
-                  <a:srgbClr val="111111"/>
-                </a:solidFill>
-                <a:latin typeface="Arial"/>
-                <a:ea typeface="Arial"/>
-                <a:cs typeface="Arial"/>
-              </a:rPr>
-              <a:t>DoRA оправдана, когда ожидается drift норм строк и особенно важен малый rank. В остальных случаях LoRA остаётся сильным baseline.</a:t>
-            </a:r>
-          </a:p>
-          <a:p xmlns:a="http://schemas.openxmlformats.org/drawingml/2006/main">
-            <a:pPr algn="l">
-              <a:lnSpc>
-                <a:spcPct val="96000"/>
-              </a:lnSpc>
-              <a:spcAft>
-                <a:spcPts val="0"/>
-              </a:spcAft>
-              <a:buNone/>
-              <a:defRPr sz="2228" b="0">
-                <a:solidFill>
-                  <a:srgbClr val="111111"/>
-                </a:solidFill>
-                <a:latin typeface="Arial"/>
-                <a:ea typeface="Arial"/>
-                <a:cs typeface="Arial"/>
-              </a:defRPr>
-            </a:pPr>
-            <a:r>
-              <a:rPr sz="2228" b="0">
-                <a:solidFill>
-                  <a:srgbClr val="111111"/>
-                </a:solidFill>
-                <a:latin typeface="Arial"/>
-                <a:ea typeface="Arial"/>
-                <a:cs typeface="Arial"/>
-              </a:rPr>
-              <a:t>Ограничения: </a:t>
-            </a:r>
-            <a:r>
-              <a:rPr sz="2228" b="0">
-                <a:solidFill>
-                  <a:srgbClr val="111111"/>
-                </a:solidFill>
-                <a:latin typeface="Arial"/>
-                <a:ea typeface="Arial"/>
-                <a:cs typeface="Arial"/>
-              </a:rPr>
-              <a:t>малый MLP/dataset, 5 seeds; не измерены transformer-scale качество и throughput.</a:t>
+              <a:defRPr sz="1875" b="0">
+                <a:solidFill>
+                  <a:srgbClr val="101820"/>
+                </a:solidFill>
+                <a:latin typeface="Arial"/>
+                <a:ea typeface="Arial"/>
+                <a:cs typeface="Arial"/>
+              </a:defRPr>
+            </a:pPr>
+            <a:r>
+              <a:rPr sz="1875" b="0">
+                <a:solidFill>
+                  <a:srgbClr val="101820"/>
+                </a:solidFill>
+                <a:latin typeface="Arial"/>
+                <a:ea typeface="Arial"/>
+                <a:cs typeface="Arial"/>
+              </a:rPr>
+              <a:t>- </a:t>
+            </a:r>
+            <a:r>
+              <a:rPr sz="1875" b="1">
+                <a:solidFill>
+                  <a:srgbClr val="101820"/>
+                </a:solidFill>
+                <a:latin typeface="Arial"/>
+                <a:ea typeface="Arial"/>
+                <a:cs typeface="Arial"/>
+              </a:rPr>
+              <a:t>Decision rule:</a:t>
+            </a:r>
+            <a:r>
+              <a:rPr sz="1875" b="0">
+                <a:solidFill>
+                  <a:srgbClr val="101820"/>
+                </a:solidFill>
+                <a:latin typeface="Arial"/>
+                <a:ea typeface="Arial"/>
+                <a:cs typeface="Arial"/>
+              </a:rPr>
+              <a:t> test DoRA when heterogeneous row-norm drift is plausible; retain LoRA and magnitude-only baselines.</a:t>
             </a:r>
           </a:p>
         </p:txBody>
@@ -3189,16 +3230,16 @@
         </p:nvSpPr>
         <p:spPr>
           <a:xfrm xmlns:a="http://schemas.openxmlformats.org/drawingml/2006/main">
-            <a:off x="11542427" y="6653687"/>
-            <a:ext cx="8328874" cy="738664"/>
+            <a:off x="11542395" y="6572250"/>
+            <a:ext cx="8328851" cy="400050"/>
           </a:xfrm>
           <a:prstGeom xmlns:a="http://schemas.openxmlformats.org/drawingml/2006/main" prst="rect">
             <a:avLst/>
           </a:prstGeom>
         </p:spPr>
         <p:txBody>
-          <a:bodyPr xmlns:a="http://schemas.openxmlformats.org/drawingml/2006/main" vert="horz" wrap="square" lIns="0" tIns="0" rIns="0" bIns="0" anchor="ctr">
-            <a:normAutofit fontScale="100000"/>
+          <a:bodyPr xmlns:a="http://schemas.openxmlformats.org/drawingml/2006/main" vert="horz" wrap="square" lIns="0" tIns="0" rIns="0" bIns="0" anchor="t">
+            <a:noAutofit/>
           </a:bodyPr>
           <a:lstStyle xmlns:a="http://schemas.openxmlformats.org/drawingml/2006/main">
             <a:lvl1pPr algn="ctr">
@@ -3222,25 +3263,25 @@
                 <a:spcPct val="94000"/>
               </a:lnSpc>
               <a:buNone/>
-              <a:defRPr sz="4800" b="0">
-                <a:solidFill>
-                  <a:srgbClr val="111111"/>
-                </a:solidFill>
-                <a:latin typeface="Arial"/>
-                <a:ea typeface="Arial"/>
-                <a:cs typeface="Arial"/>
-              </a:defRPr>
-            </a:pPr>
-            <a:r>
-              <a:rPr sz="4800" b="0">
-                <a:solidFill>
-                  <a:srgbClr val="111111"/>
-                </a:solidFill>
-                <a:latin typeface="Arial"/>
-                <a:ea typeface="Arial"/>
-                <a:cs typeface="Arial"/>
-              </a:rPr>
-              <a:t>Два уровня проверки</a:t>
+              <a:defRPr sz="1725" b="1">
+                <a:solidFill>
+                  <a:srgbClr val="008A80"/>
+                </a:solidFill>
+                <a:latin typeface="Arial"/>
+                <a:ea typeface="Arial"/>
+                <a:cs typeface="Arial"/>
+              </a:defRPr>
+            </a:pPr>
+            <a:r>
+              <a:rPr sz="1725" b="1">
+                <a:solidFill>
+                  <a:srgbClr val="008A80"/>
+                </a:solidFill>
+                <a:latin typeface="Arial"/>
+                <a:ea typeface="Arial"/>
+                <a:cs typeface="Arial"/>
+              </a:rPr>
+              <a:t>CONFIRMATORY MIXED-SHIFT EFFECT</a:t>
             </a:r>
           </a:p>
         </p:txBody>
@@ -3261,8 +3302,8 @@
         </p:nvSpPr>
         <p:spPr>
           <a:xfrm xmlns:a="http://schemas.openxmlformats.org/drawingml/2006/main">
-            <a:off x="11542938" y="7624916"/>
-            <a:ext cx="8328874" cy="29629227"/>
+            <a:off x="11542966" y="22288500"/>
+            <a:ext cx="8328851" cy="781050"/>
           </a:xfrm>
           <a:prstGeom xmlns:a="http://schemas.openxmlformats.org/drawingml/2006/main" prst="rect">
             <a:avLst/>
@@ -3270,7 +3311,7 @@
         </p:spPr>
         <p:txBody>
           <a:bodyPr xmlns:a="http://schemas.openxmlformats.org/drawingml/2006/main" vert="horz" wrap="square" lIns="0" tIns="0" rIns="0" bIns="0" anchor="t">
-            <a:normAutofit fontScale="100000"/>
+            <a:noAutofit/>
           </a:bodyPr>
           <a:lstStyle xmlns:a="http://schemas.openxmlformats.org/drawingml/2006/main">
             <a:lvl1pPr algn="ctr">
@@ -3291,124 +3332,31 @@
           <a:p xmlns:a="http://schemas.openxmlformats.org/drawingml/2006/main">
             <a:pPr marL="24" indent="-14" algn="l">
               <a:lnSpc>
-                <a:spcPct val="99000"/>
+                <a:spcPct val="105000"/>
               </a:lnSpc>
               <a:spcAft>
                 <a:spcPts val="7"/>
               </a:spcAft>
               <a:buNone/>
-              <a:defRPr sz="2363" b="0">
-                <a:solidFill>
-                  <a:srgbClr val="111111"/>
-                </a:solidFill>
-                <a:latin typeface="Arial"/>
-                <a:ea typeface="Arial"/>
-                <a:cs typeface="Arial"/>
-              </a:defRPr>
-            </a:pPr>
-            <a:r>
-              <a:rPr sz="2363" b="0">
-                <a:solidFill>
-                  <a:srgbClr val="111111"/>
-                </a:solidFill>
-                <a:latin typeface="Arial"/>
-                <a:ea typeface="Arial"/>
-                <a:cs typeface="Arial"/>
-              </a:rPr>
-              <a:t>Ёмкость: </a:t>
-            </a:r>
-            <a:r>
-              <a:rPr sz="2363" b="0">
-                <a:solidFill>
-                  <a:srgbClr val="111111"/>
-                </a:solidFill>
-                <a:latin typeface="Arial"/>
-                <a:ea typeface="Arial"/>
-                <a:cs typeface="Arial"/>
-              </a:rPr>
-              <a:t>может ли параметризация выразить целевую матрицу без влияния оптимизатора?</a:t>
-            </a:r>
-          </a:p>
-          <a:p xmlns:a="http://schemas.openxmlformats.org/drawingml/2006/main">
-            <a:pPr marL="24" indent="-14" algn="l">
-              <a:lnSpc>
-                <a:spcPct val="99000"/>
-              </a:lnSpc>
-              <a:spcAft>
-                <a:spcPts val="7"/>
-              </a:spcAft>
-              <a:buNone/>
-              <a:defRPr sz="2363" b="0">
-                <a:solidFill>
-                  <a:srgbClr val="111111"/>
-                </a:solidFill>
-                <a:latin typeface="Arial"/>
-                <a:ea typeface="Arial"/>
-                <a:cs typeface="Arial"/>
-              </a:defRPr>
-            </a:pPr>
-            <a:r>
-              <a:rPr sz="2363" b="0">
-                <a:solidFill>
-                  <a:srgbClr val="111111"/>
-                </a:solidFill>
-                <a:latin typeface="Arial"/>
-                <a:ea typeface="Arial"/>
-                <a:cs typeface="Arial"/>
-              </a:rPr>
-              <a:t>Обучение: </a:t>
-            </a:r>
-            <a:r>
-              <a:rPr sz="2363" b="0">
-                <a:solidFill>
-                  <a:srgbClr val="111111"/>
-                </a:solidFill>
-                <a:latin typeface="Arial"/>
-                <a:ea typeface="Arial"/>
-                <a:cs typeface="Arial"/>
-              </a:rPr>
-              <a:t>сохраняется ли эффект при конечных данных, SGD и выборе гиперпараметров?</a:t>
-            </a:r>
-          </a:p>
-          <a:p xmlns:a="http://schemas.openxmlformats.org/drawingml/2006/main">
-            <a:pPr marL="24" indent="-14" algn="l">
-              <a:lnSpc>
-                <a:spcPct val="99000"/>
-              </a:lnSpc>
-              <a:spcAft>
-                <a:spcPts val="7"/>
-              </a:spcAft>
-              <a:buNone/>
-              <a:defRPr sz="2363" b="0">
-                <a:solidFill>
-                  <a:srgbClr val="111111"/>
-                </a:solidFill>
-                <a:latin typeface="Arial"/>
-                <a:ea typeface="Arial"/>
-                <a:cs typeface="Arial"/>
-              </a:defRPr>
-            </a:pPr>
-            <a:r>
-              <a:rPr sz="2363" b="0">
-                <a:solidFill>
-                  <a:srgbClr val="111111"/>
-                </a:solidFill>
-                <a:latin typeface="Arial"/>
-                <a:ea typeface="Arial"/>
-                <a:cs typeface="Arial"/>
-              </a:rPr>
-              <a:t>Фальсифицируемость: </a:t>
-            </a:r>
-            <a:r>
-              <a:rPr sz="2363" b="0">
-                <a:solidFill>
-                  <a:srgbClr val="111111"/>
-                </a:solidFill>
-                <a:latin typeface="Arial"/>
-                <a:ea typeface="Arial"/>
-                <a:cs typeface="Arial"/>
-              </a:rPr>
-              <a:t>γ = 0, contrast shift и rotation r=8 служат отрицательными примерами.</a:t>
+              <a:defRPr sz="1650" b="0">
+                <a:solidFill>
+                  <a:srgbClr val="5F6870"/>
+                </a:solidFill>
+                <a:latin typeface="Arial"/>
+                <a:ea typeface="Arial"/>
+                <a:cs typeface="Arial"/>
+              </a:defRPr>
+            </a:pPr>
+            <a:r>
+              <a:rPr sz="1650" b="0">
+                <a:solidFill>
+                  <a:srgbClr val="5F6870"/>
+                </a:solidFill>
+                <a:latin typeface="Arial"/>
+                <a:ea typeface="Arial"/>
+                <a:cs typeface="Arial"/>
+              </a:rPr>
+              <a:t>Target-test evaluation followed the frozen validation-selected extension protocol. Error bars are paired t intervals; exact CIs, p-values, and rank budgets are in the repository.</a:t>
             </a:r>
           </a:p>
         </p:txBody>
@@ -3472,8 +3420,8 @@
         </p:nvSpPr>
         <p:spPr>
           <a:xfrm xmlns:a="http://schemas.openxmlformats.org/drawingml/2006/main">
-            <a:off x="1511811" y="29460098"/>
-            <a:ext cx="16893945" cy="310896"/>
+            <a:off x="1511808" y="29460063"/>
+            <a:ext cx="16893921" cy="310896"/>
           </a:xfrm>
           <a:prstGeom xmlns:a="http://schemas.openxmlformats.org/drawingml/2006/main" prst="rect">
             <a:avLst/>
@@ -3481,7 +3429,7 @@
         </p:spPr>
         <p:txBody>
           <a:bodyPr xmlns:a="http://schemas.openxmlformats.org/drawingml/2006/main" vert="horz" wrap="square" lIns="0" tIns="0" rIns="0" bIns="0" anchor="ctr">
-            <a:normAutofit fontScale="100000"/>
+            <a:noAutofit/>
           </a:bodyPr>
           <a:lstStyle xmlns:a="http://schemas.openxmlformats.org/drawingml/2006/main">
             <a:lvl1pPr algn="ctr">
@@ -3505,25 +3453,25 @@
                 <a:spcPct val="102000"/>
               </a:lnSpc>
               <a:buNone/>
-              <a:defRPr sz="2000" b="0">
-                <a:solidFill>
-                  <a:srgbClr val="5B6268"/>
-                </a:solidFill>
-                <a:latin typeface="Arial"/>
-                <a:ea typeface="Arial"/>
-                <a:cs typeface="Arial"/>
-              </a:defRPr>
-            </a:pPr>
-            <a:r>
-              <a:rPr sz="2000" b="0">
-                <a:solidFill>
-                  <a:srgbClr val="5B6268"/>
-                </a:solidFill>
-                <a:latin typeface="Arial"/>
-                <a:ea typeface="Arial"/>
-                <a:cs typeface="Arial"/>
-              </a:rPr>
-              <a:t>[3] scikit-learn Digits; код, seeds, CSV и notebook - GitHub (QR).</a:t>
+              <a:defRPr sz="1500" b="0">
+                <a:solidFill>
+                  <a:srgbClr val="5F6870"/>
+                </a:solidFill>
+                <a:latin typeface="Arial"/>
+                <a:ea typeface="Arial"/>
+                <a:cs typeface="Arial"/>
+              </a:defRPr>
+            </a:pPr>
+            <a:r>
+              <a:rPr sz="1500" b="0">
+                <a:solidFill>
+                  <a:srgbClr val="5F6870"/>
+                </a:solidFill>
+                <a:latin typeface="Arial"/>
+                <a:ea typeface="Arial"/>
+                <a:cs typeface="Arial"/>
+              </a:rPr>
+              <a:t>Code, executed notebook, full report, raw results, and reproduction instructions → QR.</a:t>
             </a:r>
           </a:p>
         </p:txBody>
@@ -3544,8 +3492,8 @@
         </p:nvSpPr>
         <p:spPr>
           <a:xfrm xmlns:a="http://schemas.openxmlformats.org/drawingml/2006/main">
-            <a:off x="1511811" y="29021186"/>
-            <a:ext cx="16893945" cy="310896"/>
+            <a:off x="1511808" y="29021151"/>
+            <a:ext cx="16893921" cy="310896"/>
           </a:xfrm>
           <a:prstGeom xmlns:a="http://schemas.openxmlformats.org/drawingml/2006/main" prst="rect">
             <a:avLst/>
@@ -3553,7 +3501,7 @@
         </p:spPr>
         <p:txBody>
           <a:bodyPr xmlns:a="http://schemas.openxmlformats.org/drawingml/2006/main" vert="horz" wrap="square" lIns="0" tIns="0" rIns="0" bIns="0" anchor="ctr">
-            <a:normAutofit fontScale="100000"/>
+            <a:noAutofit/>
           </a:bodyPr>
           <a:lstStyle xmlns:a="http://schemas.openxmlformats.org/drawingml/2006/main">
             <a:lvl1pPr algn="ctr">
@@ -3577,25 +3525,25 @@
                 <a:spcPct val="102000"/>
               </a:lnSpc>
               <a:buNone/>
-              <a:defRPr sz="2000" b="0">
-                <a:solidFill>
-                  <a:srgbClr val="5B6268"/>
-                </a:solidFill>
-                <a:latin typeface="Arial"/>
-                <a:ea typeface="Arial"/>
-                <a:cs typeface="Arial"/>
-              </a:defRPr>
-            </a:pPr>
-            <a:r>
-              <a:rPr sz="2000" b="0">
-                <a:solidFill>
-                  <a:srgbClr val="5B6268"/>
-                </a:solidFill>
-                <a:latin typeface="Arial"/>
-                <a:ea typeface="Arial"/>
-                <a:cs typeface="Arial"/>
-              </a:rPr>
-              <a:t>[2] Hu et al. LoRA: Low-Rank Adaptation of Large Language Models. ICLR 2022.</a:t>
+              <a:defRPr sz="1500" b="0">
+                <a:solidFill>
+                  <a:srgbClr val="5F6870"/>
+                </a:solidFill>
+                <a:latin typeface="Arial"/>
+                <a:ea typeface="Arial"/>
+                <a:cs typeface="Arial"/>
+              </a:defRPr>
+            </a:pPr>
+            <a:r>
+              <a:rPr sz="1500" b="0">
+                <a:solidFill>
+                  <a:srgbClr val="5F6870"/>
+                </a:solidFill>
+                <a:latin typeface="Arial"/>
+                <a:ea typeface="Arial"/>
+                <a:cs typeface="Arial"/>
+              </a:rPr>
+              <a:t>[3] Hayou et al. LoRA+. ICML 2024.     Statistical protocol and raw CSV: GitHub.</a:t>
             </a:r>
           </a:p>
         </p:txBody>
@@ -3616,8 +3564,8 @@
         </p:nvSpPr>
         <p:spPr>
           <a:xfrm xmlns:a="http://schemas.openxmlformats.org/drawingml/2006/main">
-            <a:off x="1511811" y="28545698"/>
-            <a:ext cx="16893945" cy="310896"/>
+            <a:off x="1511808" y="28545663"/>
+            <a:ext cx="16893921" cy="310896"/>
           </a:xfrm>
           <a:prstGeom xmlns:a="http://schemas.openxmlformats.org/drawingml/2006/main" prst="rect">
             <a:avLst/>
@@ -3625,7 +3573,7 @@
         </p:spPr>
         <p:txBody>
           <a:bodyPr xmlns:a="http://schemas.openxmlformats.org/drawingml/2006/main" vert="horz" wrap="square" lIns="0" tIns="0" rIns="0" bIns="0" anchor="ctr">
-            <a:normAutofit fontScale="100000"/>
+            <a:noAutofit/>
           </a:bodyPr>
           <a:lstStyle xmlns:a="http://schemas.openxmlformats.org/drawingml/2006/main">
             <a:lvl1pPr algn="ctr">
@@ -3649,25 +3597,25 @@
                 <a:spcPct val="102000"/>
               </a:lnSpc>
               <a:buNone/>
-              <a:defRPr sz="2000" b="0">
-                <a:solidFill>
-                  <a:srgbClr val="5B6268"/>
-                </a:solidFill>
-                <a:latin typeface="Arial"/>
-                <a:ea typeface="Arial"/>
-                <a:cs typeface="Arial"/>
-              </a:defRPr>
-            </a:pPr>
-            <a:r>
-              <a:rPr sz="2000" b="0">
-                <a:solidFill>
-                  <a:srgbClr val="5B6268"/>
-                </a:solidFill>
-                <a:latin typeface="Arial"/>
-                <a:ea typeface="Arial"/>
-                <a:cs typeface="Arial"/>
-              </a:rPr>
-              <a:t>[1] Liu et al. DoRA: Weight-Decomposed Low-Rank Adaptation. ICML 2024, PMLR 235.</a:t>
+              <a:defRPr sz="1500" b="0">
+                <a:solidFill>
+                  <a:srgbClr val="5F6870"/>
+                </a:solidFill>
+                <a:latin typeface="Arial"/>
+                <a:ea typeface="Arial"/>
+                <a:cs typeface="Arial"/>
+              </a:defRPr>
+            </a:pPr>
+            <a:r>
+              <a:rPr sz="1500" b="0">
+                <a:solidFill>
+                  <a:srgbClr val="5F6870"/>
+                </a:solidFill>
+                <a:latin typeface="Arial"/>
+                <a:ea typeface="Arial"/>
+                <a:cs typeface="Arial"/>
+              </a:rPr>
+              <a:t>[1] Hu et al. LoRA. ICLR 2022.     [2] Liu et al. DoRA. ICML 2024.</a:t>
             </a:r>
           </a:p>
         </p:txBody>
@@ -3809,8 +3757,8 @@
         </p:nvSpPr>
         <p:spPr>
           <a:xfrm xmlns:a="http://schemas.openxmlformats.org/drawingml/2006/main">
-            <a:off x="18135600" y="29870400"/>
-            <a:ext cx="1885950" cy="274320"/>
+            <a:off x="17926050" y="29870400"/>
+            <a:ext cx="2305050" cy="274320"/>
           </a:xfrm>
           <a:prstGeom xmlns:a="http://schemas.openxmlformats.org/drawingml/2006/main" prst="rect">
             <a:avLst/>
@@ -3818,7 +3766,7 @@
         </p:spPr>
         <p:txBody>
           <a:bodyPr xmlns:a="http://schemas.openxmlformats.org/drawingml/2006/main" vert="horz" wrap="square" lIns="0" tIns="0" rIns="0" bIns="0" anchor="ctr">
-            <a:normAutofit fontScale="100000"/>
+            <a:noAutofit/>
           </a:bodyPr>
           <a:lstStyle xmlns:a="http://schemas.openxmlformats.org/drawingml/2006/main">
             <a:lvl1pPr algn="ctr">
@@ -3842,26 +3790,26 @@
                 <a:spcPct val="92000"/>
               </a:lnSpc>
               <a:buNone/>
-              <a:defRPr sz="1650" b="1">
-                <a:solidFill>
-                  <a:srgbClr val="087F78"/>
-                </a:solidFill>
-                <a:latin typeface="Arial"/>
-                <a:ea typeface="Arial"/>
-                <a:cs typeface="Arial"/>
-              </a:defRPr>
-            </a:pPr>
-            <a:r>
-              <a:rPr sz="1650" b="1">
-                <a:solidFill>
-                  <a:srgbClr val="087F78"/>
-                </a:solidFill>
-                <a:latin typeface="Arial"/>
-                <a:ea typeface="Arial"/>
-                <a:cs typeface="Arial"/>
-                <a:hlinkClick xmlns:r="http://schemas.openxmlformats.org/officeDocument/2006/relationships" r:id="R8edebec4c7da4c97"/>
-              </a:rPr>
-              <a:t>КОД И CSV</a:t>
+              <a:defRPr sz="1275" b="1">
+                <a:solidFill>
+                  <a:srgbClr val="008A80"/>
+                </a:solidFill>
+                <a:latin typeface="Arial"/>
+                <a:ea typeface="Arial"/>
+                <a:cs typeface="Arial"/>
+              </a:defRPr>
+            </a:pPr>
+            <a:r>
+              <a:rPr sz="1275" b="1">
+                <a:solidFill>
+                  <a:srgbClr val="008A80"/>
+                </a:solidFill>
+                <a:latin typeface="Arial"/>
+                <a:ea typeface="Arial"/>
+                <a:cs typeface="Arial"/>
+                <a:hlinkClick xmlns:r="http://schemas.openxmlformats.org/officeDocument/2006/relationships" r:id="R86527362545a4ea4"/>
+              </a:rPr>
+              <a:t>CODE / DATA / REPORT</a:t>
             </a:r>
           </a:p>
         </p:txBody>
@@ -4212,7 +4160,7 @@
       </p:sp>
       <p:cxnSp>
         <p:nvCxnSpPr>
-          <p:cNvPr id="87" name=""/>
+          <p:cNvPr id="169" name=""/>
           <p:cNvCxnSpPr>
             <a:stCxn xmlns:a="http://schemas.openxmlformats.org/drawingml/2006/main" id="40" idx="3"/>
             <a:endCxn xmlns:a="http://schemas.openxmlformats.org/drawingml/2006/main" id="41" idx="1"/>
@@ -4238,7 +4186,7 @@
       </p:cxnSp>
       <p:cxnSp>
         <p:nvCxnSpPr>
-          <p:cNvPr id="88" name=""/>
+          <p:cNvPr id="170" name=""/>
           <p:cNvCxnSpPr>
             <a:stCxn xmlns:a="http://schemas.openxmlformats.org/drawingml/2006/main" id="41" idx="3"/>
             <a:endCxn xmlns:a="http://schemas.openxmlformats.org/drawingml/2006/main" id="42" idx="1"/>
@@ -4536,7 +4484,7 @@
       </p:sp>
       <p:cxnSp>
         <p:nvCxnSpPr>
-          <p:cNvPr id="93" name=""/>
+          <p:cNvPr id="175" name=""/>
           <p:cNvCxnSpPr>
             <a:stCxn xmlns:a="http://schemas.openxmlformats.org/drawingml/2006/main" id="45" idx="3"/>
             <a:endCxn xmlns:a="http://schemas.openxmlformats.org/drawingml/2006/main" id="46" idx="1"/>
@@ -4562,7 +4510,7 @@
       </p:cxnSp>
       <p:cxnSp>
         <p:nvCxnSpPr>
-          <p:cNvPr id="94" name=""/>
+          <p:cNvPr id="176" name=""/>
           <p:cNvCxnSpPr>
             <a:stCxn xmlns:a="http://schemas.openxmlformats.org/drawingml/2006/main" id="46" idx="3"/>
             <a:endCxn xmlns:a="http://schemas.openxmlformats.org/drawingml/2006/main" id="47" idx="1"/>
@@ -4588,7 +4536,7 @@
       </p:cxnSp>
       <p:cxnSp>
         <p:nvCxnSpPr>
-          <p:cNvPr id="95" name=""/>
+          <p:cNvPr id="177" name=""/>
           <p:cNvCxnSpPr>
             <a:stCxn xmlns:a="http://schemas.openxmlformats.org/drawingml/2006/main" id="47" idx="3"/>
             <a:endCxn xmlns:a="http://schemas.openxmlformats.org/drawingml/2006/main" id="48" idx="1"/>
@@ -4650,7 +4598,7 @@
         </p:spPr>
         <p:txBody>
           <a:bodyPr xmlns:a="http://schemas.openxmlformats.org/drawingml/2006/main" wrap="square" lIns="38100" tIns="19050" rIns="38100" bIns="19050" anchor="ctr">
-            <a:normAutofit fontScale="100000"/>
+            <a:noAutofit/>
           </a:bodyPr>
           <a:lstStyle xmlns:a="http://schemas.openxmlformats.org/drawingml/2006/main"/>
           <a:p xmlns:a="http://schemas.openxmlformats.org/drawingml/2006/main">
@@ -4659,25 +4607,25 @@
                 <a:spcPct val="96000"/>
               </a:lnSpc>
               <a:buNone/>
-              <a:defRPr sz="1725" b="0">
-                <a:solidFill>
-                  <a:srgbClr val="5B6268"/>
-                </a:solidFill>
-                <a:latin typeface="Arial"/>
-                <a:ea typeface="Arial"/>
-                <a:cs typeface="Arial"/>
-              </a:defRPr>
-            </a:pPr>
-            <a:r>
-              <a:rPr sz="1725" b="0">
-                <a:solidFill>
-                  <a:srgbClr val="5B6268"/>
-                </a:solidFill>
-                <a:latin typeface="Arial"/>
-                <a:ea typeface="Arial"/>
-                <a:cs typeface="Arial"/>
-              </a:rPr>
-              <a:t>направление</a:t>
+              <a:defRPr sz="1500" b="0">
+                <a:solidFill>
+                  <a:srgbClr val="5F6870"/>
+                </a:solidFill>
+                <a:latin typeface="Arial"/>
+                <a:ea typeface="Arial"/>
+                <a:cs typeface="Arial"/>
+              </a:defRPr>
+            </a:pPr>
+            <a:r>
+              <a:rPr sz="1500" b="0">
+                <a:solidFill>
+                  <a:srgbClr val="5F6870"/>
+                </a:solidFill>
+                <a:latin typeface="Arial"/>
+                <a:ea typeface="Arial"/>
+                <a:cs typeface="Arial"/>
+              </a:rPr>
+              <a:t>direction</a:t>
             </a:r>
           </a:p>
         </p:txBody>
@@ -4720,7 +4668,7 @@
         </p:spPr>
         <p:txBody>
           <a:bodyPr xmlns:a="http://schemas.openxmlformats.org/drawingml/2006/main" wrap="square" lIns="38100" tIns="19050" rIns="38100" bIns="19050" anchor="ctr">
-            <a:normAutofit fontScale="77720"/>
+            <a:normAutofit fontScale="91628"/>
           </a:bodyPr>
           <a:lstStyle xmlns:a="http://schemas.openxmlformats.org/drawingml/2006/main"/>
           <a:p xmlns:a="http://schemas.openxmlformats.org/drawingml/2006/main">
@@ -4729,25 +4677,25 @@
                 <a:spcPct val="96000"/>
               </a:lnSpc>
               <a:buNone/>
-              <a:defRPr sz="1725" b="1">
-                <a:solidFill>
-                  <a:srgbClr val="087F78"/>
-                </a:solidFill>
-                <a:latin typeface="Arial"/>
-                <a:ea typeface="Arial"/>
-                <a:cs typeface="Arial"/>
-              </a:defRPr>
-            </a:pPr>
-            <a:r>
-              <a:rPr sz="1725" b="1">
-                <a:solidFill>
-                  <a:srgbClr val="087F78"/>
-                </a:solidFill>
-                <a:latin typeface="Arial"/>
-                <a:ea typeface="Arial"/>
-                <a:cs typeface="Arial"/>
-              </a:rPr>
-              <a:t>отдельная норма m</a:t>
+              <a:defRPr sz="1350" b="1">
+                <a:solidFill>
+                  <a:srgbClr val="008A80"/>
+                </a:solidFill>
+                <a:latin typeface="Arial"/>
+                <a:ea typeface="Arial"/>
+                <a:cs typeface="Arial"/>
+              </a:defRPr>
+            </a:pPr>
+            <a:r>
+              <a:rPr sz="1350" b="1">
+                <a:solidFill>
+                  <a:srgbClr val="008A80"/>
+                </a:solidFill>
+                <a:latin typeface="Arial"/>
+                <a:ea typeface="Arial"/>
+                <a:cs typeface="Arial"/>
+              </a:rPr>
+              <a:t>independent row scale m</a:t>
             </a:r>
           </a:p>
         </p:txBody>
@@ -4790,54 +4738,54 @@
         </p:spPr>
         <p:txBody>
           <a:bodyPr xmlns:a="http://schemas.openxmlformats.org/drawingml/2006/main" wrap="square" lIns="38100" tIns="19050" rIns="38100" bIns="19050" anchor="ctr">
-            <a:normAutofit fontScale="91210"/>
+            <a:noAutofit/>
           </a:bodyPr>
           <a:lstStyle xmlns:a="http://schemas.openxmlformats.org/drawingml/2006/main"/>
           <a:p xmlns:a="http://schemas.openxmlformats.org/drawingml/2006/main">
-            <a:pPr algn="l">
+            <a:pPr algn="ctr">
               <a:lnSpc>
                 <a:spcPct val="96000"/>
               </a:lnSpc>
               <a:buNone/>
-              <a:defRPr sz="1800" b="0">
-                <a:solidFill>
-                  <a:srgbClr val="5B6268"/>
-                </a:solidFill>
-                <a:latin typeface="Arial"/>
-                <a:ea typeface="Arial"/>
-                <a:cs typeface="Arial"/>
-              </a:defRPr>
-            </a:pPr>
-            <a:r>
-              <a:rPr sz="1800" b="0">
-                <a:solidFill>
-                  <a:srgbClr val="5B6268"/>
-                </a:solidFill>
-                <a:latin typeface="Arial"/>
-                <a:ea typeface="Arial"/>
-                <a:cs typeface="Arial"/>
-              </a:rPr>
-              <a:t>Одинаковый rank r; у DoRA добавляется d_out magnitude-параметров.</a:t>
+              <a:defRPr sz="1500" b="0">
+                <a:solidFill>
+                  <a:srgbClr val="5F6870"/>
+                </a:solidFill>
+                <a:latin typeface="Arial"/>
+                <a:ea typeface="Arial"/>
+                <a:cs typeface="Arial"/>
+              </a:defRPr>
+            </a:pPr>
+            <a:r>
+              <a:rPr sz="1500" b="0">
+                <a:solidFill>
+                  <a:srgbClr val="5F6870"/>
+                </a:solidFill>
+                <a:latin typeface="Arial"/>
+                <a:ea typeface="Arial"/>
+                <a:cs typeface="Arial"/>
+              </a:rPr>
+              <a:t>Same rank r; DoRA adds d_out trainable magnitude parameters.</a:t>
             </a:r>
           </a:p>
         </p:txBody>
       </p:sp>
       <p:pic>
         <p:nvPicPr>
-          <p:cNvPr id="99" name=""/>
+          <p:cNvPr id="181" name=""/>
           <p:cNvPicPr>
             <a:picLocks xmlns:a="http://schemas.openxmlformats.org/drawingml/2006/main" noChangeAspect="1"/>
           </p:cNvPicPr>
           <p:nvPr/>
         </p:nvPicPr>
         <p:blipFill>
-          <a:blip xmlns:r="http://schemas.openxmlformats.org/officeDocument/2006/relationships" xmlns:a="http://schemas.openxmlformats.org/drawingml/2006/main" r:embed="Rb85b9e7012104491"/>
+          <a:blip xmlns:r="http://schemas.openxmlformats.org/officeDocument/2006/relationships" xmlns:a="http://schemas.openxmlformats.org/drawingml/2006/main" r:embed="Rf2ef21d7841e402a"/>
           <a:stretch xmlns:a="http://schemas.openxmlformats.org/drawingml/2006/main"/>
         </p:blipFill>
         <p:spPr>
           <a:xfrm xmlns:a="http://schemas.openxmlformats.org/drawingml/2006/main">
-            <a:off x="11540395" y="16130343"/>
-            <a:ext cx="8328851" cy="4250353"/>
+            <a:off x="11540395" y="9240089"/>
+            <a:ext cx="8328851" cy="12552272"/>
           </a:xfrm>
           <a:prstGeom xmlns:a="http://schemas.openxmlformats.org/drawingml/2006/main" prst="rect">
             <a:avLst/>
@@ -4846,14 +4794,14 @@
       </p:pic>
       <p:pic>
         <p:nvPicPr>
-          <p:cNvPr id="100" name=""/>
+          <p:cNvPr id="182" name=""/>
           <p:cNvPicPr>
             <a:picLocks xmlns:a="http://schemas.openxmlformats.org/drawingml/2006/main" noChangeAspect="1"/>
           </p:cNvPicPr>
           <p:nvPr/>
         </p:nvPicPr>
         <p:blipFill>
-          <a:blip xmlns:r="http://schemas.openxmlformats.org/officeDocument/2006/relationships" xmlns:a="http://schemas.openxmlformats.org/drawingml/2006/main" r:embed="Re642377f71264de3"/>
+          <a:blip xmlns:r="http://schemas.openxmlformats.org/officeDocument/2006/relationships" xmlns:a="http://schemas.openxmlformats.org/drawingml/2006/main" r:embed="Rf30d876fabb746fb"/>
           <a:stretch xmlns:a="http://schemas.openxmlformats.org/drawingml/2006/main"/>
         </p:blipFill>
         <p:spPr>

</xml_diff>

<commit_message>
Calibrate AIRI DoRA claims after external review
</commit_message>
<xml_diff>
--- a/poster/Lapin_Vladislav_DoRA_AIRI_2026.pptx
+++ b/poster/Lapin_Vladislav_DoRA_AIRI_2026.pptx
@@ -2,13 +2,13 @@
 <file path=ppt/presentation.xml><?xml version="1.0" encoding="utf-8"?>
 <p:presentation xmlns:p="http://schemas.openxmlformats.org/presentationml/2006/main">
   <p:sldMasterIdLst>
-    <p:sldMasterId xmlns:r="http://schemas.openxmlformats.org/officeDocument/2006/relationships" id="2147483648" r:id="R9cf5abe7ca3243d4"/>
+    <p:sldMasterId xmlns:r="http://schemas.openxmlformats.org/officeDocument/2006/relationships" id="2147483648" r:id="Rd68580fc692e443d"/>
   </p:sldMasterIdLst>
   <p:notesMasterIdLst>
-    <p:notesMasterId xmlns:r="http://schemas.openxmlformats.org/officeDocument/2006/relationships" r:id="Re5e9fe7dfca34cea"/>
+    <p:notesMasterId xmlns:r="http://schemas.openxmlformats.org/officeDocument/2006/relationships" r:id="Reee719eadaf44130"/>
   </p:notesMasterIdLst>
   <p:sldIdLst>
-    <p:sldId xmlns:r="http://schemas.openxmlformats.org/officeDocument/2006/relationships" id="256" r:id="R6cee9e0473404e54"/>
+    <p:sldId xmlns:r="http://schemas.openxmlformats.org/officeDocument/2006/relationships" id="256" r:id="R731320b00efe4a06"/>
   </p:sldIdLst>
   <p:sldSz cx="21383625" cy="30275213"/>
   <p:notesSz cx="6858000" cy="9144000"/>
@@ -590,7 +590,7 @@
           <p:nvPr/>
         </p:nvPicPr>
         <p:blipFill>
-          <a:blip xmlns:r="http://schemas.openxmlformats.org/officeDocument/2006/relationships" xmlns:a="http://schemas.openxmlformats.org/drawingml/2006/main" r:embed="R10657e7a6d7348a1"/>
+          <a:blip xmlns:r="http://schemas.openxmlformats.org/officeDocument/2006/relationships" xmlns:a="http://schemas.openxmlformats.org/drawingml/2006/main" r:embed="R1593d766020c4289"/>
           <a:stretch xmlns:a="http://schemas.openxmlformats.org/drawingml/2006/main">
             <a:fillRect l="0" t="0" r="0" b="0"/>
           </a:stretch>
@@ -614,7 +614,7 @@
           <p:nvPr/>
         </p:nvPicPr>
         <p:blipFill>
-          <a:blip xmlns:r="http://schemas.openxmlformats.org/officeDocument/2006/relationships" xmlns:a="http://schemas.openxmlformats.org/drawingml/2006/main" r:embed="Rd03fe83c58aa4aac"/>
+          <a:blip xmlns:r="http://schemas.openxmlformats.org/officeDocument/2006/relationships" xmlns:a="http://schemas.openxmlformats.org/drawingml/2006/main" r:embed="R0c1f96dd6ab743c8"/>
           <a:stretch xmlns:a="http://schemas.openxmlformats.org/drawingml/2006/main">
             <a:fillRect l="0" t="0" r="0" b="0"/>
           </a:stretch>
@@ -684,7 +684,7 @@
           <p:nvPr/>
         </p:nvPicPr>
         <p:blipFill>
-          <a:blip xmlns:r="http://schemas.openxmlformats.org/officeDocument/2006/relationships" xmlns:a="http://schemas.openxmlformats.org/drawingml/2006/main" r:embed="Rc68a4f66c9c64fb0"/>
+          <a:blip xmlns:r="http://schemas.openxmlformats.org/officeDocument/2006/relationships" xmlns:a="http://schemas.openxmlformats.org/drawingml/2006/main" r:embed="R959504b1c11749b3"/>
           <a:stretch xmlns:a="http://schemas.openxmlformats.org/drawingml/2006/main">
             <a:fillRect l="0" t="0" r="0" b="0"/>
           </a:stretch>
@@ -708,7 +708,7 @@
           <p:nvPr/>
         </p:nvPicPr>
         <p:blipFill>
-          <a:blip xmlns:r="http://schemas.openxmlformats.org/officeDocument/2006/relationships" xmlns:a="http://schemas.openxmlformats.org/drawingml/2006/main" r:embed="Rc44284c420694238"/>
+          <a:blip xmlns:r="http://schemas.openxmlformats.org/officeDocument/2006/relationships" xmlns:a="http://schemas.openxmlformats.org/drawingml/2006/main" r:embed="R986eaaac4ca14f08"/>
           <a:stretch xmlns:a="http://schemas.openxmlformats.org/drawingml/2006/main">
             <a:fillRect l="0" t="0" r="0" b="0"/>
           </a:stretch>
@@ -875,7 +875,7 @@
   </p:cSld>
   <p:clrMap bg1="lt1" tx1="dk1" bg2="lt2" tx2="dk2" accent1="accent1" accent2="accent2" accent3="accent3" accent4="accent4" accent5="accent5" accent6="accent6" hlink="hlink" folHlink="folHlink"/>
   <p:sldLayoutIdLst>
-    <p:sldLayoutId xmlns:r="http://schemas.openxmlformats.org/officeDocument/2006/relationships" id="2147483649" r:id="R9f163b2d76364c59"/>
+    <p:sldLayoutId xmlns:r="http://schemas.openxmlformats.org/officeDocument/2006/relationships" id="2147483649" r:id="R35a6914c81ad495c"/>
   </p:sldLayoutIdLst>
   <p:txStyles>
     <p:titleStyle>
@@ -1495,7 +1495,7 @@
                 <a:ea typeface="Arial"/>
                 <a:cs typeface="Arial"/>
               </a:rPr>
-              <a:t>Geometry, budgets, and confirmatory few-shot adaptation</a:t>
+              <a:t>Geometry, budgets, and held-seed few-shot adaptation</a:t>
             </a:r>
           </a:p>
         </p:txBody>
@@ -1785,7 +1785,7 @@
                 <a:ea typeface="Arial"/>
                 <a:cs typeface="Arial"/>
               </a:rPr>
-              <a:t> MLP seeds and </a:t>
+              <a:t> MLP pairs and </a:t>
             </a:r>
             <a:r>
               <a:rPr sz="2025" b="1">
@@ -1807,7 +1807,7 @@
                 <a:ea typeface="Arial"/>
                 <a:cs typeface="Arial"/>
               </a:rPr>
-              <a:t> CNN seeds favored DoRA. The unadjusted 95% CI excludes zero for CNN, not MLP; </a:t>
+              <a:t> CNN pairs favored DoRA. </a:t>
             </a:r>
             <a:r>
               <a:rPr sz="2025" b="1">
@@ -1829,7 +1829,7 @@
                 <a:ea typeface="Arial"/>
                 <a:cs typeface="Arial"/>
               </a:rPr>
-              <a:t> comparison families remain inconclusive.</a:t>
+              <a:t> p=.382213 (MLP) / .158955 (CNN): internal fixed-checkpoint evidence, not external replication.</a:t>
             </a:r>
           </a:p>
         </p:txBody>
@@ -1901,7 +1901,7 @@
                 <a:ea typeface="Arial"/>
                 <a:cs typeface="Arial"/>
               </a:rPr>
-              <a:t>Figure 2. Replication → data regime → capacity / optimization diagnostic.</a:t>
+              <a:t>Figure 2. Held-seed estimate → data regime → capacity / optimization diagnostic.</a:t>
             </a:r>
           </a:p>
         </p:txBody>
@@ -2323,7 +2323,7 @@
                 <a:ea typeface="Arial"/>
                 <a:cs typeface="Arial"/>
               </a:rPr>
-              <a:t>Frozen protocol before confirmatory testing</a:t>
+              <a:t>Frozen protocol before held-seed evaluation</a:t>
             </a:r>
           </a:p>
         </p:txBody>
@@ -2439,7 +2439,7 @@
                 <a:ea typeface="Arial"/>
                 <a:cs typeface="Arial"/>
               </a:rPr>
-              <a:t>Confirmatory:</a:t>
+              <a:t>Held-seed:</a:t>
             </a:r>
             <a:r>
               <a:rPr sz="2025" b="0">
@@ -2450,7 +2450,18 @@
                 <a:ea typeface="Arial"/>
                 <a:cs typeface="Arial"/>
               </a:rPr>
-              <a:t> 20 paired MLP seeds + 10 paired CNN seeds; 3 shifts; 9 pre-declared primary comparisons with Holm correction.</a:t>
+              <a:t> </a:t>
+            </a:r>
+            <a:r>
+              <a:rPr sz="2025" b="0">
+                <a:solidFill>
+                  <a:srgbClr val="101820"/>
+                </a:solidFill>
+                <a:latin typeface="Arial"/>
+                <a:ea typeface="Arial"/>
+                <a:cs typeface="Arial"/>
+              </a:rPr>
+              <a:t>20 MLP + 10 CNN adaptation seeds; one fixed checkpoint each; 3 shifts; Holm families m=9 / 6 / 3 (secondary descriptive).</a:t>
             </a:r>
           </a:p>
           <a:p xmlns:a="http://schemas.openxmlformats.org/drawingml/2006/main">
@@ -2491,7 +2502,29 @@
                 <a:ea typeface="Arial"/>
                 <a:cs typeface="Arial"/>
               </a:rPr>
-              <a:t> frozen, magnitude-only, LoRA, LoRA+, matched-budget LoRA, budgeted DoRA, and full fine-tuning.</a:t>
+              <a:t> frozen, magnitude-only, LoRA, </a:t>
+            </a:r>
+            <a:r>
+              <a:rPr sz="2025" b="0">
+                <a:solidFill>
+                  <a:srgbClr val="101820"/>
+                </a:solidFill>
+                <a:latin typeface="Arial"/>
+                <a:ea typeface="Arial"/>
+                <a:cs typeface="Arial"/>
+              </a:rPr>
+              <a:t>LoRA+ (fixed B/A=16), matched-budget</a:t>
+            </a:r>
+            <a:r>
+              <a:rPr sz="2025" b="0">
+                <a:solidFill>
+                  <a:srgbClr val="101820"/>
+                </a:solidFill>
+                <a:latin typeface="Arial"/>
+                <a:ea typeface="Arial"/>
+                <a:cs typeface="Arial"/>
+              </a:rPr>
+              <a:t> LoRA, budgeted DoRA, and full fine-tuning.</a:t>
             </a:r>
           </a:p>
           <a:p xmlns:a="http://schemas.openxmlformats.org/drawingml/2006/main">
@@ -2573,7 +2606,18 @@
                 <a:ea typeface="Arial"/>
                 <a:cs typeface="Arial"/>
               </a:rPr>
-              <a:t> saved result rows; 1,840 independent training / optimization jobs.</a:t>
+              <a:t> saved result rows; </a:t>
+            </a:r>
+            <a:r>
+              <a:rPr sz="2025" b="0">
+                <a:solidFill>
+                  <a:srgbClr val="101820"/>
+                </a:solidFill>
+                <a:latin typeface="Arial"/>
+                <a:ea typeface="Arial"/>
+                <a:cs typeface="Arial"/>
+              </a:rPr>
+              <a:t>1,840 training / optimization jobs.</a:t>
             </a:r>
           </a:p>
         </p:txBody>
@@ -2956,7 +3000,7 @@
                 <a:ea typeface="Arial"/>
                 <a:cs typeface="Arial"/>
               </a:rPr>
-              <a:t>What survived the controls</a:t>
+              <a:t>What the controls still support</a:t>
             </a:r>
           </a:p>
         </p:txBody>
@@ -3042,7 +3086,7 @@
                 <a:ea typeface="Arial"/>
                 <a:cs typeface="Arial"/>
               </a:rPr>
-              <a:t>Mixed-shift DoRA</a:t>
+              <a:t>The mixed-shift DoRA estimate</a:t>
             </a:r>
             <a:r>
               <a:rPr sz="1875" b="0">
@@ -3094,18 +3138,7 @@
                 <a:ea typeface="Arial"/>
                 <a:cs typeface="Arial"/>
               </a:rPr>
-              <a:t>Matched-budget LoRA</a:t>
-            </a:r>
-            <a:r>
-              <a:rPr sz="1875" b="0">
-                <a:solidFill>
-                  <a:srgbClr val="101820"/>
-                </a:solidFill>
-                <a:latin typeface="Arial"/>
-                <a:ea typeface="Arial"/>
-                <a:cs typeface="Arial"/>
-              </a:rPr>
-              <a:t> narrows the MLP gap to +0.53 pp; budgeted DoRA still gains +0.82 pp over uniform LoRA.</a:t>
+              <a:t>Matched-budget LoRA narrows the MLP gap to +0.53 pp; DoRA−LoRA+ Holm p=.050935 (&gt; .05); budgeted DoRA +.82 pp (secondary Holm p=.347089).</a:t>
             </a:r>
           </a:p>
           <a:p xmlns:a="http://schemas.openxmlformats.org/drawingml/2006/main">
@@ -3198,7 +3231,7 @@
                 <a:ea typeface="Arial"/>
                 <a:cs typeface="Arial"/>
               </a:rPr>
-              <a:t>Decision rule:</a:t>
+              <a:t>Follow-up hypothesis:</a:t>
             </a:r>
             <a:r>
               <a:rPr sz="1875" b="0">
@@ -3281,7 +3314,7 @@
                 <a:ea typeface="Arial"/>
                 <a:cs typeface="Arial"/>
               </a:rPr>
-              <a:t>CONFIRMATORY MIXED-SHIFT EFFECT</a:t>
+              <a:t>HELD-SEED MIXED-SHIFT ESTIMATES</a:t>
             </a:r>
           </a:p>
         </p:txBody>
@@ -3356,7 +3389,7 @@
                 <a:ea typeface="Arial"/>
                 <a:cs typeface="Arial"/>
               </a:rPr>
-              <a:t>Target-test evaluation followed the frozen validation-selected extension protocol. Error bars are paired t intervals; exact CIs, p-values, and rank budgets are in the repository.</a:t>
+              <a:t>Target-test evaluation followed the frozen validation-selected protocol. Internal confirmation on fixed checkpoints; exact CIs, raw/adjusted p-values, and rank budgets are in the repository.</a:t>
             </a:r>
           </a:p>
         </p:txBody>
@@ -3471,7 +3504,7 @@
                 <a:ea typeface="Arial"/>
                 <a:cs typeface="Arial"/>
               </a:rPr>
-              <a:t>Code, executed notebook, full report, raw results, and reproduction instructions → QR.</a:t>
+              <a:t>Code, validated notebook, full report, raw results, and reproduction instructions → QR.</a:t>
             </a:r>
           </a:p>
         </p:txBody>
@@ -3807,7 +3840,7 @@
                 <a:latin typeface="Arial"/>
                 <a:ea typeface="Arial"/>
                 <a:cs typeface="Arial"/>
-                <a:hlinkClick xmlns:r="http://schemas.openxmlformats.org/officeDocument/2006/relationships" r:id="R86527362545a4ea4"/>
+                <a:hlinkClick xmlns:r="http://schemas.openxmlformats.org/officeDocument/2006/relationships" r:id="Rdb120b4cd5a74c9f"/>
               </a:rPr>
               <a:t>CODE / DATA / REPORT</a:t>
             </a:r>
@@ -4160,7 +4193,7 @@
       </p:sp>
       <p:cxnSp>
         <p:nvCxnSpPr>
-          <p:cNvPr id="169" name=""/>
+          <p:cNvPr id="251" name=""/>
           <p:cNvCxnSpPr>
             <a:stCxn xmlns:a="http://schemas.openxmlformats.org/drawingml/2006/main" id="40" idx="3"/>
             <a:endCxn xmlns:a="http://schemas.openxmlformats.org/drawingml/2006/main" id="41" idx="1"/>
@@ -4186,7 +4219,7 @@
       </p:cxnSp>
       <p:cxnSp>
         <p:nvCxnSpPr>
-          <p:cNvPr id="170" name=""/>
+          <p:cNvPr id="252" name=""/>
           <p:cNvCxnSpPr>
             <a:stCxn xmlns:a="http://schemas.openxmlformats.org/drawingml/2006/main" id="41" idx="3"/>
             <a:endCxn xmlns:a="http://schemas.openxmlformats.org/drawingml/2006/main" id="42" idx="1"/>
@@ -4484,7 +4517,7 @@
       </p:sp>
       <p:cxnSp>
         <p:nvCxnSpPr>
-          <p:cNvPr id="175" name=""/>
+          <p:cNvPr id="257" name=""/>
           <p:cNvCxnSpPr>
             <a:stCxn xmlns:a="http://schemas.openxmlformats.org/drawingml/2006/main" id="45" idx="3"/>
             <a:endCxn xmlns:a="http://schemas.openxmlformats.org/drawingml/2006/main" id="46" idx="1"/>
@@ -4510,7 +4543,7 @@
       </p:cxnSp>
       <p:cxnSp>
         <p:nvCxnSpPr>
-          <p:cNvPr id="176" name=""/>
+          <p:cNvPr id="258" name=""/>
           <p:cNvCxnSpPr>
             <a:stCxn xmlns:a="http://schemas.openxmlformats.org/drawingml/2006/main" id="46" idx="3"/>
             <a:endCxn xmlns:a="http://schemas.openxmlformats.org/drawingml/2006/main" id="47" idx="1"/>
@@ -4536,7 +4569,7 @@
       </p:cxnSp>
       <p:cxnSp>
         <p:nvCxnSpPr>
-          <p:cNvPr id="177" name=""/>
+          <p:cNvPr id="259" name=""/>
           <p:cNvCxnSpPr>
             <a:stCxn xmlns:a="http://schemas.openxmlformats.org/drawingml/2006/main" id="47" idx="3"/>
             <a:endCxn xmlns:a="http://schemas.openxmlformats.org/drawingml/2006/main" id="48" idx="1"/>
@@ -4772,18 +4805,18 @@
       </p:sp>
       <p:pic>
         <p:nvPicPr>
-          <p:cNvPr id="181" name=""/>
+          <p:cNvPr id="263" name=""/>
           <p:cNvPicPr>
             <a:picLocks xmlns:a="http://schemas.openxmlformats.org/drawingml/2006/main" noChangeAspect="1"/>
           </p:cNvPicPr>
           <p:nvPr/>
         </p:nvPicPr>
         <p:blipFill>
-          <a:blip xmlns:r="http://schemas.openxmlformats.org/officeDocument/2006/relationships" xmlns:a="http://schemas.openxmlformats.org/drawingml/2006/main" r:embed="Rf2ef21d7841e402a"/>
+          <a:blip xmlns:r="http://schemas.openxmlformats.org/officeDocument/2006/relationships" xmlns:a="http://schemas.openxmlformats.org/drawingml/2006/main" r:embed="R88342b52dc1543df"/>
           <a:stretch xmlns:a="http://schemas.openxmlformats.org/drawingml/2006/main"/>
         </p:blipFill>
         <p:spPr>
-          <a:xfrm xmlns:a="http://schemas.openxmlformats.org/drawingml/2006/main">
+          <a:xfrm xmlns:a="http://schemas.openxmlformats.org/drawingml/2006/main" flipH="0" flipV="0">
             <a:off x="11540395" y="9240089"/>
             <a:ext cx="8328851" cy="12552272"/>
           </a:xfrm>
@@ -4794,14 +4827,14 @@
       </p:pic>
       <p:pic>
         <p:nvPicPr>
-          <p:cNvPr id="182" name=""/>
+          <p:cNvPr id="264" name=""/>
           <p:cNvPicPr>
             <a:picLocks xmlns:a="http://schemas.openxmlformats.org/drawingml/2006/main" noChangeAspect="1"/>
           </p:cNvPicPr>
           <p:nvPr/>
         </p:nvPicPr>
         <p:blipFill>
-          <a:blip xmlns:r="http://schemas.openxmlformats.org/officeDocument/2006/relationships" xmlns:a="http://schemas.openxmlformats.org/drawingml/2006/main" r:embed="Rf30d876fabb746fb"/>
+          <a:blip xmlns:r="http://schemas.openxmlformats.org/officeDocument/2006/relationships" xmlns:a="http://schemas.openxmlformats.org/drawingml/2006/main" r:embed="R81ba2f99242f4b13"/>
           <a:stretch xmlns:a="http://schemas.openxmlformats.org/drawingml/2006/main"/>
         </p:blipFill>
         <p:spPr>

</xml_diff>

<commit_message>
Polish AIRI poster after final evidence review
</commit_message>
<xml_diff>
--- a/poster/Lapin_Vladislav_DoRA_AIRI_2026.pptx
+++ b/poster/Lapin_Vladislav_DoRA_AIRI_2026.pptx
@@ -2,13 +2,13 @@
 <file path=ppt/presentation.xml><?xml version="1.0" encoding="utf-8"?>
 <p:presentation xmlns:p="http://schemas.openxmlformats.org/presentationml/2006/main">
   <p:sldMasterIdLst>
-    <p:sldMasterId xmlns:r="http://schemas.openxmlformats.org/officeDocument/2006/relationships" id="2147483648" r:id="Rd68580fc692e443d"/>
+    <p:sldMasterId xmlns:r="http://schemas.openxmlformats.org/officeDocument/2006/relationships" id="2147483648" r:id="R41496daa97864a20"/>
   </p:sldMasterIdLst>
   <p:notesMasterIdLst>
-    <p:notesMasterId xmlns:r="http://schemas.openxmlformats.org/officeDocument/2006/relationships" r:id="Reee719eadaf44130"/>
+    <p:notesMasterId xmlns:r="http://schemas.openxmlformats.org/officeDocument/2006/relationships" r:id="R91fb8d0b580148f0"/>
   </p:notesMasterIdLst>
   <p:sldIdLst>
-    <p:sldId xmlns:r="http://schemas.openxmlformats.org/officeDocument/2006/relationships" id="256" r:id="R731320b00efe4a06"/>
+    <p:sldId xmlns:r="http://schemas.openxmlformats.org/officeDocument/2006/relationships" id="256" r:id="Rdc7637082647466c"/>
   </p:sldIdLst>
   <p:sldSz cx="21383625" cy="30275213"/>
   <p:notesSz cx="6858000" cy="9144000"/>
@@ -590,7 +590,7 @@
           <p:nvPr/>
         </p:nvPicPr>
         <p:blipFill>
-          <a:blip xmlns:r="http://schemas.openxmlformats.org/officeDocument/2006/relationships" xmlns:a="http://schemas.openxmlformats.org/drawingml/2006/main" r:embed="R1593d766020c4289"/>
+          <a:blip xmlns:r="http://schemas.openxmlformats.org/officeDocument/2006/relationships" xmlns:a="http://schemas.openxmlformats.org/drawingml/2006/main" r:embed="R926c640bdf9046c0"/>
           <a:stretch xmlns:a="http://schemas.openxmlformats.org/drawingml/2006/main">
             <a:fillRect l="0" t="0" r="0" b="0"/>
           </a:stretch>
@@ -614,7 +614,7 @@
           <p:nvPr/>
         </p:nvPicPr>
         <p:blipFill>
-          <a:blip xmlns:r="http://schemas.openxmlformats.org/officeDocument/2006/relationships" xmlns:a="http://schemas.openxmlformats.org/drawingml/2006/main" r:embed="R0c1f96dd6ab743c8"/>
+          <a:blip xmlns:r="http://schemas.openxmlformats.org/officeDocument/2006/relationships" xmlns:a="http://schemas.openxmlformats.org/drawingml/2006/main" r:embed="Rcf630ab0e8fa4864"/>
           <a:stretch xmlns:a="http://schemas.openxmlformats.org/drawingml/2006/main">
             <a:fillRect l="0" t="0" r="0" b="0"/>
           </a:stretch>
@@ -684,7 +684,7 @@
           <p:nvPr/>
         </p:nvPicPr>
         <p:blipFill>
-          <a:blip xmlns:r="http://schemas.openxmlformats.org/officeDocument/2006/relationships" xmlns:a="http://schemas.openxmlformats.org/drawingml/2006/main" r:embed="R959504b1c11749b3"/>
+          <a:blip xmlns:r="http://schemas.openxmlformats.org/officeDocument/2006/relationships" xmlns:a="http://schemas.openxmlformats.org/drawingml/2006/main" r:embed="Rc104d6f9bfbc4bc6"/>
           <a:stretch xmlns:a="http://schemas.openxmlformats.org/drawingml/2006/main">
             <a:fillRect l="0" t="0" r="0" b="0"/>
           </a:stretch>
@@ -708,7 +708,7 @@
           <p:nvPr/>
         </p:nvPicPr>
         <p:blipFill>
-          <a:blip xmlns:r="http://schemas.openxmlformats.org/officeDocument/2006/relationships" xmlns:a="http://schemas.openxmlformats.org/drawingml/2006/main" r:embed="R986eaaac4ca14f08"/>
+          <a:blip xmlns:r="http://schemas.openxmlformats.org/officeDocument/2006/relationships" xmlns:a="http://schemas.openxmlformats.org/drawingml/2006/main" r:embed="R333c383b30d34ff3"/>
           <a:stretch xmlns:a="http://schemas.openxmlformats.org/drawingml/2006/main">
             <a:fillRect l="0" t="0" r="0" b="0"/>
           </a:stretch>
@@ -875,7 +875,7 @@
   </p:cSld>
   <p:clrMap bg1="lt1" tx1="dk1" bg2="lt2" tx2="dk2" accent1="accent1" accent2="accent2" accent3="accent3" accent4="accent4" accent5="accent5" accent6="accent6" hlink="hlink" folHlink="folHlink"/>
   <p:sldLayoutIdLst>
-    <p:sldLayoutId xmlns:r="http://schemas.openxmlformats.org/officeDocument/2006/relationships" id="2147483649" r:id="R35a6914c81ad495c"/>
+    <p:sldLayoutId xmlns:r="http://schemas.openxmlformats.org/officeDocument/2006/relationships" id="2147483649" r:id="Rd0399522f3fc4ba0"/>
   </p:sldLayoutIdLst>
   <p:txStyles>
     <p:titleStyle>
@@ -3051,13 +3051,13 @@
           <a:p xmlns:a="http://schemas.openxmlformats.org/drawingml/2006/main">
             <a:pPr marL="24" indent="-14" algn="l">
               <a:lnSpc>
-                <a:spcPct val="104000"/>
+                <a:spcPct val="102000"/>
               </a:lnSpc>
               <a:spcAft>
-                <a:spcPts val="7"/>
+                <a:spcPts val="6"/>
               </a:spcAft>
               <a:buNone/>
-              <a:defRPr sz="1875" b="0">
+              <a:defRPr sz="2100">
                 <a:solidFill>
                   <a:srgbClr val="101820"/>
                 </a:solidFill>
@@ -3067,7 +3067,7 @@
               </a:defRPr>
             </a:pPr>
             <a:r>
-              <a:rPr sz="1875" b="0">
+              <a:rPr sz="2100">
                 <a:solidFill>
                   <a:srgbClr val="101820"/>
                 </a:solidFill>
@@ -3078,38 +3078,38 @@
               <a:t>- </a:t>
             </a:r>
             <a:r>
-              <a:rPr sz="1875" b="1">
-                <a:solidFill>
-                  <a:srgbClr val="101820"/>
-                </a:solidFill>
-                <a:latin typeface="Arial"/>
-                <a:ea typeface="Arial"/>
-                <a:cs typeface="Arial"/>
-              </a:rPr>
-              <a:t>The mixed-shift DoRA estimate</a:t>
-            </a:r>
-            <a:r>
-              <a:rPr sz="1875" b="0">
-                <a:solidFill>
-                  <a:srgbClr val="101820"/>
-                </a:solidFill>
-                <a:latin typeface="Arial"/>
-                <a:ea typeface="Arial"/>
-                <a:cs typeface="Arial"/>
-              </a:rPr>
-              <a:t> reaches 75.22% on MLP and 80.53% on CNN - near full FT (75.17%, 80.67%) with only ~12-15% as many trainable parameters.</a:t>
+              <a:rPr sz="2100" b="1">
+                <a:solidFill>
+                  <a:srgbClr val="101820"/>
+                </a:solidFill>
+                <a:latin typeface="Arial"/>
+                <a:ea typeface="Arial"/>
+                <a:cs typeface="Arial"/>
+              </a:rPr>
+              <a:t>Mixed shift:</a:t>
+            </a:r>
+            <a:r>
+              <a:rPr sz="2100">
+                <a:solidFill>
+                  <a:srgbClr val="101820"/>
+                </a:solidFill>
+                <a:latin typeface="Arial"/>
+                <a:ea typeface="Arial"/>
+                <a:cs typeface="Arial"/>
+              </a:rPr>
+              <a:t> DoRA reaches 75.22% (MLP) and 80.53% (CNN), near full FT (75.17%, 80.67%) with ~12-15% of its trainable parameters.</a:t>
             </a:r>
           </a:p>
           <a:p xmlns:a="http://schemas.openxmlformats.org/drawingml/2006/main">
             <a:pPr marL="24" indent="-14" algn="l">
               <a:lnSpc>
-                <a:spcPct val="104000"/>
+                <a:spcPct val="102000"/>
               </a:lnSpc>
               <a:spcAft>
-                <a:spcPts val="7"/>
+                <a:spcPts val="6"/>
               </a:spcAft>
               <a:buNone/>
-              <a:defRPr sz="1875" b="0">
+              <a:defRPr sz="2100">
                 <a:solidFill>
                   <a:srgbClr val="101820"/>
                 </a:solidFill>
@@ -3119,7 +3119,7 @@
               </a:defRPr>
             </a:pPr>
             <a:r>
-              <a:rPr sz="1875" b="0">
+              <a:rPr sz="2100">
                 <a:solidFill>
                   <a:srgbClr val="101820"/>
                 </a:solidFill>
@@ -3130,27 +3130,38 @@
               <a:t>- </a:t>
             </a:r>
             <a:r>
-              <a:rPr sz="1875" b="1">
-                <a:solidFill>
-                  <a:srgbClr val="101820"/>
-                </a:solidFill>
-                <a:latin typeface="Arial"/>
-                <a:ea typeface="Arial"/>
-                <a:cs typeface="Arial"/>
-              </a:rPr>
-              <a:t>Matched-budget LoRA narrows the MLP gap to +0.53 pp; DoRA−LoRA+ Holm p=.050935 (&gt; .05); budgeted DoRA +.82 pp (secondary Holm p=.347089).</a:t>
+              <a:rPr sz="2100" b="1">
+                <a:solidFill>
+                  <a:srgbClr val="101820"/>
+                </a:solidFill>
+                <a:latin typeface="Arial"/>
+                <a:ea typeface="Arial"/>
+                <a:cs typeface="Arial"/>
+              </a:rPr>
+              <a:t>Fairer baselines:</a:t>
+            </a:r>
+            <a:r>
+              <a:rPr sz="2100">
+                <a:solidFill>
+                  <a:srgbClr val="101820"/>
+                </a:solidFill>
+                <a:latin typeface="Arial"/>
+                <a:ea typeface="Arial"/>
+                <a:cs typeface="Arial"/>
+              </a:rPr>
+              <a:t> matched-budget LoRA leaves +0.53 pp; DoRA-LoRA+ Holm p=.050935 (&gt; .05); budgeted DoRA +.82 pp (secondary Holm p=.347089).</a:t>
             </a:r>
           </a:p>
           <a:p xmlns:a="http://schemas.openxmlformats.org/drawingml/2006/main">
             <a:pPr marL="24" indent="-14" algn="l">
               <a:lnSpc>
-                <a:spcPct val="104000"/>
+                <a:spcPct val="102000"/>
               </a:lnSpc>
               <a:spcAft>
-                <a:spcPts val="7"/>
+                <a:spcPts val="6"/>
               </a:spcAft>
               <a:buNone/>
-              <a:defRPr sz="1875" b="0">
+              <a:defRPr sz="2100">
                 <a:solidFill>
                   <a:srgbClr val="101820"/>
                 </a:solidFill>
@@ -3160,7 +3171,7 @@
               </a:defRPr>
             </a:pPr>
             <a:r>
-              <a:rPr sz="1875" b="0">
+              <a:rPr sz="2100">
                 <a:solidFill>
                   <a:srgbClr val="101820"/>
                 </a:solidFill>
@@ -3171,38 +3182,38 @@
               <a:t>- </a:t>
             </a:r>
             <a:r>
-              <a:rPr sz="1875" b="1">
-                <a:solidFill>
-                  <a:srgbClr val="101820"/>
-                </a:solidFill>
-                <a:latin typeface="Arial"/>
-                <a:ea typeface="Arial"/>
-                <a:cs typeface="Arial"/>
-              </a:rPr>
-              <a:t>At γ=.8</a:t>
-            </a:r>
-            <a:r>
-              <a:rPr sz="1875" b="0">
-                <a:solidFill>
-                  <a:srgbClr val="101820"/>
-                </a:solidFill>
-                <a:latin typeface="Arial"/>
-                <a:ea typeface="Arial"/>
-                <a:cs typeface="Arial"/>
-              </a:rPr>
-              <a:t>, DoRA is representationally exact; training converges below 10⁻³ in 44/50 runs. LoRA's best possible mean error is 0.289.</a:t>
+              <a:rPr sz="2100" b="1">
+                <a:solidFill>
+                  <a:srgbClr val="101820"/>
+                </a:solidFill>
+                <a:latin typeface="Arial"/>
+                <a:ea typeface="Arial"/>
+                <a:cs typeface="Arial"/>
+              </a:rPr>
+              <a:t>Synthetic diagnostic (gamma=.8):</a:t>
+            </a:r>
+            <a:r>
+              <a:rPr sz="2100">
+                <a:solidFill>
+                  <a:srgbClr val="101820"/>
+                </a:solidFill>
+                <a:latin typeface="Arial"/>
+                <a:ea typeface="Arial"/>
+                <a:cs typeface="Arial"/>
+              </a:rPr>
+              <a:t> DoRA is representationally exact; 44/50 runs reach error &lt;10^-3. LoRA oracle mean error is .289.</a:t>
             </a:r>
           </a:p>
           <a:p xmlns:a="http://schemas.openxmlformats.org/drawingml/2006/main">
             <a:pPr marL="24" indent="-14" algn="l">
               <a:lnSpc>
-                <a:spcPct val="104000"/>
+                <a:spcPct val="102000"/>
               </a:lnSpc>
               <a:spcAft>
-                <a:spcPts val="7"/>
+                <a:spcPts val="0"/>
               </a:spcAft>
               <a:buNone/>
-              <a:defRPr sz="1875" b="0">
+              <a:defRPr sz="2100">
                 <a:solidFill>
                   <a:srgbClr val="101820"/>
                 </a:solidFill>
@@ -3212,7 +3223,7 @@
               </a:defRPr>
             </a:pPr>
             <a:r>
-              <a:rPr sz="1875" b="0">
+              <a:rPr sz="2100">
                 <a:solidFill>
                   <a:srgbClr val="101820"/>
                 </a:solidFill>
@@ -3223,26 +3234,26 @@
               <a:t>- </a:t>
             </a:r>
             <a:r>
-              <a:rPr sz="1875" b="1">
-                <a:solidFill>
-                  <a:srgbClr val="101820"/>
-                </a:solidFill>
-                <a:latin typeface="Arial"/>
-                <a:ea typeface="Arial"/>
-                <a:cs typeface="Arial"/>
-              </a:rPr>
-              <a:t>Follow-up hypothesis:</a:t>
-            </a:r>
-            <a:r>
-              <a:rPr sz="1875" b="0">
-                <a:solidFill>
-                  <a:srgbClr val="101820"/>
-                </a:solidFill>
-                <a:latin typeface="Arial"/>
-                <a:ea typeface="Arial"/>
-                <a:cs typeface="Arial"/>
-              </a:rPr>
-              <a:t> test DoRA when heterogeneous row-norm drift is plausible; retain LoRA and magnitude-only baselines.</a:t>
+              <a:rPr sz="2100" b="1">
+                <a:solidFill>
+                  <a:srgbClr val="101820"/>
+                </a:solidFill>
+                <a:latin typeface="Arial"/>
+                <a:ea typeface="Arial"/>
+                <a:cs typeface="Arial"/>
+              </a:rPr>
+              <a:t>Next test:</a:t>
+            </a:r>
+            <a:r>
+              <a:rPr sz="2100">
+                <a:solidFill>
+                  <a:srgbClr val="101820"/>
+                </a:solidFill>
+                <a:latin typeface="Arial"/>
+                <a:ea typeface="Arial"/>
+                <a:cs typeface="Arial"/>
+              </a:rPr>
+              <a:t> heterogeneous row-norm drift, retaining LoRA and magnitude-only controls.</a:t>
             </a:r>
           </a:p>
         </p:txBody>
@@ -3504,7 +3515,7 @@
                 <a:ea typeface="Arial"/>
                 <a:cs typeface="Arial"/>
               </a:rPr>
-              <a:t>Code, validated notebook, full report, raw results, and reproduction instructions → QR.</a:t>
+              <a:t>Code, raw results, notebook, and report → private review link; access available on request.</a:t>
             </a:r>
           </a:p>
         </p:txBody>
@@ -3840,9 +3851,9 @@
                 <a:latin typeface="Arial"/>
                 <a:ea typeface="Arial"/>
                 <a:cs typeface="Arial"/>
-                <a:hlinkClick xmlns:r="http://schemas.openxmlformats.org/officeDocument/2006/relationships" r:id="Rdb120b4cd5a74c9f"/>
-              </a:rPr>
-              <a:t>CODE / DATA / REPORT</a:t>
+                <a:hlinkClick xmlns:r="http://schemas.openxmlformats.org/officeDocument/2006/relationships" r:id="R2b7152ec2ffb4795"/>
+              </a:rPr>
+              <a:t>PRIVATE REVIEW LINK</a:t>
             </a:r>
           </a:p>
         </p:txBody>
@@ -4193,7 +4204,7 @@
       </p:sp>
       <p:cxnSp>
         <p:nvCxnSpPr>
-          <p:cNvPr id="251" name=""/>
+          <p:cNvPr id="333" name=""/>
           <p:cNvCxnSpPr>
             <a:stCxn xmlns:a="http://schemas.openxmlformats.org/drawingml/2006/main" id="40" idx="3"/>
             <a:endCxn xmlns:a="http://schemas.openxmlformats.org/drawingml/2006/main" id="41" idx="1"/>
@@ -4219,7 +4230,7 @@
       </p:cxnSp>
       <p:cxnSp>
         <p:nvCxnSpPr>
-          <p:cNvPr id="252" name=""/>
+          <p:cNvPr id="334" name=""/>
           <p:cNvCxnSpPr>
             <a:stCxn xmlns:a="http://schemas.openxmlformats.org/drawingml/2006/main" id="41" idx="3"/>
             <a:endCxn xmlns:a="http://schemas.openxmlformats.org/drawingml/2006/main" id="42" idx="1"/>
@@ -4517,7 +4528,7 @@
       </p:sp>
       <p:cxnSp>
         <p:nvCxnSpPr>
-          <p:cNvPr id="257" name=""/>
+          <p:cNvPr id="339" name=""/>
           <p:cNvCxnSpPr>
             <a:stCxn xmlns:a="http://schemas.openxmlformats.org/drawingml/2006/main" id="45" idx="3"/>
             <a:endCxn xmlns:a="http://schemas.openxmlformats.org/drawingml/2006/main" id="46" idx="1"/>
@@ -4543,7 +4554,7 @@
       </p:cxnSp>
       <p:cxnSp>
         <p:nvCxnSpPr>
-          <p:cNvPr id="258" name=""/>
+          <p:cNvPr id="340" name=""/>
           <p:cNvCxnSpPr>
             <a:stCxn xmlns:a="http://schemas.openxmlformats.org/drawingml/2006/main" id="46" idx="3"/>
             <a:endCxn xmlns:a="http://schemas.openxmlformats.org/drawingml/2006/main" id="47" idx="1"/>
@@ -4569,7 +4580,7 @@
       </p:cxnSp>
       <p:cxnSp>
         <p:nvCxnSpPr>
-          <p:cNvPr id="259" name=""/>
+          <p:cNvPr id="341" name=""/>
           <p:cNvCxnSpPr>
             <a:stCxn xmlns:a="http://schemas.openxmlformats.org/drawingml/2006/main" id="47" idx="3"/>
             <a:endCxn xmlns:a="http://schemas.openxmlformats.org/drawingml/2006/main" id="48" idx="1"/>
@@ -4805,14 +4816,14 @@
       </p:sp>
       <p:pic>
         <p:nvPicPr>
-          <p:cNvPr id="263" name=""/>
+          <p:cNvPr id="345" name=""/>
           <p:cNvPicPr>
             <a:picLocks xmlns:a="http://schemas.openxmlformats.org/drawingml/2006/main" noChangeAspect="1"/>
           </p:cNvPicPr>
           <p:nvPr/>
         </p:nvPicPr>
         <p:blipFill>
-          <a:blip xmlns:r="http://schemas.openxmlformats.org/officeDocument/2006/relationships" xmlns:a="http://schemas.openxmlformats.org/drawingml/2006/main" r:embed="R88342b52dc1543df"/>
+          <a:blip xmlns:r="http://schemas.openxmlformats.org/officeDocument/2006/relationships" xmlns:a="http://schemas.openxmlformats.org/drawingml/2006/main" r:embed="Ra324163ed0584a31"/>
           <a:stretch xmlns:a="http://schemas.openxmlformats.org/drawingml/2006/main"/>
         </p:blipFill>
         <p:spPr>
@@ -4827,14 +4838,14 @@
       </p:pic>
       <p:pic>
         <p:nvPicPr>
-          <p:cNvPr id="264" name=""/>
+          <p:cNvPr id="346" name=""/>
           <p:cNvPicPr>
             <a:picLocks xmlns:a="http://schemas.openxmlformats.org/drawingml/2006/main" noChangeAspect="1"/>
           </p:cNvPicPr>
           <p:nvPr/>
         </p:nvPicPr>
         <p:blipFill>
-          <a:blip xmlns:r="http://schemas.openxmlformats.org/officeDocument/2006/relationships" xmlns:a="http://schemas.openxmlformats.org/drawingml/2006/main" r:embed="R81ba2f99242f4b13"/>
+          <a:blip xmlns:r="http://schemas.openxmlformats.org/officeDocument/2006/relationships" xmlns:a="http://schemas.openxmlformats.org/drawingml/2006/main" r:embed="R96c666b76e694a2a"/>
           <a:stretch xmlns:a="http://schemas.openxmlformats.org/drawingml/2006/main"/>
         </p:blipFill>
         <p:spPr>

</xml_diff>

<commit_message>
Publish final AIRI poster access
</commit_message>
<xml_diff>
--- a/poster/Lapin_Vladislav_DoRA_AIRI_2026.pptx
+++ b/poster/Lapin_Vladislav_DoRA_AIRI_2026.pptx
@@ -2,13 +2,13 @@
 <file path=ppt/presentation.xml><?xml version="1.0" encoding="utf-8"?>
 <p:presentation xmlns:p="http://schemas.openxmlformats.org/presentationml/2006/main">
   <p:sldMasterIdLst>
-    <p:sldMasterId xmlns:r="http://schemas.openxmlformats.org/officeDocument/2006/relationships" id="2147483648" r:id="R41496daa97864a20"/>
+    <p:sldMasterId xmlns:r="http://schemas.openxmlformats.org/officeDocument/2006/relationships" id="2147483648" r:id="R6c3fc15fe4ea4f59"/>
   </p:sldMasterIdLst>
   <p:notesMasterIdLst>
-    <p:notesMasterId xmlns:r="http://schemas.openxmlformats.org/officeDocument/2006/relationships" r:id="R91fb8d0b580148f0"/>
+    <p:notesMasterId xmlns:r="http://schemas.openxmlformats.org/officeDocument/2006/relationships" r:id="R951ec83a9f894661"/>
   </p:notesMasterIdLst>
   <p:sldIdLst>
-    <p:sldId xmlns:r="http://schemas.openxmlformats.org/officeDocument/2006/relationships" id="256" r:id="Rdc7637082647466c"/>
+    <p:sldId xmlns:r="http://schemas.openxmlformats.org/officeDocument/2006/relationships" id="256" r:id="R191dabbd21654ff7"/>
   </p:sldIdLst>
   <p:sldSz cx="21383625" cy="30275213"/>
   <p:notesSz cx="6858000" cy="9144000"/>
@@ -590,7 +590,7 @@
           <p:nvPr/>
         </p:nvPicPr>
         <p:blipFill>
-          <a:blip xmlns:r="http://schemas.openxmlformats.org/officeDocument/2006/relationships" xmlns:a="http://schemas.openxmlformats.org/drawingml/2006/main" r:embed="R926c640bdf9046c0"/>
+          <a:blip xmlns:r="http://schemas.openxmlformats.org/officeDocument/2006/relationships" xmlns:a="http://schemas.openxmlformats.org/drawingml/2006/main" r:embed="R57410abcf9234d00"/>
           <a:stretch xmlns:a="http://schemas.openxmlformats.org/drawingml/2006/main">
             <a:fillRect l="0" t="0" r="0" b="0"/>
           </a:stretch>
@@ -614,7 +614,7 @@
           <p:nvPr/>
         </p:nvPicPr>
         <p:blipFill>
-          <a:blip xmlns:r="http://schemas.openxmlformats.org/officeDocument/2006/relationships" xmlns:a="http://schemas.openxmlformats.org/drawingml/2006/main" r:embed="Rcf630ab0e8fa4864"/>
+          <a:blip xmlns:r="http://schemas.openxmlformats.org/officeDocument/2006/relationships" xmlns:a="http://schemas.openxmlformats.org/drawingml/2006/main" r:embed="Rc55725b04b344b4c"/>
           <a:stretch xmlns:a="http://schemas.openxmlformats.org/drawingml/2006/main">
             <a:fillRect l="0" t="0" r="0" b="0"/>
           </a:stretch>
@@ -684,7 +684,7 @@
           <p:nvPr/>
         </p:nvPicPr>
         <p:blipFill>
-          <a:blip xmlns:r="http://schemas.openxmlformats.org/officeDocument/2006/relationships" xmlns:a="http://schemas.openxmlformats.org/drawingml/2006/main" r:embed="Rc104d6f9bfbc4bc6"/>
+          <a:blip xmlns:r="http://schemas.openxmlformats.org/officeDocument/2006/relationships" xmlns:a="http://schemas.openxmlformats.org/drawingml/2006/main" r:embed="Ra0e6a2f3fedc4d1a"/>
           <a:stretch xmlns:a="http://schemas.openxmlformats.org/drawingml/2006/main">
             <a:fillRect l="0" t="0" r="0" b="0"/>
           </a:stretch>
@@ -708,7 +708,7 @@
           <p:nvPr/>
         </p:nvPicPr>
         <p:blipFill>
-          <a:blip xmlns:r="http://schemas.openxmlformats.org/officeDocument/2006/relationships" xmlns:a="http://schemas.openxmlformats.org/drawingml/2006/main" r:embed="R333c383b30d34ff3"/>
+          <a:blip xmlns:r="http://schemas.openxmlformats.org/officeDocument/2006/relationships" xmlns:a="http://schemas.openxmlformats.org/drawingml/2006/main" r:embed="R2c65e64f5cee4f6c"/>
           <a:stretch xmlns:a="http://schemas.openxmlformats.org/drawingml/2006/main">
             <a:fillRect l="0" t="0" r="0" b="0"/>
           </a:stretch>
@@ -875,7 +875,7 @@
   </p:cSld>
   <p:clrMap bg1="lt1" tx1="dk1" bg2="lt2" tx2="dk2" accent1="accent1" accent2="accent2" accent3="accent3" accent4="accent4" accent5="accent5" accent6="accent6" hlink="hlink" folHlink="folHlink"/>
   <p:sldLayoutIdLst>
-    <p:sldLayoutId xmlns:r="http://schemas.openxmlformats.org/officeDocument/2006/relationships" id="2147483649" r:id="Rd0399522f3fc4ba0"/>
+    <p:sldLayoutId xmlns:r="http://schemas.openxmlformats.org/officeDocument/2006/relationships" id="2147483649" r:id="Rdab5a047215e461c"/>
   </p:sldLayoutIdLst>
   <p:txStyles>
     <p:titleStyle>
@@ -3515,7 +3515,7 @@
                 <a:ea typeface="Arial"/>
                 <a:cs typeface="Arial"/>
               </a:rPr>
-              <a:t>Code, raw results, notebook, and report → private review link; access available on request.</a:t>
+              <a:t>Code, raw results, notebook, and report → public GitHub repository.</a:t>
             </a:r>
           </a:p>
         </p:txBody>
@@ -3851,9 +3851,9 @@
                 <a:latin typeface="Arial"/>
                 <a:ea typeface="Arial"/>
                 <a:cs typeface="Arial"/>
-                <a:hlinkClick xmlns:r="http://schemas.openxmlformats.org/officeDocument/2006/relationships" r:id="R2b7152ec2ffb4795"/>
-              </a:rPr>
-              <a:t>PRIVATE REVIEW LINK</a:t>
+                <a:hlinkClick xmlns:r="http://schemas.openxmlformats.org/officeDocument/2006/relationships" r:id="R18da06e1c64b4d42"/>
+              </a:rPr>
+              <a:t>CODE + DATA</a:t>
             </a:r>
           </a:p>
         </p:txBody>
@@ -4204,7 +4204,7 @@
       </p:sp>
       <p:cxnSp>
         <p:nvCxnSpPr>
-          <p:cNvPr id="333" name=""/>
+          <p:cNvPr id="415" name=""/>
           <p:cNvCxnSpPr>
             <a:stCxn xmlns:a="http://schemas.openxmlformats.org/drawingml/2006/main" id="40" idx="3"/>
             <a:endCxn xmlns:a="http://schemas.openxmlformats.org/drawingml/2006/main" id="41" idx="1"/>
@@ -4230,7 +4230,7 @@
       </p:cxnSp>
       <p:cxnSp>
         <p:nvCxnSpPr>
-          <p:cNvPr id="334" name=""/>
+          <p:cNvPr id="416" name=""/>
           <p:cNvCxnSpPr>
             <a:stCxn xmlns:a="http://schemas.openxmlformats.org/drawingml/2006/main" id="41" idx="3"/>
             <a:endCxn xmlns:a="http://schemas.openxmlformats.org/drawingml/2006/main" id="42" idx="1"/>
@@ -4528,7 +4528,7 @@
       </p:sp>
       <p:cxnSp>
         <p:nvCxnSpPr>
-          <p:cNvPr id="339" name=""/>
+          <p:cNvPr id="421" name=""/>
           <p:cNvCxnSpPr>
             <a:stCxn xmlns:a="http://schemas.openxmlformats.org/drawingml/2006/main" id="45" idx="3"/>
             <a:endCxn xmlns:a="http://schemas.openxmlformats.org/drawingml/2006/main" id="46" idx="1"/>
@@ -4554,7 +4554,7 @@
       </p:cxnSp>
       <p:cxnSp>
         <p:nvCxnSpPr>
-          <p:cNvPr id="340" name=""/>
+          <p:cNvPr id="422" name=""/>
           <p:cNvCxnSpPr>
             <a:stCxn xmlns:a="http://schemas.openxmlformats.org/drawingml/2006/main" id="46" idx="3"/>
             <a:endCxn xmlns:a="http://schemas.openxmlformats.org/drawingml/2006/main" id="47" idx="1"/>
@@ -4580,7 +4580,7 @@
       </p:cxnSp>
       <p:cxnSp>
         <p:nvCxnSpPr>
-          <p:cNvPr id="341" name=""/>
+          <p:cNvPr id="423" name=""/>
           <p:cNvCxnSpPr>
             <a:stCxn xmlns:a="http://schemas.openxmlformats.org/drawingml/2006/main" id="47" idx="3"/>
             <a:endCxn xmlns:a="http://schemas.openxmlformats.org/drawingml/2006/main" id="48" idx="1"/>
@@ -4816,14 +4816,14 @@
       </p:sp>
       <p:pic>
         <p:nvPicPr>
-          <p:cNvPr id="345" name=""/>
+          <p:cNvPr id="427" name=""/>
           <p:cNvPicPr>
             <a:picLocks xmlns:a="http://schemas.openxmlformats.org/drawingml/2006/main" noChangeAspect="1"/>
           </p:cNvPicPr>
           <p:nvPr/>
         </p:nvPicPr>
         <p:blipFill>
-          <a:blip xmlns:r="http://schemas.openxmlformats.org/officeDocument/2006/relationships" xmlns:a="http://schemas.openxmlformats.org/drawingml/2006/main" r:embed="Ra324163ed0584a31"/>
+          <a:blip xmlns:r="http://schemas.openxmlformats.org/officeDocument/2006/relationships" xmlns:a="http://schemas.openxmlformats.org/drawingml/2006/main" r:embed="R4e6405af2fc94ce2"/>
           <a:stretch xmlns:a="http://schemas.openxmlformats.org/drawingml/2006/main"/>
         </p:blipFill>
         <p:spPr>
@@ -4838,14 +4838,14 @@
       </p:pic>
       <p:pic>
         <p:nvPicPr>
-          <p:cNvPr id="346" name=""/>
+          <p:cNvPr id="428" name=""/>
           <p:cNvPicPr>
             <a:picLocks xmlns:a="http://schemas.openxmlformats.org/drawingml/2006/main" noChangeAspect="1"/>
           </p:cNvPicPr>
           <p:nvPr/>
         </p:nvPicPr>
         <p:blipFill>
-          <a:blip xmlns:r="http://schemas.openxmlformats.org/officeDocument/2006/relationships" xmlns:a="http://schemas.openxmlformats.org/drawingml/2006/main" r:embed="R96c666b76e694a2a"/>
+          <a:blip xmlns:r="http://schemas.openxmlformats.org/officeDocument/2006/relationships" xmlns:a="http://schemas.openxmlformats.org/drawingml/2006/main" r:embed="R4107f0ecd0d041a5"/>
           <a:stretch xmlns:a="http://schemas.openxmlformats.org/drawingml/2006/main"/>
         </p:blipFill>
         <p:spPr>

</xml_diff>

<commit_message>
Complete and publish held-seed DoRA study for AIRI 2026
Finalize the protocol-frozen DoRA research package, reproducible evidence, AIRI poster, public QR access, and defense materials.
</commit_message>
<xml_diff>
--- a/poster/Lapin_Vladislav_DoRA_AIRI_2026.pptx
+++ b/poster/Lapin_Vladislav_DoRA_AIRI_2026.pptx
@@ -2,13 +2,13 @@
 <file path=ppt/presentation.xml><?xml version="1.0" encoding="utf-8"?>
 <p:presentation xmlns:p="http://schemas.openxmlformats.org/presentationml/2006/main">
   <p:sldMasterIdLst>
-    <p:sldMasterId xmlns:r="http://schemas.openxmlformats.org/officeDocument/2006/relationships" id="2147483648" r:id="R91ee16d8a1814b64"/>
+    <p:sldMasterId xmlns:r="http://schemas.openxmlformats.org/officeDocument/2006/relationships" id="2147483648" r:id="R6c3fc15fe4ea4f59"/>
   </p:sldMasterIdLst>
   <p:notesMasterIdLst>
-    <p:notesMasterId xmlns:r="http://schemas.openxmlformats.org/officeDocument/2006/relationships" r:id="R3b107342d5ea400c"/>
+    <p:notesMasterId xmlns:r="http://schemas.openxmlformats.org/officeDocument/2006/relationships" r:id="R951ec83a9f894661"/>
   </p:notesMasterIdLst>
   <p:sldIdLst>
-    <p:sldId xmlns:r="http://schemas.openxmlformats.org/officeDocument/2006/relationships" id="256" r:id="Rf10289a5fba04b4a"/>
+    <p:sldId xmlns:r="http://schemas.openxmlformats.org/officeDocument/2006/relationships" id="256" r:id="R191dabbd21654ff7"/>
   </p:sldIdLst>
   <p:sldSz cx="21383625" cy="30275213"/>
   <p:notesSz cx="6858000" cy="9144000"/>
@@ -590,7 +590,7 @@
           <p:nvPr/>
         </p:nvPicPr>
         <p:blipFill>
-          <a:blip xmlns:r="http://schemas.openxmlformats.org/officeDocument/2006/relationships" xmlns:a="http://schemas.openxmlformats.org/drawingml/2006/main" r:embed="Ra301741397e94bfa"/>
+          <a:blip xmlns:r="http://schemas.openxmlformats.org/officeDocument/2006/relationships" xmlns:a="http://schemas.openxmlformats.org/drawingml/2006/main" r:embed="R57410abcf9234d00"/>
           <a:stretch xmlns:a="http://schemas.openxmlformats.org/drawingml/2006/main">
             <a:fillRect l="0" t="0" r="0" b="0"/>
           </a:stretch>
@@ -614,7 +614,7 @@
           <p:nvPr/>
         </p:nvPicPr>
         <p:blipFill>
-          <a:blip xmlns:r="http://schemas.openxmlformats.org/officeDocument/2006/relationships" xmlns:a="http://schemas.openxmlformats.org/drawingml/2006/main" r:embed="R8e73e9fb4a964b77"/>
+          <a:blip xmlns:r="http://schemas.openxmlformats.org/officeDocument/2006/relationships" xmlns:a="http://schemas.openxmlformats.org/drawingml/2006/main" r:embed="Rc55725b04b344b4c"/>
           <a:stretch xmlns:a="http://schemas.openxmlformats.org/drawingml/2006/main">
             <a:fillRect l="0" t="0" r="0" b="0"/>
           </a:stretch>
@@ -684,7 +684,7 @@
           <p:nvPr/>
         </p:nvPicPr>
         <p:blipFill>
-          <a:blip xmlns:r="http://schemas.openxmlformats.org/officeDocument/2006/relationships" xmlns:a="http://schemas.openxmlformats.org/drawingml/2006/main" r:embed="R0eb19099dd294f0e"/>
+          <a:blip xmlns:r="http://schemas.openxmlformats.org/officeDocument/2006/relationships" xmlns:a="http://schemas.openxmlformats.org/drawingml/2006/main" r:embed="Ra0e6a2f3fedc4d1a"/>
           <a:stretch xmlns:a="http://schemas.openxmlformats.org/drawingml/2006/main">
             <a:fillRect l="0" t="0" r="0" b="0"/>
           </a:stretch>
@@ -708,7 +708,7 @@
           <p:nvPr/>
         </p:nvPicPr>
         <p:blipFill>
-          <a:blip xmlns:r="http://schemas.openxmlformats.org/officeDocument/2006/relationships" xmlns:a="http://schemas.openxmlformats.org/drawingml/2006/main" r:embed="R2d6388a814424445"/>
+          <a:blip xmlns:r="http://schemas.openxmlformats.org/officeDocument/2006/relationships" xmlns:a="http://schemas.openxmlformats.org/drawingml/2006/main" r:embed="R2c65e64f5cee4f6c"/>
           <a:stretch xmlns:a="http://schemas.openxmlformats.org/drawingml/2006/main">
             <a:fillRect l="0" t="0" r="0" b="0"/>
           </a:stretch>
@@ -875,7 +875,7 @@
   </p:cSld>
   <p:clrMap bg1="lt1" tx1="dk1" bg2="lt2" tx2="dk2" accent1="accent1" accent2="accent2" accent3="accent3" accent4="accent4" accent5="accent5" accent6="accent6" hlink="hlink" folHlink="folHlink"/>
   <p:sldLayoutIdLst>
-    <p:sldLayoutId xmlns:r="http://schemas.openxmlformats.org/officeDocument/2006/relationships" id="2147483649" r:id="Rbb3d70efb3734051"/>
+    <p:sldLayoutId xmlns:r="http://schemas.openxmlformats.org/officeDocument/2006/relationships" id="2147483649" r:id="Rdab5a047215e461c"/>
   </p:sldLayoutIdLst>
   <p:txStyles>
     <p:titleStyle>
@@ -1435,24 +1435,24 @@
         </p:nvSpPr>
         <p:spPr>
           <a:xfrm xmlns:a="http://schemas.openxmlformats.org/drawingml/2006/main">
-            <a:off x="1511812" y="2430030"/>
-            <a:ext cx="18360000" cy="1246495"/>
+            <a:off x="1511808" y="2133600"/>
+            <a:ext cx="18360009" cy="1695450"/>
           </a:xfrm>
         </p:spPr>
         <p:txBody>
           <a:bodyPr xmlns:a="http://schemas.openxmlformats.org/drawingml/2006/main" wrap="square" lIns="0" tIns="0" rIns="0" bIns="0" anchor="ctr">
-            <a:normAutofit fontScale="100000"/>
+            <a:noAutofit/>
           </a:bodyPr>
           <a:lstStyle xmlns:a="http://schemas.openxmlformats.org/drawingml/2006/main"/>
           <a:p xmlns:a="http://schemas.openxmlformats.org/drawingml/2006/main">
-            <a:pPr algn="l">
-              <a:lnSpc>
-                <a:spcPct val="92000"/>
-              </a:lnSpc>
-              <a:buNone/>
-              <a:defRPr sz="5400" b="0">
-                <a:solidFill>
-                  <a:srgbClr val="111111"/>
+            <a:pPr algn="ctr">
+              <a:lnSpc>
+                <a:spcPct val="94000"/>
+              </a:lnSpc>
+              <a:buNone/>
+              <a:defRPr sz="4950" b="0">
+                <a:solidFill>
+                  <a:srgbClr val="101820"/>
                 </a:solidFill>
                 <a:latin typeface="Arial"/>
                 <a:ea typeface="Arial"/>
@@ -1460,15 +1460,42 @@
               </a:defRPr>
             </a:pPr>
             <a:r>
-              <a:rPr sz="5400" b="0">
-                <a:solidFill>
-                  <a:srgbClr val="111111"/>
-                </a:solidFill>
-                <a:latin typeface="Arial"/>
-                <a:ea typeface="Arial"/>
-                <a:cs typeface="Arial"/>
-              </a:rPr>
-              <a:t>DoRA vs LoRA: когда декомпозиция весов помогает?</a:t>
+              <a:rPr sz="4950" b="0">
+                <a:solidFill>
+                  <a:srgbClr val="101820"/>
+                </a:solidFill>
+                <a:latin typeface="Arial"/>
+                <a:ea typeface="Arial"/>
+                <a:cs typeface="Arial"/>
+              </a:rPr>
+              <a:t>When does DoRA help?</a:t>
+            </a:r>
+          </a:p>
+          <a:p xmlns:a="http://schemas.openxmlformats.org/drawingml/2006/main">
+            <a:pPr algn="ctr">
+              <a:lnSpc>
+                <a:spcPct val="94000"/>
+              </a:lnSpc>
+              <a:buNone/>
+              <a:defRPr sz="4950" b="0">
+                <a:solidFill>
+                  <a:srgbClr val="101820"/>
+                </a:solidFill>
+                <a:latin typeface="Arial"/>
+                <a:ea typeface="Arial"/>
+                <a:cs typeface="Arial"/>
+              </a:defRPr>
+            </a:pPr>
+            <a:r>
+              <a:rPr sz="4950" b="0">
+                <a:solidFill>
+                  <a:srgbClr val="101820"/>
+                </a:solidFill>
+                <a:latin typeface="Arial"/>
+                <a:ea typeface="Arial"/>
+                <a:cs typeface="Arial"/>
+              </a:rPr>
+              <a:t>Geometry, budgets, and held-seed few-shot adaptation</a:t>
             </a:r>
           </a:p>
         </p:txBody>
@@ -1489,8 +1516,8 @@
         </p:nvSpPr>
         <p:spPr>
           <a:xfrm xmlns:a="http://schemas.openxmlformats.org/drawingml/2006/main">
-            <a:off x="4594660" y="4258828"/>
-            <a:ext cx="12194304" cy="497434"/>
+            <a:off x="3642170" y="4171950"/>
+            <a:ext cx="14099286" cy="514350"/>
           </a:xfrm>
           <a:prstGeom xmlns:a="http://schemas.openxmlformats.org/drawingml/2006/main" prst="rect">
             <a:avLst/>
@@ -1498,7 +1525,7 @@
         </p:spPr>
         <p:txBody>
           <a:bodyPr xmlns:a="http://schemas.openxmlformats.org/drawingml/2006/main" vert="horz" wrap="square" lIns="0" tIns="0" rIns="0" bIns="0" anchor="ctr">
-            <a:normAutofit fontScale="100000"/>
+            <a:noAutofit/>
           </a:bodyPr>
           <a:lstStyle xmlns:a="http://schemas.openxmlformats.org/drawingml/2006/main">
             <a:lvl1pPr algn="ctr">
@@ -1522,9 +1549,9 @@
                 <a:spcPct val="102000"/>
               </a:lnSpc>
               <a:buNone/>
-              <a:defRPr sz="3200" b="0">
-                <a:solidFill>
-                  <a:srgbClr val="5B6268"/>
+              <a:defRPr sz="2550" b="0">
+                <a:solidFill>
+                  <a:srgbClr val="5F6870"/>
                 </a:solidFill>
                 <a:latin typeface="Arial"/>
                 <a:ea typeface="Arial"/>
@@ -1532,15 +1559,15 @@
               </a:defRPr>
             </a:pPr>
             <a:r>
-              <a:rPr sz="3200" b="0">
-                <a:solidFill>
-                  <a:srgbClr val="5B6268"/>
-                </a:solidFill>
-                <a:latin typeface="Arial"/>
-                <a:ea typeface="Arial"/>
-                <a:cs typeface="Arial"/>
-              </a:rPr>
-              <a:t>Владислав Лапин · МФТИ ФПМИ / AI360</a:t>
+              <a:rPr sz="2550" b="0">
+                <a:solidFill>
+                  <a:srgbClr val="5F6870"/>
+                </a:solidFill>
+                <a:latin typeface="Arial"/>
+                <a:ea typeface="Arial"/>
+                <a:cs typeface="Arial"/>
+              </a:rPr>
+              <a:t>Vladislav Lapin  ·  MIPT FPMI / AI360  ·  AIRI Summer School 2026</a:t>
             </a:r>
           </a:p>
         </p:txBody>
@@ -1561,8 +1588,8 @@
         </p:nvSpPr>
         <p:spPr>
           <a:xfrm xmlns:a="http://schemas.openxmlformats.org/drawingml/2006/main">
-            <a:off x="11540382" y="10942257"/>
-            <a:ext cx="8328874" cy="1477328"/>
+            <a:off x="11540395" y="7029450"/>
+            <a:ext cx="8328851" cy="685800"/>
           </a:xfrm>
           <a:prstGeom xmlns:a="http://schemas.openxmlformats.org/drawingml/2006/main" prst="rect">
             <a:avLst/>
@@ -1570,7 +1597,7 @@
         </p:spPr>
         <p:txBody>
           <a:bodyPr xmlns:a="http://schemas.openxmlformats.org/drawingml/2006/main" vert="horz" wrap="square" lIns="0" tIns="0" rIns="0" bIns="0" anchor="ctr">
-            <a:normAutofit fontScale="100000"/>
+            <a:noAutofit/>
           </a:bodyPr>
           <a:lstStyle xmlns:a="http://schemas.openxmlformats.org/drawingml/2006/main">
             <a:lvl1pPr algn="ctr">
@@ -1594,9 +1621,9 @@
                 <a:spcPct val="94000"/>
               </a:lnSpc>
               <a:buNone/>
-              <a:defRPr sz="4800" b="0">
-                <a:solidFill>
-                  <a:srgbClr val="111111"/>
+              <a:defRPr sz="3750" b="1">
+                <a:solidFill>
+                  <a:srgbClr val="008A80"/>
                 </a:solidFill>
                 <a:latin typeface="Arial"/>
                 <a:ea typeface="Arial"/>
@@ -1604,15 +1631,15 @@
               </a:defRPr>
             </a:pPr>
             <a:r>
-              <a:rPr sz="4800" b="0">
-                <a:solidFill>
-                  <a:srgbClr val="111111"/>
-                </a:solidFill>
-                <a:latin typeface="Arial"/>
-                <a:ea typeface="Arial"/>
-                <a:cs typeface="Arial"/>
-              </a:rPr>
-              <a:t>Главный результат</a:t>
+              <a:rPr sz="3750" b="1">
+                <a:solidFill>
+                  <a:srgbClr val="008A80"/>
+                </a:solidFill>
+                <a:latin typeface="Arial"/>
+                <a:ea typeface="Arial"/>
+                <a:cs typeface="Arial"/>
+              </a:rPr>
+              <a:t>+1.06 pp MLP  ·  +0.92 pp CNN</a:t>
             </a:r>
           </a:p>
         </p:txBody>
@@ -1693,8 +1720,8 @@
         </p:nvSpPr>
         <p:spPr>
           <a:xfrm xmlns:a="http://schemas.openxmlformats.org/drawingml/2006/main">
-            <a:off x="11542938" y="12833810"/>
-            <a:ext cx="8328874" cy="32098107"/>
+            <a:off x="11542966" y="7848600"/>
+            <a:ext cx="8328851" cy="1190625"/>
           </a:xfrm>
           <a:prstGeom xmlns:a="http://schemas.openxmlformats.org/drawingml/2006/main" prst="rect">
             <a:avLst/>
@@ -1702,7 +1729,7 @@
         </p:spPr>
         <p:txBody>
           <a:bodyPr xmlns:a="http://schemas.openxmlformats.org/drawingml/2006/main" vert="horz" wrap="square" lIns="0" tIns="0" rIns="0" bIns="0" anchor="t">
-            <a:normAutofit fontScale="100000"/>
+            <a:noAutofit/>
           </a:bodyPr>
           <a:lstStyle xmlns:a="http://schemas.openxmlformats.org/drawingml/2006/main">
             <a:lvl1pPr algn="ctr">
@@ -1723,15 +1750,15 @@
           <a:p xmlns:a="http://schemas.openxmlformats.org/drawingml/2006/main">
             <a:pPr marL="24" indent="-14" algn="l">
               <a:lnSpc>
-                <a:spcPct val="96000"/>
+                <a:spcPct val="106000"/>
               </a:lnSpc>
               <a:spcAft>
                 <a:spcPts val="7"/>
               </a:spcAft>
               <a:buNone/>
-              <a:defRPr sz="2288" b="0">
-                <a:solidFill>
-                  <a:srgbClr val="111111"/>
+              <a:defRPr sz="2025" b="0">
+                <a:solidFill>
+                  <a:srgbClr val="101820"/>
                 </a:solidFill>
                 <a:latin typeface="Arial"/>
                 <a:ea typeface="Arial"/>
@@ -1739,108 +1766,70 @@
               </a:defRPr>
             </a:pPr>
             <a:r>
-              <a:rPr sz="2288" b="0">
-                <a:solidFill>
-                  <a:srgbClr val="111111"/>
-                </a:solidFill>
-                <a:latin typeface="Arial"/>
-                <a:ea typeface="Arial"/>
-                <a:cs typeface="Arial"/>
-              </a:rPr>
-              <a:t>Синтетика, r=4, γ=.8: </a:t>
-            </a:r>
-            <a:r>
-              <a:rPr sz="2288" b="0">
-                <a:solidFill>
-                  <a:srgbClr val="111111"/>
-                </a:solidFill>
-                <a:latin typeface="Arial"/>
-                <a:ea typeface="Arial"/>
-                <a:cs typeface="Arial"/>
-              </a:rPr>
-              <a:t>LoRA oracle error = 0.2923; DoRA ≤ 1.5×10⁻⁷. При γ=0 обе ошибки ≈0.</a:t>
-            </a:r>
-          </a:p>
-          <a:p xmlns:a="http://schemas.openxmlformats.org/drawingml/2006/main">
-            <a:pPr marL="24" indent="-14" algn="l">
-              <a:lnSpc>
-                <a:spcPct val="96000"/>
-              </a:lnSpc>
-              <a:spcAft>
-                <a:spcPts val="7"/>
-              </a:spcAft>
-              <a:buNone/>
-              <a:defRPr sz="2288" b="0">
-                <a:solidFill>
-                  <a:srgbClr val="111111"/>
-                </a:solidFill>
-                <a:latin typeface="Arial"/>
-                <a:ea typeface="Arial"/>
-                <a:cs typeface="Arial"/>
-              </a:defRPr>
-            </a:pPr>
-            <a:r>
-              <a:rPr sz="2288" b="0">
-                <a:solidFill>
-                  <a:srgbClr val="111111"/>
-                </a:solidFill>
-                <a:latin typeface="Arial"/>
-                <a:ea typeface="Arial"/>
-                <a:cs typeface="Arial"/>
-              </a:rPr>
-              <a:t>Реальные shifts, r=4: </a:t>
-            </a:r>
-            <a:r>
-              <a:rPr sz="2288" b="0">
-                <a:solidFill>
-                  <a:srgbClr val="111111"/>
-                </a:solidFill>
-                <a:latin typeface="Arial"/>
-                <a:ea typeface="Arial"/>
-                <a:cs typeface="Arial"/>
-              </a:rPr>
-              <a:t>DoRA−LoRA = +0.33 pp contrast, +0.67 pp rotation, +1.39 pp mixed; CI &gt; 0 для rotation и mixed.</a:t>
-            </a:r>
-          </a:p>
-          <a:p xmlns:a="http://schemas.openxmlformats.org/drawingml/2006/main">
-            <a:pPr marL="24" indent="-14" algn="l">
-              <a:lnSpc>
-                <a:spcPct val="96000"/>
-              </a:lnSpc>
-              <a:spcAft>
-                <a:spcPts val="7"/>
-              </a:spcAft>
-              <a:buNone/>
-              <a:defRPr sz="2288" b="0">
-                <a:solidFill>
-                  <a:srgbClr val="111111"/>
-                </a:solidFill>
-                <a:latin typeface="Arial"/>
-                <a:ea typeface="Arial"/>
-                <a:cs typeface="Arial"/>
-              </a:defRPr>
-            </a:pPr>
-            <a:r>
-              <a:rPr sz="2288" b="0">
-                <a:solidFill>
-                  <a:srgbClr val="111111"/>
-                </a:solidFill>
-                <a:latin typeface="Arial"/>
-                <a:ea typeface="Arial"/>
-                <a:cs typeface="Arial"/>
-              </a:rPr>
-              <a:t>Контрпример: </a:t>
-            </a:r>
-            <a:r>
-              <a:rPr sz="2288" b="0">
-                <a:solidFill>
-                  <a:srgbClr val="111111"/>
-                </a:solidFill>
-                <a:latin typeface="Arial"/>
-                <a:ea typeface="Arial"/>
-                <a:cs typeface="Arial"/>
-              </a:rPr>
-              <a:t>rotation r=8 - LoRA 94.61%, DoRA 94.22%. Универсального превосходства нет.</a:t>
+              <a:rPr sz="2025" b="1">
+                <a:solidFill>
+                  <a:srgbClr val="101820"/>
+                </a:solidFill>
+                <a:latin typeface="Arial"/>
+                <a:ea typeface="Arial"/>
+                <a:cs typeface="Arial"/>
+              </a:rPr>
+              <a:t>15/20</a:t>
+            </a:r>
+            <a:r>
+              <a:rPr sz="2025" b="0">
+                <a:solidFill>
+                  <a:srgbClr val="101820"/>
+                </a:solidFill>
+                <a:latin typeface="Arial"/>
+                <a:ea typeface="Arial"/>
+                <a:cs typeface="Arial"/>
+              </a:rPr>
+              <a:t> MLP pairs and </a:t>
+            </a:r>
+            <a:r>
+              <a:rPr sz="2025" b="1">
+                <a:solidFill>
+                  <a:srgbClr val="101820"/>
+                </a:solidFill>
+                <a:latin typeface="Arial"/>
+                <a:ea typeface="Arial"/>
+                <a:cs typeface="Arial"/>
+              </a:rPr>
+              <a:t>8/10</a:t>
+            </a:r>
+            <a:r>
+              <a:rPr sz="2025" b="0">
+                <a:solidFill>
+                  <a:srgbClr val="101820"/>
+                </a:solidFill>
+                <a:latin typeface="Arial"/>
+                <a:ea typeface="Arial"/>
+                <a:cs typeface="Arial"/>
+              </a:rPr>
+              <a:t> CNN pairs favored DoRA. </a:t>
+            </a:r>
+            <a:r>
+              <a:rPr sz="2025" b="1">
+                <a:solidFill>
+                  <a:srgbClr val="101820"/>
+                </a:solidFill>
+                <a:latin typeface="Arial"/>
+                <a:ea typeface="Arial"/>
+                <a:cs typeface="Arial"/>
+              </a:rPr>
+              <a:t>Holm-adjusted</a:t>
+            </a:r>
+            <a:r>
+              <a:rPr sz="2025" b="0">
+                <a:solidFill>
+                  <a:srgbClr val="101820"/>
+                </a:solidFill>
+                <a:latin typeface="Arial"/>
+                <a:ea typeface="Arial"/>
+                <a:cs typeface="Arial"/>
+              </a:rPr>
+              <a:t> p=.382213 (MLP) / .158955 (CNN): internal fixed-checkpoint evidence, not external replication.</a:t>
             </a:r>
           </a:p>
         </p:txBody>
@@ -1861,16 +1850,16 @@
         </p:nvSpPr>
         <p:spPr>
           <a:xfrm xmlns:a="http://schemas.openxmlformats.org/drawingml/2006/main">
-            <a:off x="11540382" y="20773642"/>
-            <a:ext cx="8328874" cy="310896"/>
+            <a:off x="11540395" y="21878925"/>
+            <a:ext cx="8328851" cy="295275"/>
           </a:xfrm>
           <a:prstGeom xmlns:a="http://schemas.openxmlformats.org/drawingml/2006/main" prst="rect">
             <a:avLst/>
           </a:prstGeom>
         </p:spPr>
         <p:txBody>
-          <a:bodyPr xmlns:a="http://schemas.openxmlformats.org/drawingml/2006/main" vert="horz" wrap="square" lIns="0" tIns="0" rIns="0" bIns="0" anchor="ctr">
-            <a:normAutofit fontScale="100000"/>
+          <a:bodyPr xmlns:a="http://schemas.openxmlformats.org/drawingml/2006/main" vert="horz" wrap="square" lIns="0" tIns="0" rIns="0" bIns="0" anchor="t">
+            <a:noAutofit/>
           </a:bodyPr>
           <a:lstStyle xmlns:a="http://schemas.openxmlformats.org/drawingml/2006/main">
             <a:lvl1pPr algn="ctr">
@@ -1894,9 +1883,9 @@
                 <a:spcPct val="102000"/>
               </a:lnSpc>
               <a:buNone/>
-              <a:defRPr sz="2000" b="0">
-                <a:solidFill>
-                  <a:srgbClr val="5B6268"/>
+              <a:defRPr sz="1500" b="0">
+                <a:solidFill>
+                  <a:srgbClr val="5F6870"/>
                 </a:solidFill>
                 <a:latin typeface="Arial"/>
                 <a:ea typeface="Arial"/>
@@ -1904,15 +1893,15 @@
               </a:defRPr>
             </a:pPr>
             <a:r>
-              <a:rPr sz="2000" b="0">
-                <a:solidFill>
-                  <a:srgbClr val="5B6268"/>
-                </a:solidFill>
-                <a:latin typeface="Arial"/>
-                <a:ea typeface="Arial"/>
-                <a:cs typeface="Arial"/>
-              </a:rPr>
-              <a:t>Рис. 2. Capacity gap и paired test gain; среднее ± 95% CI, 5 seeds.</a:t>
+              <a:rPr sz="1500" b="0">
+                <a:solidFill>
+                  <a:srgbClr val="5F6870"/>
+                </a:solidFill>
+                <a:latin typeface="Arial"/>
+                <a:ea typeface="Arial"/>
+                <a:cs typeface="Arial"/>
+              </a:rPr>
+              <a:t>Figure 2. Held-seed estimate → data regime → capacity / optimization diagnostic.</a:t>
             </a:r>
           </a:p>
         </p:txBody>
@@ -1933,16 +1922,16 @@
         </p:nvSpPr>
         <p:spPr>
           <a:xfrm xmlns:a="http://schemas.openxmlformats.org/drawingml/2006/main">
-            <a:off x="1512323" y="6653687"/>
-            <a:ext cx="8328874" cy="738664"/>
+            <a:off x="1512284" y="6572250"/>
+            <a:ext cx="8328851" cy="590550"/>
           </a:xfrm>
           <a:prstGeom xmlns:a="http://schemas.openxmlformats.org/drawingml/2006/main" prst="rect">
             <a:avLst/>
           </a:prstGeom>
         </p:spPr>
         <p:txBody>
-          <a:bodyPr xmlns:a="http://schemas.openxmlformats.org/drawingml/2006/main" vert="horz" wrap="square" lIns="0" tIns="0" rIns="0" bIns="0" anchor="ctr">
-            <a:normAutofit fontScale="100000"/>
+          <a:bodyPr xmlns:a="http://schemas.openxmlformats.org/drawingml/2006/main" vert="horz" wrap="square" lIns="0" tIns="0" rIns="0" bIns="0" anchor="t">
+            <a:noAutofit/>
           </a:bodyPr>
           <a:lstStyle xmlns:a="http://schemas.openxmlformats.org/drawingml/2006/main">
             <a:lvl1pPr algn="ctr">
@@ -1966,9 +1955,9 @@
                 <a:spcPct val="94000"/>
               </a:lnSpc>
               <a:buNone/>
-              <a:defRPr sz="4800" b="0">
-                <a:solidFill>
-                  <a:srgbClr val="111111"/>
+              <a:defRPr sz="3225" b="0">
+                <a:solidFill>
+                  <a:srgbClr val="101820"/>
                 </a:solidFill>
                 <a:latin typeface="Arial"/>
                 <a:ea typeface="Arial"/>
@@ -1976,15 +1965,15 @@
               </a:defRPr>
             </a:pPr>
             <a:r>
-              <a:rPr sz="4800" b="0">
-                <a:solidFill>
-                  <a:srgbClr val="111111"/>
-                </a:solidFill>
-                <a:latin typeface="Arial"/>
-                <a:ea typeface="Arial"/>
-                <a:cs typeface="Arial"/>
-              </a:rPr>
-              <a:t>Мотивация</a:t>
+              <a:rPr sz="3225" b="0">
+                <a:solidFill>
+                  <a:srgbClr val="101820"/>
+                </a:solidFill>
+                <a:latin typeface="Arial"/>
+                <a:ea typeface="Arial"/>
+                <a:cs typeface="Arial"/>
+              </a:rPr>
+              <a:t>Why separate magnitude from direction?</a:t>
             </a:r>
           </a:p>
         </p:txBody>
@@ -2065,8 +2054,8 @@
         </p:nvSpPr>
         <p:spPr>
           <a:xfrm xmlns:a="http://schemas.openxmlformats.org/drawingml/2006/main">
-            <a:off x="1509767" y="7624916"/>
-            <a:ext cx="8328874" cy="41973627"/>
+            <a:off x="1509808" y="7400925"/>
+            <a:ext cx="8328851" cy="3752850"/>
           </a:xfrm>
           <a:prstGeom xmlns:a="http://schemas.openxmlformats.org/drawingml/2006/main" prst="rect">
             <a:avLst/>
@@ -2074,7 +2063,7 @@
         </p:spPr>
         <p:txBody>
           <a:bodyPr xmlns:a="http://schemas.openxmlformats.org/drawingml/2006/main" vert="horz" wrap="square" lIns="0" tIns="0" rIns="0" bIns="0" anchor="t">
-            <a:normAutofit fontScale="100000"/>
+            <a:noAutofit/>
           </a:bodyPr>
           <a:lstStyle xmlns:a="http://schemas.openxmlformats.org/drawingml/2006/main">
             <a:lvl1pPr algn="ctr">
@@ -2095,15 +2084,15 @@
           <a:p xmlns:a="http://schemas.openxmlformats.org/drawingml/2006/main">
             <a:pPr marL="24" indent="-14" algn="l">
               <a:lnSpc>
-                <a:spcPct val="100000"/>
+                <a:spcPct val="108000"/>
               </a:lnSpc>
               <a:spcAft>
                 <a:spcPts val="7"/>
               </a:spcAft>
               <a:buNone/>
-              <a:defRPr sz="2400" b="0">
-                <a:solidFill>
-                  <a:srgbClr val="111111"/>
+              <a:defRPr sz="2100" b="0">
+                <a:solidFill>
+                  <a:srgbClr val="101820"/>
                 </a:solidFill>
                 <a:latin typeface="Arial"/>
                 <a:ea typeface="Arial"/>
@@ -2111,26 +2100,15 @@
               </a:defRPr>
             </a:pPr>
             <a:r>
-              <a:rPr sz="2400" b="0">
-                <a:solidFill>
-                  <a:srgbClr val="111111"/>
-                </a:solidFill>
-                <a:latin typeface="Arial"/>
-                <a:ea typeface="Arial"/>
-                <a:cs typeface="Arial"/>
-              </a:rPr>
-              <a:t>Full fine-tuning </a:t>
-            </a:r>
-            <a:r>
-              <a:rPr sz="2400" b="0">
-                <a:solidFill>
-                  <a:srgbClr val="111111"/>
-                </a:solidFill>
-                <a:latin typeface="Arial"/>
-                <a:ea typeface="Arial"/>
-                <a:cs typeface="Arial"/>
-              </a:rPr>
-              <a:t>точен, но обновляет все параметры. LoRA дешевле, однако одна low-rank поправка одновременно меняет норму и направление строк W.</a:t>
+              <a:rPr sz="2100" b="0">
+                <a:solidFill>
+                  <a:srgbClr val="101820"/>
+                </a:solidFill>
+                <a:latin typeface="Arial"/>
+                <a:ea typeface="Arial"/>
+                <a:cs typeface="Arial"/>
+              </a:rPr>
+              <a:t>LoRA adds a low-rank update BA, coupling row direction and row norm. DoRA writes W = m ⊙ (W₀ + BA) / ‖W₀ + BA‖₂, so BA controls direction while m controls row scale.</a:t>
             </a:r>
           </a:p>
           <a:p xmlns:a="http://schemas.openxmlformats.org/drawingml/2006/main">
@@ -2160,32 +2138,21 @@
                 <a:ea typeface="Arial"/>
                 <a:cs typeface="Arial"/>
               </a:rPr>
-              <a:t>DoRA </a:t>
-            </a:r>
-            <a:r>
-              <a:rPr sz="2400" b="0">
-                <a:solidFill>
-                  <a:srgbClr val="111111"/>
-                </a:solidFill>
-                <a:latin typeface="Arial"/>
-                <a:ea typeface="Arial"/>
-                <a:cs typeface="Arial"/>
-              </a:rPr>
-              <a:t>задаёт Ŵ = m ⊙ V / ‖V‖₂, где V = W₀ + BA: BA отвечает за направление, m - за масштаб каждой строки.</a:t>
+              <a:t/>
             </a:r>
           </a:p>
           <a:p xmlns:a="http://schemas.openxmlformats.org/drawingml/2006/main">
             <a:pPr marL="24" indent="-14" algn="l">
               <a:lnSpc>
-                <a:spcPct val="100000"/>
+                <a:spcPct val="108000"/>
               </a:lnSpc>
               <a:spcAft>
                 <a:spcPts val="7"/>
               </a:spcAft>
               <a:buNone/>
-              <a:defRPr sz="2400" b="0">
-                <a:solidFill>
-                  <a:srgbClr val="111111"/>
+              <a:defRPr sz="2100" b="0">
+                <a:solidFill>
+                  <a:srgbClr val="101820"/>
                 </a:solidFill>
                 <a:latin typeface="Arial"/>
                 <a:ea typeface="Arial"/>
@@ -2193,26 +2160,26 @@
               </a:defRPr>
             </a:pPr>
             <a:r>
-              <a:rPr sz="2400" b="0">
-                <a:solidFill>
-                  <a:srgbClr val="111111"/>
-                </a:solidFill>
-                <a:latin typeface="Arial"/>
-                <a:ea typeface="Arial"/>
-                <a:cs typeface="Arial"/>
-              </a:rPr>
-              <a:t>Исследовательский вопрос: </a:t>
-            </a:r>
-            <a:r>
-              <a:rPr sz="2400" b="0">
-                <a:solidFill>
-                  <a:srgbClr val="111111"/>
-                </a:solidFill>
-                <a:latin typeface="Arial"/>
-                <a:ea typeface="Arial"/>
-                <a:cs typeface="Arial"/>
-              </a:rPr>
-              <a:t>когда дополнительные magnitude-параметры действительно дают преимущество, а когда LoRA достаточно?</a:t>
+              <a:rPr sz="2100" b="1">
+                <a:solidFill>
+                  <a:srgbClr val="101820"/>
+                </a:solidFill>
+                <a:latin typeface="Arial"/>
+                <a:ea typeface="Arial"/>
+                <a:cs typeface="Arial"/>
+              </a:rPr>
+              <a:t>Research question:</a:t>
+            </a:r>
+            <a:r>
+              <a:rPr sz="2100" b="0">
+                <a:solidFill>
+                  <a:srgbClr val="101820"/>
+                </a:solidFill>
+                <a:latin typeface="Arial"/>
+                <a:ea typeface="Arial"/>
+                <a:cs typeface="Arial"/>
+              </a:rPr>
+              <a:t> does this extra degree of freedom improve target adaptation after fair selection, budget controls, and negative controls?</a:t>
             </a:r>
           </a:p>
         </p:txBody>
@@ -2233,16 +2200,16 @@
         </p:nvSpPr>
         <p:spPr>
           <a:xfrm xmlns:a="http://schemas.openxmlformats.org/drawingml/2006/main">
-            <a:off x="1509767" y="17166206"/>
-            <a:ext cx="8328874" cy="621792"/>
+            <a:off x="1509808" y="17106900"/>
+            <a:ext cx="8328851" cy="419100"/>
           </a:xfrm>
           <a:prstGeom xmlns:a="http://schemas.openxmlformats.org/drawingml/2006/main" prst="rect">
             <a:avLst/>
           </a:prstGeom>
         </p:spPr>
         <p:txBody>
-          <a:bodyPr xmlns:a="http://schemas.openxmlformats.org/drawingml/2006/main" vert="horz" wrap="square" lIns="0" tIns="0" rIns="0" bIns="0" anchor="ctr">
-            <a:normAutofit fontScale="100000"/>
+          <a:bodyPr xmlns:a="http://schemas.openxmlformats.org/drawingml/2006/main" vert="horz" wrap="square" lIns="0" tIns="0" rIns="0" bIns="0" anchor="t">
+            <a:noAutofit/>
           </a:bodyPr>
           <a:lstStyle xmlns:a="http://schemas.openxmlformats.org/drawingml/2006/main">
             <a:lvl1pPr algn="ctr">
@@ -2266,9 +2233,9 @@
                 <a:spcPct val="102000"/>
               </a:lnSpc>
               <a:buNone/>
-              <a:defRPr sz="2000" b="0">
-                <a:solidFill>
-                  <a:srgbClr val="5B6268"/>
+              <a:defRPr sz="1650" b="0">
+                <a:solidFill>
+                  <a:srgbClr val="5F6870"/>
                 </a:solidFill>
                 <a:latin typeface="Arial"/>
                 <a:ea typeface="Arial"/>
@@ -2276,15 +2243,15 @@
               </a:defRPr>
             </a:pPr>
             <a:r>
-              <a:rPr sz="2000" b="0">
-                <a:solidFill>
-                  <a:srgbClr val="5B6268"/>
-                </a:solidFill>
-                <a:latin typeface="Arial"/>
-                <a:ea typeface="Arial"/>
-                <a:cs typeface="Arial"/>
-              </a:rPr>
-              <a:t>Рис. 1. LoRA связывает масштаб и направление; DoRA разделяет их явно.</a:t>
+              <a:rPr sz="1650" b="0">
+                <a:solidFill>
+                  <a:srgbClr val="5F6870"/>
+                </a:solidFill>
+                <a:latin typeface="Arial"/>
+                <a:ea typeface="Arial"/>
+                <a:cs typeface="Arial"/>
+              </a:rPr>
+              <a:t>Figure 1. LoRA couples scale and direction; DoRA models row scale explicitly.</a:t>
             </a:r>
           </a:p>
         </p:txBody>
@@ -2305,16 +2272,16 @@
         </p:nvSpPr>
         <p:spPr>
           <a:xfrm xmlns:a="http://schemas.openxmlformats.org/drawingml/2006/main">
-            <a:off x="1509767" y="18111914"/>
-            <a:ext cx="8328874" cy="738664"/>
+            <a:off x="1509808" y="17859375"/>
+            <a:ext cx="8328851" cy="590550"/>
           </a:xfrm>
           <a:prstGeom xmlns:a="http://schemas.openxmlformats.org/drawingml/2006/main" prst="rect">
             <a:avLst/>
           </a:prstGeom>
         </p:spPr>
         <p:txBody>
-          <a:bodyPr xmlns:a="http://schemas.openxmlformats.org/drawingml/2006/main" vert="horz" wrap="square" lIns="0" tIns="0" rIns="0" bIns="0" anchor="ctr">
-            <a:normAutofit fontScale="100000"/>
+          <a:bodyPr xmlns:a="http://schemas.openxmlformats.org/drawingml/2006/main" vert="horz" wrap="square" lIns="0" tIns="0" rIns="0" bIns="0" anchor="t">
+            <a:noAutofit/>
           </a:bodyPr>
           <a:lstStyle xmlns:a="http://schemas.openxmlformats.org/drawingml/2006/main">
             <a:lvl1pPr algn="ctr">
@@ -2338,9 +2305,9 @@
                 <a:spcPct val="94000"/>
               </a:lnSpc>
               <a:buNone/>
-              <a:defRPr sz="4800" b="0">
-                <a:solidFill>
-                  <a:srgbClr val="111111"/>
+              <a:defRPr sz="3225" b="0">
+                <a:solidFill>
+                  <a:srgbClr val="101820"/>
                 </a:solidFill>
                 <a:latin typeface="Arial"/>
                 <a:ea typeface="Arial"/>
@@ -2348,15 +2315,15 @@
               </a:defRPr>
             </a:pPr>
             <a:r>
-              <a:rPr sz="4800" b="0">
-                <a:solidFill>
-                  <a:srgbClr val="111111"/>
-                </a:solidFill>
-                <a:latin typeface="Arial"/>
-                <a:ea typeface="Arial"/>
-                <a:cs typeface="Arial"/>
-              </a:rPr>
-              <a:t>Гипотезы и метрики</a:t>
+              <a:rPr sz="3225" b="0">
+                <a:solidFill>
+                  <a:srgbClr val="101820"/>
+                </a:solidFill>
+                <a:latin typeface="Arial"/>
+                <a:ea typeface="Arial"/>
+                <a:cs typeface="Arial"/>
+              </a:rPr>
+              <a:t>Frozen protocol before held-seed evaluation</a:t>
             </a:r>
           </a:p>
         </p:txBody>
@@ -2377,8 +2344,8 @@
         </p:nvSpPr>
         <p:spPr>
           <a:xfrm xmlns:a="http://schemas.openxmlformats.org/drawingml/2006/main">
-            <a:off x="1509767" y="19092852"/>
-            <a:ext cx="8328874" cy="39504747"/>
+            <a:off x="1509808" y="18630900"/>
+            <a:ext cx="8328851" cy="3771900"/>
           </a:xfrm>
           <a:prstGeom xmlns:a="http://schemas.openxmlformats.org/drawingml/2006/main" prst="rect">
             <a:avLst/>
@@ -2386,7 +2353,7 @@
         </p:spPr>
         <p:txBody>
           <a:bodyPr xmlns:a="http://schemas.openxmlformats.org/drawingml/2006/main" vert="horz" wrap="square" lIns="0" tIns="0" rIns="0" bIns="0" anchor="t">
-            <a:normAutofit fontScale="100000"/>
+            <a:noAutofit/>
           </a:bodyPr>
           <a:lstStyle xmlns:a="http://schemas.openxmlformats.org/drawingml/2006/main">
             <a:lvl1pPr algn="ctr">
@@ -2407,15 +2374,15 @@
           <a:p xmlns:a="http://schemas.openxmlformats.org/drawingml/2006/main">
             <a:pPr marL="24" indent="-14" algn="l">
               <a:lnSpc>
-                <a:spcPct val="99000"/>
+                <a:spcPct val="106000"/>
               </a:lnSpc>
               <a:spcAft>
                 <a:spcPts val="7"/>
               </a:spcAft>
               <a:buNone/>
-              <a:defRPr sz="2363" b="0">
-                <a:solidFill>
-                  <a:srgbClr val="111111"/>
+              <a:defRPr sz="2025" b="0">
+                <a:solidFill>
+                  <a:srgbClr val="101820"/>
                 </a:solidFill>
                 <a:latin typeface="Arial"/>
                 <a:ea typeface="Arial"/>
@@ -2423,40 +2390,40 @@
               </a:defRPr>
             </a:pPr>
             <a:r>
-              <a:rPr sz="2363" b="0">
-                <a:solidFill>
-                  <a:srgbClr val="111111"/>
-                </a:solidFill>
-                <a:latin typeface="Arial"/>
-                <a:ea typeface="Arial"/>
-                <a:cs typeface="Arial"/>
-              </a:rPr>
-              <a:t>H1 · аддитивный target (γ = 0): </a:t>
-            </a:r>
-            <a:r>
-              <a:rPr sz="2363" b="0">
-                <a:solidFill>
-                  <a:srgbClr val="111111"/>
-                </a:solidFill>
-                <a:latin typeface="Arial"/>
-                <a:ea typeface="Arial"/>
-                <a:cs typeface="Arial"/>
-              </a:rPr>
-              <a:t>при rank ≥ 4 методы должны совпасть.</a:t>
+              <a:rPr sz="2025" b="1">
+                <a:solidFill>
+                  <a:srgbClr val="101820"/>
+                </a:solidFill>
+                <a:latin typeface="Arial"/>
+                <a:ea typeface="Arial"/>
+                <a:cs typeface="Arial"/>
+              </a:rPr>
+              <a:t>Pilot only</a:t>
+            </a:r>
+            <a:r>
+              <a:rPr sz="2025" b="0">
+                <a:solidFill>
+                  <a:srgbClr val="101820"/>
+                </a:solidFill>
+                <a:latin typeface="Arial"/>
+                <a:ea typeface="Arial"/>
+                <a:cs typeface="Arial"/>
+              </a:rPr>
+              <a:t> (validation): learning rate, early stopping, and rank allocation.</a:t>
             </a:r>
           </a:p>
           <a:p xmlns:a="http://schemas.openxmlformats.org/drawingml/2006/main">
             <a:pPr marL="24" indent="-14" algn="l">
               <a:lnSpc>
-                <a:spcPct val="99000"/>
+                <a:spcPct val="106000"/>
               </a:lnSpc>
               <a:spcAft>
                 <a:spcPts val="7"/>
               </a:spcAft>
               <a:buNone/>
-              <a:defRPr sz="2363" b="0">
-                <a:solidFill>
-                  <a:srgbClr val="111111"/>
+              <a:defRPr sz="2025" b="0">
+                <a:solidFill>
+                  <a:srgbClr val="101820"/>
                 </a:solidFill>
                 <a:latin typeface="Arial"/>
                 <a:ea typeface="Arial"/>
@@ -2464,40 +2431,51 @@
               </a:defRPr>
             </a:pPr>
             <a:r>
-              <a:rPr sz="2363" b="0">
-                <a:solidFill>
-                  <a:srgbClr val="111111"/>
-                </a:solidFill>
-                <a:latin typeface="Arial"/>
-                <a:ea typeface="Arial"/>
-                <a:cs typeface="Arial"/>
-              </a:rPr>
-              <a:t>H2 · неоднородный row scaling (γ &gt; 0): </a:t>
-            </a:r>
-            <a:r>
-              <a:rPr sz="2363" b="0">
-                <a:solidFill>
-                  <a:srgbClr val="111111"/>
-                </a:solidFill>
-                <a:latin typeface="Arial"/>
-                <a:ea typeface="Arial"/>
-                <a:cs typeface="Arial"/>
-              </a:rPr>
-              <a:t>разрыв ёмкости LoRA растёт; DoRA сохраняет точность.</a:t>
+              <a:rPr sz="2025" b="1">
+                <a:solidFill>
+                  <a:srgbClr val="101820"/>
+                </a:solidFill>
+                <a:latin typeface="Arial"/>
+                <a:ea typeface="Arial"/>
+                <a:cs typeface="Arial"/>
+              </a:rPr>
+              <a:t>Held-seed:</a:t>
+            </a:r>
+            <a:r>
+              <a:rPr sz="2025" b="0">
+                <a:solidFill>
+                  <a:srgbClr val="101820"/>
+                </a:solidFill>
+                <a:latin typeface="Arial"/>
+                <a:ea typeface="Arial"/>
+                <a:cs typeface="Arial"/>
+              </a:rPr>
+              <a:t> </a:t>
+            </a:r>
+            <a:r>
+              <a:rPr sz="2025" b="0">
+                <a:solidFill>
+                  <a:srgbClr val="101820"/>
+                </a:solidFill>
+                <a:latin typeface="Arial"/>
+                <a:ea typeface="Arial"/>
+                <a:cs typeface="Arial"/>
+              </a:rPr>
+              <a:t>20 MLP + 10 CNN adaptation seeds; one fixed checkpoint each; 3 shifts; Holm families m=9 / 6 / 3 (secondary descriptive).</a:t>
             </a:r>
           </a:p>
           <a:p xmlns:a="http://schemas.openxmlformats.org/drawingml/2006/main">
             <a:pPr marL="24" indent="-14" algn="l">
               <a:lnSpc>
-                <a:spcPct val="99000"/>
+                <a:spcPct val="106000"/>
               </a:lnSpc>
               <a:spcAft>
                 <a:spcPts val="7"/>
               </a:spcAft>
               <a:buNone/>
-              <a:defRPr sz="2363" b="0">
-                <a:solidFill>
-                  <a:srgbClr val="111111"/>
+              <a:defRPr sz="2025" b="0">
+                <a:solidFill>
+                  <a:srgbClr val="101820"/>
                 </a:solidFill>
                 <a:latin typeface="Arial"/>
                 <a:ea typeface="Arial"/>
@@ -2505,40 +2483,62 @@
               </a:defRPr>
             </a:pPr>
             <a:r>
-              <a:rPr sz="2363" b="0">
-                <a:solidFill>
-                  <a:srgbClr val="111111"/>
-                </a:solidFill>
-                <a:latin typeface="Arial"/>
-                <a:ea typeface="Arial"/>
-                <a:cs typeface="Arial"/>
-              </a:rPr>
-              <a:t>H3 · реальные shifts: </a:t>
-            </a:r>
-            <a:r>
-              <a:rPr sz="2363" b="0">
-                <a:solidFill>
-                  <a:srgbClr val="111111"/>
-                </a:solidFill>
-                <a:latin typeface="Arial"/>
-                <a:ea typeface="Arial"/>
-                <a:cs typeface="Arial"/>
-              </a:rPr>
-              <a:t>выигрыш будет умеренным и зависимым от геометрии сдвига.</a:t>
+              <a:rPr sz="2025" b="1">
+                <a:solidFill>
+                  <a:srgbClr val="101820"/>
+                </a:solidFill>
+                <a:latin typeface="Arial"/>
+                <a:ea typeface="Arial"/>
+                <a:cs typeface="Arial"/>
+              </a:rPr>
+              <a:t>Baselines:</a:t>
+            </a:r>
+            <a:r>
+              <a:rPr sz="2025" b="0">
+                <a:solidFill>
+                  <a:srgbClr val="101820"/>
+                </a:solidFill>
+                <a:latin typeface="Arial"/>
+                <a:ea typeface="Arial"/>
+                <a:cs typeface="Arial"/>
+              </a:rPr>
+              <a:t> frozen, magnitude-only, LoRA, </a:t>
+            </a:r>
+            <a:r>
+              <a:rPr sz="2025" b="0">
+                <a:solidFill>
+                  <a:srgbClr val="101820"/>
+                </a:solidFill>
+                <a:latin typeface="Arial"/>
+                <a:ea typeface="Arial"/>
+                <a:cs typeface="Arial"/>
+              </a:rPr>
+              <a:t>LoRA+ (fixed B/A=16), matched-budget</a:t>
+            </a:r>
+            <a:r>
+              <a:rPr sz="2025" b="0">
+                <a:solidFill>
+                  <a:srgbClr val="101820"/>
+                </a:solidFill>
+                <a:latin typeface="Arial"/>
+                <a:ea typeface="Arial"/>
+                <a:cs typeface="Arial"/>
+              </a:rPr>
+              <a:t> LoRA, budgeted DoRA, and full fine-tuning.</a:t>
             </a:r>
           </a:p>
           <a:p xmlns:a="http://schemas.openxmlformats.org/drawingml/2006/main">
             <a:pPr algn="l">
               <a:lnSpc>
-                <a:spcPct val="99000"/>
+                <a:spcPct val="106000"/>
               </a:lnSpc>
               <a:spcAft>
                 <a:spcPts val="0"/>
               </a:spcAft>
               <a:buNone/>
-              <a:defRPr sz="2363" b="0">
-                <a:solidFill>
-                  <a:srgbClr val="111111"/>
+              <a:defRPr sz="2025" b="0">
+                <a:solidFill>
+                  <a:srgbClr val="101820"/>
                 </a:solidFill>
                 <a:latin typeface="Arial"/>
                 <a:ea typeface="Arial"/>
@@ -2546,26 +2546,78 @@
               </a:defRPr>
             </a:pPr>
             <a:r>
-              <a:rPr sz="2363" b="0">
-                <a:solidFill>
-                  <a:srgbClr val="111111"/>
-                </a:solidFill>
-                <a:latin typeface="Arial"/>
-                <a:ea typeface="Arial"/>
-                <a:cs typeface="Arial"/>
-              </a:rPr>
-              <a:t>Метрики: </a:t>
-            </a:r>
-            <a:r>
-              <a:rPr sz="2363" b="0">
-                <a:solidFill>
-                  <a:srgbClr val="111111"/>
-                </a:solidFill>
-                <a:latin typeface="Arial"/>
-                <a:ea typeface="Arial"/>
-                <a:cs typeface="Arial"/>
-              </a:rPr>
-              <a:t>relative Frobenius error; test accuracy; paired DoRA−LoRA с 95% t-CI; число trainable parameters.</a:t>
+              <a:rPr sz="2025" b="1">
+                <a:solidFill>
+                  <a:srgbClr val="101820"/>
+                </a:solidFill>
+                <a:latin typeface="Arial"/>
+                <a:ea typeface="Arial"/>
+                <a:cs typeface="Arial"/>
+              </a:rPr>
+              <a:t>Robustness:</a:t>
+            </a:r>
+            <a:r>
+              <a:rPr sz="2025" b="0">
+                <a:solidFill>
+                  <a:srgbClr val="101820"/>
+                </a:solidFill>
+                <a:latin typeface="Arial"/>
+                <a:ea typeface="Arial"/>
+                <a:cs typeface="Arial"/>
+              </a:rPr>
+              <a:t> 4 nested data regimes; 10 synthetic targets × 5 initializations.</a:t>
+            </a:r>
+          </a:p>
+          <a:p xmlns:a="http://schemas.openxmlformats.org/drawingml/2006/main">
+            <a:pPr algn="l">
+              <a:lnSpc>
+                <a:spcPct val="106000"/>
+              </a:lnSpc>
+              <a:spcAft>
+                <a:spcPts val="0"/>
+              </a:spcAft>
+              <a:buNone/>
+              <a:defRPr sz="2025" b="0">
+                <a:solidFill>
+                  <a:srgbClr val="101820"/>
+                </a:solidFill>
+                <a:latin typeface="Arial"/>
+                <a:ea typeface="Arial"/>
+                <a:cs typeface="Arial"/>
+              </a:defRPr>
+            </a:pPr>
+            <a:r>
+              <a:rPr sz="2025" b="1">
+                <a:solidFill>
+                  <a:srgbClr val="101820"/>
+                </a:solidFill>
+                <a:latin typeface="Arial"/>
+                <a:ea typeface="Arial"/>
+                <a:cs typeface="Arial"/>
+              </a:rPr>
+              <a:t>1,960</a:t>
+            </a:r>
+            <a:r>
+              <a:rPr sz="2025" b="0">
+                <a:solidFill>
+                  <a:srgbClr val="101820"/>
+                </a:solidFill>
+                <a:latin typeface="Arial"/>
+                <a:ea typeface="Arial"/>
+                <a:cs typeface="Arial"/>
+              </a:rPr>
+              <a:t> saved result rows; </a:t>
+            </a:r>
+            <a:r>
+              <a:rPr sz="2025" b="0">
+                <a:solidFill>
+                  <a:srgbClr val="101820"/>
+                </a:solidFill>
+                <a:latin typeface="Arial"/>
+                <a:ea typeface="Arial"/>
+                <a:cs typeface="Arial"/>
+              </a:rPr>
+              <a:t>1,840 training / optimization jobs.</a:t>
             </a:r>
           </a:p>
         </p:txBody>
@@ -2586,16 +2638,16 @@
         </p:nvSpPr>
         <p:spPr>
           <a:xfrm xmlns:a="http://schemas.openxmlformats.org/drawingml/2006/main">
-            <a:off x="1511812" y="22938553"/>
-            <a:ext cx="8328874" cy="738664"/>
+            <a:off x="1511808" y="22764750"/>
+            <a:ext cx="8328851" cy="590550"/>
           </a:xfrm>
           <a:prstGeom xmlns:a="http://schemas.openxmlformats.org/drawingml/2006/main" prst="rect">
             <a:avLst/>
           </a:prstGeom>
         </p:spPr>
         <p:txBody>
-          <a:bodyPr xmlns:a="http://schemas.openxmlformats.org/drawingml/2006/main" vert="horz" wrap="square" lIns="0" tIns="0" rIns="0" bIns="0" anchor="ctr">
-            <a:normAutofit fontScale="100000"/>
+          <a:bodyPr xmlns:a="http://schemas.openxmlformats.org/drawingml/2006/main" vert="horz" wrap="square" lIns="0" tIns="0" rIns="0" bIns="0" anchor="t">
+            <a:noAutofit/>
           </a:bodyPr>
           <a:lstStyle xmlns:a="http://schemas.openxmlformats.org/drawingml/2006/main">
             <a:lvl1pPr algn="ctr">
@@ -2619,9 +2671,9 @@
                 <a:spcPct val="94000"/>
               </a:lnSpc>
               <a:buNone/>
-              <a:defRPr sz="4800" b="0">
-                <a:solidFill>
-                  <a:srgbClr val="111111"/>
+              <a:defRPr sz="3225" b="0">
+                <a:solidFill>
+                  <a:srgbClr val="101820"/>
                 </a:solidFill>
                 <a:latin typeface="Arial"/>
                 <a:ea typeface="Arial"/>
@@ -2629,15 +2681,15 @@
               </a:defRPr>
             </a:pPr>
             <a:r>
-              <a:rPr sz="4800" b="0">
-                <a:solidFill>
-                  <a:srgbClr val="111111"/>
-                </a:solidFill>
-                <a:latin typeface="Arial"/>
-                <a:ea typeface="Arial"/>
-                <a:cs typeface="Arial"/>
-              </a:rPr>
-              <a:t>Протокол</a:t>
+              <a:rPr sz="3225" b="0">
+                <a:solidFill>
+                  <a:srgbClr val="101820"/>
+                </a:solidFill>
+                <a:latin typeface="Arial"/>
+                <a:ea typeface="Arial"/>
+                <a:cs typeface="Arial"/>
+              </a:rPr>
+              <a:t>Negative controls prevent a victory-only story</a:t>
             </a:r>
           </a:p>
         </p:txBody>
@@ -2658,8 +2710,8 @@
         </p:nvSpPr>
         <p:spPr>
           <a:xfrm xmlns:a="http://schemas.openxmlformats.org/drawingml/2006/main">
-            <a:off x="1509767" y="23952775"/>
-            <a:ext cx="8328874" cy="35801427"/>
+            <a:off x="1509808" y="23574375"/>
+            <a:ext cx="8328851" cy="3829050"/>
           </a:xfrm>
           <a:prstGeom xmlns:a="http://schemas.openxmlformats.org/drawingml/2006/main" prst="rect">
             <a:avLst/>
@@ -2667,7 +2719,7 @@
         </p:spPr>
         <p:txBody>
           <a:bodyPr xmlns:a="http://schemas.openxmlformats.org/drawingml/2006/main" vert="horz" wrap="square" lIns="0" tIns="0" rIns="0" bIns="0" anchor="t">
-            <a:normAutofit fontScale="100000"/>
+            <a:noAutofit/>
           </a:bodyPr>
           <a:lstStyle xmlns:a="http://schemas.openxmlformats.org/drawingml/2006/main">
             <a:lvl1pPr algn="ctr">
@@ -2688,15 +2740,15 @@
           <a:p xmlns:a="http://schemas.openxmlformats.org/drawingml/2006/main">
             <a:pPr marL="24" indent="-14" algn="l">
               <a:lnSpc>
-                <a:spcPct val="98000"/>
+                <a:spcPct val="108000"/>
               </a:lnSpc>
               <a:spcAft>
                 <a:spcPts val="7"/>
               </a:spcAft>
               <a:buNone/>
-              <a:defRPr sz="2325" b="0">
-                <a:solidFill>
-                  <a:srgbClr val="111111"/>
+              <a:defRPr sz="2025" b="0">
+                <a:solidFill>
+                  <a:srgbClr val="101820"/>
                 </a:solidFill>
                 <a:latin typeface="Arial"/>
                 <a:ea typeface="Arial"/>
@@ -2704,40 +2756,40 @@
               </a:defRPr>
             </a:pPr>
             <a:r>
-              <a:rPr sz="2325" b="0">
-                <a:solidFill>
-                  <a:srgbClr val="111111"/>
-                </a:solidFill>
-                <a:latin typeface="Arial"/>
-                <a:ea typeface="Arial"/>
-                <a:cs typeface="Arial"/>
-              </a:rPr>
-              <a:t>Capacity test: </a:t>
-            </a:r>
-            <a:r>
-              <a:rPr sz="2325" b="0">
-                <a:solidFill>
-                  <a:srgbClr val="111111"/>
-                </a:solidFill>
-                <a:latin typeface="Arial"/>
-                <a:ea typeface="Arial"/>
-                <a:cs typeface="Arial"/>
-              </a:rPr>
-              <a:t>W★ = diag(1 + γz)(W₀ + Δr=4); γ = 0…0.8, ranks 1/2/4/8, 10 seeds. LoRA - точный SVD oracle.</a:t>
+              <a:rPr sz="2025" b="1">
+                <a:solidFill>
+                  <a:srgbClr val="101820"/>
+                </a:solidFill>
+                <a:latin typeface="Arial"/>
+                <a:ea typeface="Arial"/>
+                <a:cs typeface="Arial"/>
+              </a:rPr>
+              <a:t>Contrast (MLP):</a:t>
+            </a:r>
+            <a:r>
+              <a:rPr sz="2025" b="0">
+                <a:solidFill>
+                  <a:srgbClr val="101820"/>
+                </a:solidFill>
+                <a:latin typeface="Arial"/>
+                <a:ea typeface="Arial"/>
+                <a:cs typeface="Arial"/>
+              </a:rPr>
+              <a:t> magnitude-only 96.90% &gt; DoRA 95.18%.</a:t>
             </a:r>
           </a:p>
           <a:p xmlns:a="http://schemas.openxmlformats.org/drawingml/2006/main">
             <a:pPr marL="24" indent="-14" algn="l">
               <a:lnSpc>
-                <a:spcPct val="98000"/>
+                <a:spcPct val="108000"/>
               </a:lnSpc>
               <a:spcAft>
                 <a:spcPts val="7"/>
               </a:spcAft>
               <a:buNone/>
-              <a:defRPr sz="2325" b="0">
-                <a:solidFill>
-                  <a:srgbClr val="111111"/>
+              <a:defRPr sz="2025" b="0">
+                <a:solidFill>
+                  <a:srgbClr val="101820"/>
                 </a:solidFill>
                 <a:latin typeface="Arial"/>
                 <a:ea typeface="Arial"/>
@@ -2745,37 +2797,78 @@
               </a:defRPr>
             </a:pPr>
             <a:r>
-              <a:rPr sz="2325" b="0">
-                <a:solidFill>
-                  <a:srgbClr val="111111"/>
-                </a:solidFill>
-                <a:latin typeface="Arial"/>
-                <a:ea typeface="Arial"/>
-                <a:cs typeface="Arial"/>
-              </a:rPr>
-              <a:t>Real-data test: </a:t>
-            </a:r>
-            <a:r>
-              <a:rPr sz="2325" b="0">
-                <a:solidFill>
-                  <a:srgbClr val="111111"/>
-                </a:solidFill>
-                <a:latin typeface="Arial"/>
-                <a:ea typeface="Arial"/>
-                <a:cs typeface="Arial"/>
-              </a:rPr>
-              <a:t>Digits; MLP 64→128→64→10; 400 адаптационных примеров; contrast, rotation и mixed; 5 paired seeds.</a:t>
+              <a:rPr sz="2025" b="1">
+                <a:solidFill>
+                  <a:srgbClr val="101820"/>
+                </a:solidFill>
+                <a:latin typeface="Arial"/>
+                <a:ea typeface="Arial"/>
+                <a:cs typeface="Arial"/>
+              </a:rPr>
+              <a:t>Rotation (MLP):</a:t>
+            </a:r>
+            <a:r>
+              <a:rPr sz="2025" b="0">
+                <a:solidFill>
+                  <a:srgbClr val="101820"/>
+                </a:solidFill>
+                <a:latin typeface="Arial"/>
+                <a:ea typeface="Arial"/>
+                <a:cs typeface="Arial"/>
+              </a:rPr>
+              <a:t> matched-budget LoRA = DoRA = 93.89%.</a:t>
             </a:r>
           </a:p>
           <a:p xmlns:a="http://schemas.openxmlformats.org/drawingml/2006/main">
             <a:pPr marL="24" indent="-14" algn="l">
               <a:lnSpc>
-                <a:spcPct val="98000"/>
+                <a:spcPct val="108000"/>
               </a:lnSpc>
               <a:spcAft>
                 <a:spcPts val="7"/>
               </a:spcAft>
               <a:buNone/>
+              <a:defRPr sz="2025" b="0">
+                <a:solidFill>
+                  <a:srgbClr val="101820"/>
+                </a:solidFill>
+                <a:latin typeface="Arial"/>
+                <a:ea typeface="Arial"/>
+                <a:cs typeface="Arial"/>
+              </a:defRPr>
+            </a:pPr>
+            <a:r>
+              <a:rPr sz="2025" b="1">
+                <a:solidFill>
+                  <a:srgbClr val="101820"/>
+                </a:solidFill>
+                <a:latin typeface="Arial"/>
+                <a:ea typeface="Arial"/>
+                <a:cs typeface="Arial"/>
+              </a:rPr>
+              <a:t>Mixed (MLP):</a:t>
+            </a:r>
+            <a:r>
+              <a:rPr sz="2025" b="0">
+                <a:solidFill>
+                  <a:srgbClr val="101820"/>
+                </a:solidFill>
+                <a:latin typeface="Arial"/>
+                <a:ea typeface="Arial"/>
+                <a:cs typeface="Arial"/>
+              </a:rPr>
+              <a:t> matching the parameter budget reduces the DoRA gap to +0.53 pp; its CI crosses zero.</a:t>
+            </a:r>
+          </a:p>
+          <a:p xmlns:a="http://schemas.openxmlformats.org/drawingml/2006/main">
+            <a:pPr marL="24" indent="-14" algn="l">
+              <a:lnSpc>
+                <a:spcPct val="98000"/>
+              </a:lnSpc>
+              <a:spcAft>
+                <a:spcPts val="7"/>
+              </a:spcAft>
+              <a:buNone/>
               <a:defRPr sz="2325" b="0">
                 <a:solidFill>
                   <a:srgbClr val="111111"/>
@@ -2794,18 +2887,48 @@
                 <a:ea typeface="Arial"/>
                 <a:cs typeface="Arial"/>
               </a:rPr>
-              <a:t>Без утечки: </a:t>
-            </a:r>
-            <a:r>
-              <a:rPr sz="2325" b="0">
-                <a:solidFill>
-                  <a:srgbClr val="111111"/>
-                </a:solidFill>
-                <a:latin typeface="Arial"/>
-                <a:ea typeface="Arial"/>
-                <a:cs typeface="Arial"/>
-              </a:rPr>
-              <a:t>LR и early stopping выбирались по validation; test применён один раз. Контроли: frozen, magnitude-only, full FT.</a:t>
+              <a:t/>
+            </a:r>
+          </a:p>
+          <a:p xmlns:a="http://schemas.openxmlformats.org/drawingml/2006/main">
+            <a:pPr marL="24" indent="-14" algn="l">
+              <a:lnSpc>
+                <a:spcPct val="108000"/>
+              </a:lnSpc>
+              <a:spcAft>
+                <a:spcPts val="7"/>
+              </a:spcAft>
+              <a:buNone/>
+              <a:defRPr sz="2025" b="0">
+                <a:solidFill>
+                  <a:srgbClr val="101820"/>
+                </a:solidFill>
+                <a:latin typeface="Arial"/>
+                <a:ea typeface="Arial"/>
+                <a:cs typeface="Arial"/>
+              </a:defRPr>
+            </a:pPr>
+            <a:r>
+              <a:rPr sz="2025" b="1">
+                <a:solidFill>
+                  <a:srgbClr val="101820"/>
+                </a:solidFill>
+                <a:latin typeface="Arial"/>
+                <a:ea typeface="Arial"/>
+                <a:cs typeface="Arial"/>
+              </a:rPr>
+              <a:t>Scope:</a:t>
+            </a:r>
+            <a:r>
+              <a:rPr sz="2025" b="0">
+                <a:solidFill>
+                  <a:srgbClr val="101820"/>
+                </a:solidFill>
+                <a:latin typeface="Arial"/>
+                <a:ea typeface="Arial"/>
+                <a:cs typeface="Arial"/>
+              </a:rPr>
+              <a:t> Digits, one fixed pretrained base per architecture, and one target split already seen during exploratory work. This is a controlled mechanism study, not an LLM-scale benchmark.</a:t>
             </a:r>
           </a:p>
         </p:txBody>
@@ -2826,16 +2949,16 @@
         </p:nvSpPr>
         <p:spPr>
           <a:xfrm xmlns:a="http://schemas.openxmlformats.org/drawingml/2006/main">
-            <a:off x="11542427" y="21671044"/>
-            <a:ext cx="8328874" cy="738664"/>
+            <a:off x="11542395" y="23241000"/>
+            <a:ext cx="8328851" cy="552450"/>
           </a:xfrm>
           <a:prstGeom xmlns:a="http://schemas.openxmlformats.org/drawingml/2006/main" prst="rect">
             <a:avLst/>
           </a:prstGeom>
         </p:spPr>
         <p:txBody>
-          <a:bodyPr xmlns:a="http://schemas.openxmlformats.org/drawingml/2006/main" vert="horz" wrap="square" lIns="0" tIns="0" rIns="0" bIns="0" anchor="ctr">
-            <a:normAutofit fontScale="100000"/>
+          <a:bodyPr xmlns:a="http://schemas.openxmlformats.org/drawingml/2006/main" vert="horz" wrap="square" lIns="0" tIns="0" rIns="0" bIns="0" anchor="t">
+            <a:noAutofit/>
           </a:bodyPr>
           <a:lstStyle xmlns:a="http://schemas.openxmlformats.org/drawingml/2006/main">
             <a:lvl1pPr algn="ctr">
@@ -2859,9 +2982,9 @@
                 <a:spcPct val="94000"/>
               </a:lnSpc>
               <a:buNone/>
-              <a:defRPr sz="4800" b="0">
-                <a:solidFill>
-                  <a:srgbClr val="111111"/>
+              <a:defRPr sz="3225" b="0">
+                <a:solidFill>
+                  <a:srgbClr val="101820"/>
                 </a:solidFill>
                 <a:latin typeface="Arial"/>
                 <a:ea typeface="Arial"/>
@@ -2869,15 +2992,15 @@
               </a:defRPr>
             </a:pPr>
             <a:r>
-              <a:rPr sz="4800" b="0">
-                <a:solidFill>
-                  <a:srgbClr val="111111"/>
-                </a:solidFill>
-                <a:latin typeface="Arial"/>
-                <a:ea typeface="Arial"/>
-                <a:cs typeface="Arial"/>
-              </a:rPr>
-              <a:t>Практический вывод</a:t>
+              <a:rPr sz="3225" b="0">
+                <a:solidFill>
+                  <a:srgbClr val="101820"/>
+                </a:solidFill>
+                <a:latin typeface="Arial"/>
+                <a:ea typeface="Arial"/>
+                <a:cs typeface="Arial"/>
+              </a:rPr>
+              <a:t>What the controls still support</a:t>
             </a:r>
           </a:p>
         </p:txBody>
@@ -2898,8 +3021,8 @@
         </p:nvSpPr>
         <p:spPr>
           <a:xfrm xmlns:a="http://schemas.openxmlformats.org/drawingml/2006/main">
-            <a:off x="11540382" y="22767227"/>
-            <a:ext cx="8328874" cy="53085365"/>
+            <a:off x="11540395" y="23955375"/>
+            <a:ext cx="8328851" cy="3495675"/>
           </a:xfrm>
           <a:prstGeom xmlns:a="http://schemas.openxmlformats.org/drawingml/2006/main" prst="rect">
             <a:avLst/>
@@ -2907,7 +3030,7 @@
         </p:spPr>
         <p:txBody>
           <a:bodyPr xmlns:a="http://schemas.openxmlformats.org/drawingml/2006/main" vert="horz" wrap="square" lIns="0" tIns="0" rIns="0" bIns="0" anchor="t">
-            <a:normAutofit fontScale="100000"/>
+            <a:noAutofit/>
           </a:bodyPr>
           <a:lstStyle xmlns:a="http://schemas.openxmlformats.org/drawingml/2006/main">
             <a:lvl1pPr algn="ctr">
@@ -2928,15 +3051,15 @@
           <a:p xmlns:a="http://schemas.openxmlformats.org/drawingml/2006/main">
             <a:pPr marL="24" indent="-14" algn="l">
               <a:lnSpc>
-                <a:spcPct val="96000"/>
+                <a:spcPct val="102000"/>
               </a:lnSpc>
               <a:spcAft>
-                <a:spcPts val="7"/>
+                <a:spcPts val="6"/>
               </a:spcAft>
               <a:buNone/>
-              <a:defRPr sz="2228" b="0">
-                <a:solidFill>
-                  <a:srgbClr val="111111"/>
+              <a:defRPr sz="2100">
+                <a:solidFill>
+                  <a:srgbClr val="101820"/>
                 </a:solidFill>
                 <a:latin typeface="Arial"/>
                 <a:ea typeface="Arial"/>
@@ -2944,40 +3067,51 @@
               </a:defRPr>
             </a:pPr>
             <a:r>
-              <a:rPr sz="2228" b="0">
-                <a:solidFill>
-                  <a:srgbClr val="111111"/>
-                </a:solidFill>
-                <a:latin typeface="Arial"/>
-                <a:ea typeface="Arial"/>
-                <a:cs typeface="Arial"/>
-              </a:rPr>
-              <a:t>Mixed, r=4: </a:t>
-            </a:r>
-            <a:r>
-              <a:rPr sz="2228" b="0">
-                <a:solidFill>
-                  <a:srgbClr val="111111"/>
-                </a:solidFill>
-                <a:latin typeface="Arial"/>
-                <a:ea typeface="Arial"/>
-                <a:cs typeface="Arial"/>
-              </a:rPr>
-              <a:t>Frozen 50.83 · m-only 65.89 · LoRA 73.33 · DoRA 74.72 · Full FT 73.33%.</a:t>
+              <a:rPr sz="2100">
+                <a:solidFill>
+                  <a:srgbClr val="101820"/>
+                </a:solidFill>
+                <a:latin typeface="Arial"/>
+                <a:ea typeface="Arial"/>
+                <a:cs typeface="Arial"/>
+              </a:rPr>
+              <a:t>- </a:t>
+            </a:r>
+            <a:r>
+              <a:rPr sz="2100" b="1">
+                <a:solidFill>
+                  <a:srgbClr val="101820"/>
+                </a:solidFill>
+                <a:latin typeface="Arial"/>
+                <a:ea typeface="Arial"/>
+                <a:cs typeface="Arial"/>
+              </a:rPr>
+              <a:t>Mixed shift:</a:t>
+            </a:r>
+            <a:r>
+              <a:rPr sz="2100">
+                <a:solidFill>
+                  <a:srgbClr val="101820"/>
+                </a:solidFill>
+                <a:latin typeface="Arial"/>
+                <a:ea typeface="Arial"/>
+                <a:cs typeface="Arial"/>
+              </a:rPr>
+              <a:t> DoRA reaches 75.22% (MLP) and 80.53% (CNN), near full FT (75.17%, 80.67%) with ~12-15% of its trainable parameters.</a:t>
             </a:r>
           </a:p>
           <a:p xmlns:a="http://schemas.openxmlformats.org/drawingml/2006/main">
             <a:pPr marL="24" indent="-14" algn="l">
               <a:lnSpc>
-                <a:spcPct val="96000"/>
+                <a:spcPct val="102000"/>
               </a:lnSpc>
               <a:spcAft>
-                <a:spcPts val="7"/>
+                <a:spcPts val="6"/>
               </a:spcAft>
               <a:buNone/>
-              <a:defRPr sz="2228" b="0">
-                <a:solidFill>
-                  <a:srgbClr val="111111"/>
+              <a:defRPr sz="2100">
+                <a:solidFill>
+                  <a:srgbClr val="101820"/>
                 </a:solidFill>
                 <a:latin typeface="Arial"/>
                 <a:ea typeface="Arial"/>
@@ -2985,40 +3119,51 @@
               </a:defRPr>
             </a:pPr>
             <a:r>
-              <a:rPr sz="2228" b="0">
-                <a:solidFill>
-                  <a:srgbClr val="111111"/>
-                </a:solidFill>
-                <a:latin typeface="Arial"/>
-                <a:ea typeface="Arial"/>
-                <a:cs typeface="Arial"/>
-              </a:rPr>
-              <a:t>Mixed, r=8: </a:t>
-            </a:r>
-            <a:r>
-              <a:rPr sz="2228" b="0">
-                <a:solidFill>
-                  <a:srgbClr val="111111"/>
-                </a:solidFill>
-                <a:latin typeface="Arial"/>
-                <a:ea typeface="Arial"/>
-                <a:cs typeface="Arial"/>
-              </a:rPr>
-              <a:t>DoRA 77.33% против LoRA 75.44%.</a:t>
+              <a:rPr sz="2100">
+                <a:solidFill>
+                  <a:srgbClr val="101820"/>
+                </a:solidFill>
+                <a:latin typeface="Arial"/>
+                <a:ea typeface="Arial"/>
+                <a:cs typeface="Arial"/>
+              </a:rPr>
+              <a:t>- </a:t>
+            </a:r>
+            <a:r>
+              <a:rPr sz="2100" b="1">
+                <a:solidFill>
+                  <a:srgbClr val="101820"/>
+                </a:solidFill>
+                <a:latin typeface="Arial"/>
+                <a:ea typeface="Arial"/>
+                <a:cs typeface="Arial"/>
+              </a:rPr>
+              <a:t>Fairer baselines:</a:t>
+            </a:r>
+            <a:r>
+              <a:rPr sz="2100">
+                <a:solidFill>
+                  <a:srgbClr val="101820"/>
+                </a:solidFill>
+                <a:latin typeface="Arial"/>
+                <a:ea typeface="Arial"/>
+                <a:cs typeface="Arial"/>
+              </a:rPr>
+              <a:t> matched-budget LoRA leaves +0.53 pp; DoRA-LoRA+ Holm p=.050935 (&gt; .05); budgeted DoRA +.82 pp (secondary Holm p=.347089).</a:t>
             </a:r>
           </a:p>
           <a:p xmlns:a="http://schemas.openxmlformats.org/drawingml/2006/main">
             <a:pPr marL="24" indent="-14" algn="l">
               <a:lnSpc>
-                <a:spcPct val="96000"/>
+                <a:spcPct val="102000"/>
               </a:lnSpc>
               <a:spcAft>
-                <a:spcPts val="7"/>
+                <a:spcPts val="6"/>
               </a:spcAft>
               <a:buNone/>
-              <a:defRPr sz="2228" b="0">
-                <a:solidFill>
-                  <a:srgbClr val="111111"/>
+              <a:defRPr sz="2100">
+                <a:solidFill>
+                  <a:srgbClr val="101820"/>
                 </a:solidFill>
                 <a:latin typeface="Arial"/>
                 <a:ea typeface="Arial"/>
@@ -3026,122 +3171,51 @@
               </a:defRPr>
             </a:pPr>
             <a:r>
-              <a:rPr sz="2228" b="0">
-                <a:solidFill>
-                  <a:srgbClr val="111111"/>
-                </a:solidFill>
-                <a:latin typeface="Arial"/>
-                <a:ea typeface="Arial"/>
-                <a:cs typeface="Arial"/>
-              </a:rPr>
-              <a:t>Бюджет r=4: </a:t>
-            </a:r>
-            <a:r>
-              <a:rPr sz="2228" b="0">
-                <a:solidFill>
-                  <a:srgbClr val="111111"/>
-                </a:solidFill>
-                <a:latin typeface="Arial"/>
-                <a:ea typeface="Arial"/>
-                <a:cs typeface="Arial"/>
-              </a:rPr>
-              <a:t>DoRA 2,034; LoRA 1,832 (+11%); full FT 17,226 trainable parameters.</a:t>
+              <a:rPr sz="2100">
+                <a:solidFill>
+                  <a:srgbClr val="101820"/>
+                </a:solidFill>
+                <a:latin typeface="Arial"/>
+                <a:ea typeface="Arial"/>
+                <a:cs typeface="Arial"/>
+              </a:rPr>
+              <a:t>- </a:t>
+            </a:r>
+            <a:r>
+              <a:rPr sz="2100" b="1">
+                <a:solidFill>
+                  <a:srgbClr val="101820"/>
+                </a:solidFill>
+                <a:latin typeface="Arial"/>
+                <a:ea typeface="Arial"/>
+                <a:cs typeface="Arial"/>
+              </a:rPr>
+              <a:t>Synthetic diagnostic (gamma=.8):</a:t>
+            </a:r>
+            <a:r>
+              <a:rPr sz="2100">
+                <a:solidFill>
+                  <a:srgbClr val="101820"/>
+                </a:solidFill>
+                <a:latin typeface="Arial"/>
+                <a:ea typeface="Arial"/>
+                <a:cs typeface="Arial"/>
+              </a:rPr>
+              <a:t> DoRA is representationally exact; 44/50 runs reach error &lt;10^-3. LoRA oracle mean error is .289.</a:t>
             </a:r>
           </a:p>
           <a:p xmlns:a="http://schemas.openxmlformats.org/drawingml/2006/main">
             <a:pPr marL="24" indent="-14" algn="l">
               <a:lnSpc>
-                <a:spcPct val="96000"/>
-              </a:lnSpc>
-              <a:spcAft>
-                <a:spcPts val="7"/>
-              </a:spcAft>
-              <a:buNone/>
-              <a:defRPr sz="2228" b="0">
-                <a:solidFill>
-                  <a:srgbClr val="111111"/>
-                </a:solidFill>
-                <a:latin typeface="Arial"/>
-                <a:ea typeface="Arial"/>
-                <a:cs typeface="Arial"/>
-              </a:defRPr>
-            </a:pPr>
-            <a:r>
-              <a:rPr sz="2228" b="0">
-                <a:solidFill>
-                  <a:srgbClr val="111111"/>
-                </a:solidFill>
-                <a:latin typeface="Arial"/>
-                <a:ea typeface="Arial"/>
-                <a:cs typeface="Arial"/>
-              </a:rPr>
-              <a:t>Validation-selected mixed: </a:t>
-            </a:r>
-            <a:r>
-              <a:rPr sz="2228" b="0">
-                <a:solidFill>
-                  <a:srgbClr val="111111"/>
-                </a:solidFill>
-                <a:latin typeface="Arial"/>
-                <a:ea typeface="Arial"/>
-                <a:cs typeface="Arial"/>
-              </a:rPr>
-              <a:t>DoRA 76.72 · LoRA 75.28 · full FT 73.33%.</a:t>
-            </a:r>
-          </a:p>
-          <a:p xmlns:a="http://schemas.openxmlformats.org/drawingml/2006/main">
-            <a:pPr algn="l">
-              <a:lnSpc>
-                <a:spcPct val="96000"/>
-              </a:lnSpc>
-              <a:spcAft>
-                <a:spcPts val="7"/>
-              </a:spcAft>
-              <a:buNone/>
-              <a:defRPr sz="2228" b="0">
-                <a:solidFill>
-                  <a:srgbClr val="111111"/>
-                </a:solidFill>
-                <a:latin typeface="Arial"/>
-                <a:ea typeface="Arial"/>
-                <a:cs typeface="Arial"/>
-              </a:defRPr>
-            </a:pPr>
-            <a:r>
-              <a:rPr sz="2228" b="0">
-                <a:solidFill>
-                  <a:srgbClr val="111111"/>
-                </a:solidFill>
-                <a:latin typeface="Arial"/>
-                <a:ea typeface="Arial"/>
-                <a:cs typeface="Arial"/>
-              </a:rPr>
-              <a:t>Итог: </a:t>
-            </a:r>
-            <a:r>
-              <a:rPr sz="2228" b="0">
-                <a:solidFill>
-                  <a:srgbClr val="111111"/>
-                </a:solidFill>
-                <a:latin typeface="Arial"/>
-                <a:ea typeface="Arial"/>
-                <a:cs typeface="Arial"/>
-              </a:rPr>
-              <a:t>DoRA оправдана, когда ожидается drift норм строк и особенно важен малый rank. В остальных случаях LoRA остаётся сильным baseline.</a:t>
-            </a:r>
-          </a:p>
-          <a:p xmlns:a="http://schemas.openxmlformats.org/drawingml/2006/main">
-            <a:pPr algn="l">
-              <a:lnSpc>
-                <a:spcPct val="96000"/>
+                <a:spcPct val="102000"/>
               </a:lnSpc>
               <a:spcAft>
                 <a:spcPts val="0"/>
               </a:spcAft>
               <a:buNone/>
-              <a:defRPr sz="2228" b="0">
-                <a:solidFill>
-                  <a:srgbClr val="111111"/>
+              <a:defRPr sz="2100">
+                <a:solidFill>
+                  <a:srgbClr val="101820"/>
                 </a:solidFill>
                 <a:latin typeface="Arial"/>
                 <a:ea typeface="Arial"/>
@@ -3149,26 +3223,37 @@
               </a:defRPr>
             </a:pPr>
             <a:r>
-              <a:rPr sz="2228" b="0">
-                <a:solidFill>
-                  <a:srgbClr val="111111"/>
-                </a:solidFill>
-                <a:latin typeface="Arial"/>
-                <a:ea typeface="Arial"/>
-                <a:cs typeface="Arial"/>
-              </a:rPr>
-              <a:t>Ограничения: </a:t>
-            </a:r>
-            <a:r>
-              <a:rPr sz="2228" b="0">
-                <a:solidFill>
-                  <a:srgbClr val="111111"/>
-                </a:solidFill>
-                <a:latin typeface="Arial"/>
-                <a:ea typeface="Arial"/>
-                <a:cs typeface="Arial"/>
-              </a:rPr>
-              <a:t>малый MLP/dataset, 5 seeds; не измерены transformer-scale качество и throughput.</a:t>
+              <a:rPr sz="2100">
+                <a:solidFill>
+                  <a:srgbClr val="101820"/>
+                </a:solidFill>
+                <a:latin typeface="Arial"/>
+                <a:ea typeface="Arial"/>
+                <a:cs typeface="Arial"/>
+              </a:rPr>
+              <a:t>- </a:t>
+            </a:r>
+            <a:r>
+              <a:rPr sz="2100" b="1">
+                <a:solidFill>
+                  <a:srgbClr val="101820"/>
+                </a:solidFill>
+                <a:latin typeface="Arial"/>
+                <a:ea typeface="Arial"/>
+                <a:cs typeface="Arial"/>
+              </a:rPr>
+              <a:t>Next test:</a:t>
+            </a:r>
+            <a:r>
+              <a:rPr sz="2100">
+                <a:solidFill>
+                  <a:srgbClr val="101820"/>
+                </a:solidFill>
+                <a:latin typeface="Arial"/>
+                <a:ea typeface="Arial"/>
+                <a:cs typeface="Arial"/>
+              </a:rPr>
+              <a:t> heterogeneous row-norm drift, retaining LoRA and magnitude-only controls.</a:t>
             </a:r>
           </a:p>
         </p:txBody>
@@ -3189,16 +3274,16 @@
         </p:nvSpPr>
         <p:spPr>
           <a:xfrm xmlns:a="http://schemas.openxmlformats.org/drawingml/2006/main">
-            <a:off x="11542427" y="6653687"/>
-            <a:ext cx="8328874" cy="738664"/>
+            <a:off x="11542395" y="6572250"/>
+            <a:ext cx="8328851" cy="400050"/>
           </a:xfrm>
           <a:prstGeom xmlns:a="http://schemas.openxmlformats.org/drawingml/2006/main" prst="rect">
             <a:avLst/>
           </a:prstGeom>
         </p:spPr>
         <p:txBody>
-          <a:bodyPr xmlns:a="http://schemas.openxmlformats.org/drawingml/2006/main" vert="horz" wrap="square" lIns="0" tIns="0" rIns="0" bIns="0" anchor="ctr">
-            <a:normAutofit fontScale="100000"/>
+          <a:bodyPr xmlns:a="http://schemas.openxmlformats.org/drawingml/2006/main" vert="horz" wrap="square" lIns="0" tIns="0" rIns="0" bIns="0" anchor="t">
+            <a:noAutofit/>
           </a:bodyPr>
           <a:lstStyle xmlns:a="http://schemas.openxmlformats.org/drawingml/2006/main">
             <a:lvl1pPr algn="ctr">
@@ -3222,9 +3307,9 @@
                 <a:spcPct val="94000"/>
               </a:lnSpc>
               <a:buNone/>
-              <a:defRPr sz="4800" b="0">
-                <a:solidFill>
-                  <a:srgbClr val="111111"/>
+              <a:defRPr sz="1725" b="1">
+                <a:solidFill>
+                  <a:srgbClr val="008A80"/>
                 </a:solidFill>
                 <a:latin typeface="Arial"/>
                 <a:ea typeface="Arial"/>
@@ -3232,15 +3317,15 @@
               </a:defRPr>
             </a:pPr>
             <a:r>
-              <a:rPr sz="4800" b="0">
-                <a:solidFill>
-                  <a:srgbClr val="111111"/>
-                </a:solidFill>
-                <a:latin typeface="Arial"/>
-                <a:ea typeface="Arial"/>
-                <a:cs typeface="Arial"/>
-              </a:rPr>
-              <a:t>Два уровня проверки</a:t>
+              <a:rPr sz="1725" b="1">
+                <a:solidFill>
+                  <a:srgbClr val="008A80"/>
+                </a:solidFill>
+                <a:latin typeface="Arial"/>
+                <a:ea typeface="Arial"/>
+                <a:cs typeface="Arial"/>
+              </a:rPr>
+              <a:t>HELD-SEED MIXED-SHIFT ESTIMATES</a:t>
             </a:r>
           </a:p>
         </p:txBody>
@@ -3261,8 +3346,8 @@
         </p:nvSpPr>
         <p:spPr>
           <a:xfrm xmlns:a="http://schemas.openxmlformats.org/drawingml/2006/main">
-            <a:off x="11542938" y="7624916"/>
-            <a:ext cx="8328874" cy="29629227"/>
+            <a:off x="11542966" y="22288500"/>
+            <a:ext cx="8328851" cy="781050"/>
           </a:xfrm>
           <a:prstGeom xmlns:a="http://schemas.openxmlformats.org/drawingml/2006/main" prst="rect">
             <a:avLst/>
@@ -3270,7 +3355,7 @@
         </p:spPr>
         <p:txBody>
           <a:bodyPr xmlns:a="http://schemas.openxmlformats.org/drawingml/2006/main" vert="horz" wrap="square" lIns="0" tIns="0" rIns="0" bIns="0" anchor="t">
-            <a:normAutofit fontScale="100000"/>
+            <a:noAutofit/>
           </a:bodyPr>
           <a:lstStyle xmlns:a="http://schemas.openxmlformats.org/drawingml/2006/main">
             <a:lvl1pPr algn="ctr">
@@ -3291,15 +3376,15 @@
           <a:p xmlns:a="http://schemas.openxmlformats.org/drawingml/2006/main">
             <a:pPr marL="24" indent="-14" algn="l">
               <a:lnSpc>
-                <a:spcPct val="99000"/>
+                <a:spcPct val="105000"/>
               </a:lnSpc>
               <a:spcAft>
                 <a:spcPts val="7"/>
               </a:spcAft>
               <a:buNone/>
-              <a:defRPr sz="2363" b="0">
-                <a:solidFill>
-                  <a:srgbClr val="111111"/>
+              <a:defRPr sz="1650" b="0">
+                <a:solidFill>
+                  <a:srgbClr val="5F6870"/>
                 </a:solidFill>
                 <a:latin typeface="Arial"/>
                 <a:ea typeface="Arial"/>
@@ -3307,108 +3392,15 @@
               </a:defRPr>
             </a:pPr>
             <a:r>
-              <a:rPr sz="2363" b="0">
-                <a:solidFill>
-                  <a:srgbClr val="111111"/>
-                </a:solidFill>
-                <a:latin typeface="Arial"/>
-                <a:ea typeface="Arial"/>
-                <a:cs typeface="Arial"/>
-              </a:rPr>
-              <a:t>Ёмкость: </a:t>
-            </a:r>
-            <a:r>
-              <a:rPr sz="2363" b="0">
-                <a:solidFill>
-                  <a:srgbClr val="111111"/>
-                </a:solidFill>
-                <a:latin typeface="Arial"/>
-                <a:ea typeface="Arial"/>
-                <a:cs typeface="Arial"/>
-              </a:rPr>
-              <a:t>может ли параметризация выразить целевую матрицу без влияния оптимизатора?</a:t>
-            </a:r>
-          </a:p>
-          <a:p xmlns:a="http://schemas.openxmlformats.org/drawingml/2006/main">
-            <a:pPr marL="24" indent="-14" algn="l">
-              <a:lnSpc>
-                <a:spcPct val="99000"/>
-              </a:lnSpc>
-              <a:spcAft>
-                <a:spcPts val="7"/>
-              </a:spcAft>
-              <a:buNone/>
-              <a:defRPr sz="2363" b="0">
-                <a:solidFill>
-                  <a:srgbClr val="111111"/>
-                </a:solidFill>
-                <a:latin typeface="Arial"/>
-                <a:ea typeface="Arial"/>
-                <a:cs typeface="Arial"/>
-              </a:defRPr>
-            </a:pPr>
-            <a:r>
-              <a:rPr sz="2363" b="0">
-                <a:solidFill>
-                  <a:srgbClr val="111111"/>
-                </a:solidFill>
-                <a:latin typeface="Arial"/>
-                <a:ea typeface="Arial"/>
-                <a:cs typeface="Arial"/>
-              </a:rPr>
-              <a:t>Обучение: </a:t>
-            </a:r>
-            <a:r>
-              <a:rPr sz="2363" b="0">
-                <a:solidFill>
-                  <a:srgbClr val="111111"/>
-                </a:solidFill>
-                <a:latin typeface="Arial"/>
-                <a:ea typeface="Arial"/>
-                <a:cs typeface="Arial"/>
-              </a:rPr>
-              <a:t>сохраняется ли эффект при конечных данных, SGD и выборе гиперпараметров?</a:t>
-            </a:r>
-          </a:p>
-          <a:p xmlns:a="http://schemas.openxmlformats.org/drawingml/2006/main">
-            <a:pPr marL="24" indent="-14" algn="l">
-              <a:lnSpc>
-                <a:spcPct val="99000"/>
-              </a:lnSpc>
-              <a:spcAft>
-                <a:spcPts val="7"/>
-              </a:spcAft>
-              <a:buNone/>
-              <a:defRPr sz="2363" b="0">
-                <a:solidFill>
-                  <a:srgbClr val="111111"/>
-                </a:solidFill>
-                <a:latin typeface="Arial"/>
-                <a:ea typeface="Arial"/>
-                <a:cs typeface="Arial"/>
-              </a:defRPr>
-            </a:pPr>
-            <a:r>
-              <a:rPr sz="2363" b="0">
-                <a:solidFill>
-                  <a:srgbClr val="111111"/>
-                </a:solidFill>
-                <a:latin typeface="Arial"/>
-                <a:ea typeface="Arial"/>
-                <a:cs typeface="Arial"/>
-              </a:rPr>
-              <a:t>Фальсифицируемость: </a:t>
-            </a:r>
-            <a:r>
-              <a:rPr sz="2363" b="0">
-                <a:solidFill>
-                  <a:srgbClr val="111111"/>
-                </a:solidFill>
-                <a:latin typeface="Arial"/>
-                <a:ea typeface="Arial"/>
-                <a:cs typeface="Arial"/>
-              </a:rPr>
-              <a:t>γ = 0, contrast shift и rotation r=8 служат отрицательными примерами.</a:t>
+              <a:rPr sz="1650" b="0">
+                <a:solidFill>
+                  <a:srgbClr val="5F6870"/>
+                </a:solidFill>
+                <a:latin typeface="Arial"/>
+                <a:ea typeface="Arial"/>
+                <a:cs typeface="Arial"/>
+              </a:rPr>
+              <a:t>Target-test evaluation followed the frozen validation-selected protocol. Internal confirmation on fixed checkpoints; exact CIs, raw/adjusted p-values, and rank budgets are in the repository.</a:t>
             </a:r>
           </a:p>
         </p:txBody>
@@ -3472,8 +3464,8 @@
         </p:nvSpPr>
         <p:spPr>
           <a:xfrm xmlns:a="http://schemas.openxmlformats.org/drawingml/2006/main">
-            <a:off x="1511811" y="29460098"/>
-            <a:ext cx="16893945" cy="310896"/>
+            <a:off x="1511808" y="29460063"/>
+            <a:ext cx="16893921" cy="310896"/>
           </a:xfrm>
           <a:prstGeom xmlns:a="http://schemas.openxmlformats.org/drawingml/2006/main" prst="rect">
             <a:avLst/>
@@ -3481,7 +3473,7 @@
         </p:spPr>
         <p:txBody>
           <a:bodyPr xmlns:a="http://schemas.openxmlformats.org/drawingml/2006/main" vert="horz" wrap="square" lIns="0" tIns="0" rIns="0" bIns="0" anchor="ctr">
-            <a:normAutofit fontScale="100000"/>
+            <a:noAutofit/>
           </a:bodyPr>
           <a:lstStyle xmlns:a="http://schemas.openxmlformats.org/drawingml/2006/main">
             <a:lvl1pPr algn="ctr">
@@ -3505,9 +3497,9 @@
                 <a:spcPct val="102000"/>
               </a:lnSpc>
               <a:buNone/>
-              <a:defRPr sz="2000" b="0">
-                <a:solidFill>
-                  <a:srgbClr val="5B6268"/>
+              <a:defRPr sz="1500" b="0">
+                <a:solidFill>
+                  <a:srgbClr val="5F6870"/>
                 </a:solidFill>
                 <a:latin typeface="Arial"/>
                 <a:ea typeface="Arial"/>
@@ -3515,15 +3507,15 @@
               </a:defRPr>
             </a:pPr>
             <a:r>
-              <a:rPr sz="2000" b="0">
-                <a:solidFill>
-                  <a:srgbClr val="5B6268"/>
-                </a:solidFill>
-                <a:latin typeface="Arial"/>
-                <a:ea typeface="Arial"/>
-                <a:cs typeface="Arial"/>
-              </a:rPr>
-              <a:t>[3] scikit-learn Digits; код, seeds, CSV и notebook - GitHub (QR).</a:t>
+              <a:rPr sz="1500" b="0">
+                <a:solidFill>
+                  <a:srgbClr val="5F6870"/>
+                </a:solidFill>
+                <a:latin typeface="Arial"/>
+                <a:ea typeface="Arial"/>
+                <a:cs typeface="Arial"/>
+              </a:rPr>
+              <a:t>Code, raw results, notebook, and report → public GitHub repository.</a:t>
             </a:r>
           </a:p>
         </p:txBody>
@@ -3544,8 +3536,8 @@
         </p:nvSpPr>
         <p:spPr>
           <a:xfrm xmlns:a="http://schemas.openxmlformats.org/drawingml/2006/main">
-            <a:off x="1511811" y="29021186"/>
-            <a:ext cx="16893945" cy="310896"/>
+            <a:off x="1511808" y="29021151"/>
+            <a:ext cx="16893921" cy="310896"/>
           </a:xfrm>
           <a:prstGeom xmlns:a="http://schemas.openxmlformats.org/drawingml/2006/main" prst="rect">
             <a:avLst/>
@@ -3553,7 +3545,7 @@
         </p:spPr>
         <p:txBody>
           <a:bodyPr xmlns:a="http://schemas.openxmlformats.org/drawingml/2006/main" vert="horz" wrap="square" lIns="0" tIns="0" rIns="0" bIns="0" anchor="ctr">
-            <a:normAutofit fontScale="100000"/>
+            <a:noAutofit/>
           </a:bodyPr>
           <a:lstStyle xmlns:a="http://schemas.openxmlformats.org/drawingml/2006/main">
             <a:lvl1pPr algn="ctr">
@@ -3577,9 +3569,9 @@
                 <a:spcPct val="102000"/>
               </a:lnSpc>
               <a:buNone/>
-              <a:defRPr sz="2000" b="0">
-                <a:solidFill>
-                  <a:srgbClr val="5B6268"/>
+              <a:defRPr sz="1500" b="0">
+                <a:solidFill>
+                  <a:srgbClr val="5F6870"/>
                 </a:solidFill>
                 <a:latin typeface="Arial"/>
                 <a:ea typeface="Arial"/>
@@ -3587,15 +3579,15 @@
               </a:defRPr>
             </a:pPr>
             <a:r>
-              <a:rPr sz="2000" b="0">
-                <a:solidFill>
-                  <a:srgbClr val="5B6268"/>
-                </a:solidFill>
-                <a:latin typeface="Arial"/>
-                <a:ea typeface="Arial"/>
-                <a:cs typeface="Arial"/>
-              </a:rPr>
-              <a:t>[2] Hu et al. LoRA: Low-Rank Adaptation of Large Language Models. ICLR 2022.</a:t>
+              <a:rPr sz="1500" b="0">
+                <a:solidFill>
+                  <a:srgbClr val="5F6870"/>
+                </a:solidFill>
+                <a:latin typeface="Arial"/>
+                <a:ea typeface="Arial"/>
+                <a:cs typeface="Arial"/>
+              </a:rPr>
+              <a:t>[3] Hayou et al. LoRA+. ICML 2024.     Statistical protocol and raw CSV: GitHub.</a:t>
             </a:r>
           </a:p>
         </p:txBody>
@@ -3616,8 +3608,8 @@
         </p:nvSpPr>
         <p:spPr>
           <a:xfrm xmlns:a="http://schemas.openxmlformats.org/drawingml/2006/main">
-            <a:off x="1511811" y="28545698"/>
-            <a:ext cx="16893945" cy="310896"/>
+            <a:off x="1511808" y="28545663"/>
+            <a:ext cx="16893921" cy="310896"/>
           </a:xfrm>
           <a:prstGeom xmlns:a="http://schemas.openxmlformats.org/drawingml/2006/main" prst="rect">
             <a:avLst/>
@@ -3625,7 +3617,7 @@
         </p:spPr>
         <p:txBody>
           <a:bodyPr xmlns:a="http://schemas.openxmlformats.org/drawingml/2006/main" vert="horz" wrap="square" lIns="0" tIns="0" rIns="0" bIns="0" anchor="ctr">
-            <a:normAutofit fontScale="100000"/>
+            <a:noAutofit/>
           </a:bodyPr>
           <a:lstStyle xmlns:a="http://schemas.openxmlformats.org/drawingml/2006/main">
             <a:lvl1pPr algn="ctr">
@@ -3649,9 +3641,9 @@
                 <a:spcPct val="102000"/>
               </a:lnSpc>
               <a:buNone/>
-              <a:defRPr sz="2000" b="0">
-                <a:solidFill>
-                  <a:srgbClr val="5B6268"/>
+              <a:defRPr sz="1500" b="0">
+                <a:solidFill>
+                  <a:srgbClr val="5F6870"/>
                 </a:solidFill>
                 <a:latin typeface="Arial"/>
                 <a:ea typeface="Arial"/>
@@ -3659,15 +3651,15 @@
               </a:defRPr>
             </a:pPr>
             <a:r>
-              <a:rPr sz="2000" b="0">
-                <a:solidFill>
-                  <a:srgbClr val="5B6268"/>
-                </a:solidFill>
-                <a:latin typeface="Arial"/>
-                <a:ea typeface="Arial"/>
-                <a:cs typeface="Arial"/>
-              </a:rPr>
-              <a:t>[1] Liu et al. DoRA: Weight-Decomposed Low-Rank Adaptation. ICML 2024, PMLR 235.</a:t>
+              <a:rPr sz="1500" b="0">
+                <a:solidFill>
+                  <a:srgbClr val="5F6870"/>
+                </a:solidFill>
+                <a:latin typeface="Arial"/>
+                <a:ea typeface="Arial"/>
+                <a:cs typeface="Arial"/>
+              </a:rPr>
+              <a:t>[1] Hu et al. LoRA. ICLR 2022.     [2] Liu et al. DoRA. ICML 2024.</a:t>
             </a:r>
           </a:p>
         </p:txBody>
@@ -3809,8 +3801,8 @@
         </p:nvSpPr>
         <p:spPr>
           <a:xfrm xmlns:a="http://schemas.openxmlformats.org/drawingml/2006/main">
-            <a:off x="18135600" y="29870400"/>
-            <a:ext cx="1885950" cy="274320"/>
+            <a:off x="17926050" y="29870400"/>
+            <a:ext cx="2305050" cy="274320"/>
           </a:xfrm>
           <a:prstGeom xmlns:a="http://schemas.openxmlformats.org/drawingml/2006/main" prst="rect">
             <a:avLst/>
@@ -3818,7 +3810,7 @@
         </p:spPr>
         <p:txBody>
           <a:bodyPr xmlns:a="http://schemas.openxmlformats.org/drawingml/2006/main" vert="horz" wrap="square" lIns="0" tIns="0" rIns="0" bIns="0" anchor="ctr">
-            <a:normAutofit fontScale="100000"/>
+            <a:noAutofit/>
           </a:bodyPr>
           <a:lstStyle xmlns:a="http://schemas.openxmlformats.org/drawingml/2006/main">
             <a:lvl1pPr algn="ctr">
@@ -3842,9 +3834,9 @@
                 <a:spcPct val="92000"/>
               </a:lnSpc>
               <a:buNone/>
-              <a:defRPr sz="1650" b="1">
-                <a:solidFill>
-                  <a:srgbClr val="087F78"/>
+              <a:defRPr sz="1275" b="1">
+                <a:solidFill>
+                  <a:srgbClr val="008A80"/>
                 </a:solidFill>
                 <a:latin typeface="Arial"/>
                 <a:ea typeface="Arial"/>
@@ -3852,16 +3844,16 @@
               </a:defRPr>
             </a:pPr>
             <a:r>
-              <a:rPr sz="1650" b="1">
-                <a:solidFill>
-                  <a:srgbClr val="087F78"/>
-                </a:solidFill>
-                <a:latin typeface="Arial"/>
-                <a:ea typeface="Arial"/>
-                <a:cs typeface="Arial"/>
-                <a:hlinkClick xmlns:r="http://schemas.openxmlformats.org/officeDocument/2006/relationships" r:id="R8edebec4c7da4c97"/>
-              </a:rPr>
-              <a:t>КОД И CSV</a:t>
+              <a:rPr sz="1275" b="1">
+                <a:solidFill>
+                  <a:srgbClr val="008A80"/>
+                </a:solidFill>
+                <a:latin typeface="Arial"/>
+                <a:ea typeface="Arial"/>
+                <a:cs typeface="Arial"/>
+                <a:hlinkClick xmlns:r="http://schemas.openxmlformats.org/officeDocument/2006/relationships" r:id="R18da06e1c64b4d42"/>
+              </a:rPr>
+              <a:t>CODE + DATA</a:t>
             </a:r>
           </a:p>
         </p:txBody>
@@ -4212,7 +4204,7 @@
       </p:sp>
       <p:cxnSp>
         <p:nvCxnSpPr>
-          <p:cNvPr id="87" name=""/>
+          <p:cNvPr id="415" name=""/>
           <p:cNvCxnSpPr>
             <a:stCxn xmlns:a="http://schemas.openxmlformats.org/drawingml/2006/main" id="40" idx="3"/>
             <a:endCxn xmlns:a="http://schemas.openxmlformats.org/drawingml/2006/main" id="41" idx="1"/>
@@ -4238,7 +4230,7 @@
       </p:cxnSp>
       <p:cxnSp>
         <p:nvCxnSpPr>
-          <p:cNvPr id="88" name=""/>
+          <p:cNvPr id="416" name=""/>
           <p:cNvCxnSpPr>
             <a:stCxn xmlns:a="http://schemas.openxmlformats.org/drawingml/2006/main" id="41" idx="3"/>
             <a:endCxn xmlns:a="http://schemas.openxmlformats.org/drawingml/2006/main" id="42" idx="1"/>
@@ -4536,7 +4528,7 @@
       </p:sp>
       <p:cxnSp>
         <p:nvCxnSpPr>
-          <p:cNvPr id="93" name=""/>
+          <p:cNvPr id="421" name=""/>
           <p:cNvCxnSpPr>
             <a:stCxn xmlns:a="http://schemas.openxmlformats.org/drawingml/2006/main" id="45" idx="3"/>
             <a:endCxn xmlns:a="http://schemas.openxmlformats.org/drawingml/2006/main" id="46" idx="1"/>
@@ -4562,7 +4554,7 @@
       </p:cxnSp>
       <p:cxnSp>
         <p:nvCxnSpPr>
-          <p:cNvPr id="94" name=""/>
+          <p:cNvPr id="422" name=""/>
           <p:cNvCxnSpPr>
             <a:stCxn xmlns:a="http://schemas.openxmlformats.org/drawingml/2006/main" id="46" idx="3"/>
             <a:endCxn xmlns:a="http://schemas.openxmlformats.org/drawingml/2006/main" id="47" idx="1"/>
@@ -4588,7 +4580,7 @@
       </p:cxnSp>
       <p:cxnSp>
         <p:nvCxnSpPr>
-          <p:cNvPr id="95" name=""/>
+          <p:cNvPr id="423" name=""/>
           <p:cNvCxnSpPr>
             <a:stCxn xmlns:a="http://schemas.openxmlformats.org/drawingml/2006/main" id="47" idx="3"/>
             <a:endCxn xmlns:a="http://schemas.openxmlformats.org/drawingml/2006/main" id="48" idx="1"/>
@@ -4650,7 +4642,7 @@
         </p:spPr>
         <p:txBody>
           <a:bodyPr xmlns:a="http://schemas.openxmlformats.org/drawingml/2006/main" wrap="square" lIns="38100" tIns="19050" rIns="38100" bIns="19050" anchor="ctr">
-            <a:normAutofit fontScale="100000"/>
+            <a:noAutofit/>
           </a:bodyPr>
           <a:lstStyle xmlns:a="http://schemas.openxmlformats.org/drawingml/2006/main"/>
           <a:p xmlns:a="http://schemas.openxmlformats.org/drawingml/2006/main">
@@ -4659,9 +4651,9 @@
                 <a:spcPct val="96000"/>
               </a:lnSpc>
               <a:buNone/>
-              <a:defRPr sz="1725" b="0">
-                <a:solidFill>
-                  <a:srgbClr val="5B6268"/>
+              <a:defRPr sz="1500" b="0">
+                <a:solidFill>
+                  <a:srgbClr val="5F6870"/>
                 </a:solidFill>
                 <a:latin typeface="Arial"/>
                 <a:ea typeface="Arial"/>
@@ -4669,15 +4661,15 @@
               </a:defRPr>
             </a:pPr>
             <a:r>
-              <a:rPr sz="1725" b="0">
-                <a:solidFill>
-                  <a:srgbClr val="5B6268"/>
-                </a:solidFill>
-                <a:latin typeface="Arial"/>
-                <a:ea typeface="Arial"/>
-                <a:cs typeface="Arial"/>
-              </a:rPr>
-              <a:t>направление</a:t>
+              <a:rPr sz="1500" b="0">
+                <a:solidFill>
+                  <a:srgbClr val="5F6870"/>
+                </a:solidFill>
+                <a:latin typeface="Arial"/>
+                <a:ea typeface="Arial"/>
+                <a:cs typeface="Arial"/>
+              </a:rPr>
+              <a:t>direction</a:t>
             </a:r>
           </a:p>
         </p:txBody>
@@ -4720,7 +4712,7 @@
         </p:spPr>
         <p:txBody>
           <a:bodyPr xmlns:a="http://schemas.openxmlformats.org/drawingml/2006/main" wrap="square" lIns="38100" tIns="19050" rIns="38100" bIns="19050" anchor="ctr">
-            <a:normAutofit fontScale="77720"/>
+            <a:normAutofit fontScale="91628"/>
           </a:bodyPr>
           <a:lstStyle xmlns:a="http://schemas.openxmlformats.org/drawingml/2006/main"/>
           <a:p xmlns:a="http://schemas.openxmlformats.org/drawingml/2006/main">
@@ -4729,9 +4721,9 @@
                 <a:spcPct val="96000"/>
               </a:lnSpc>
               <a:buNone/>
-              <a:defRPr sz="1725" b="1">
-                <a:solidFill>
-                  <a:srgbClr val="087F78"/>
+              <a:defRPr sz="1350" b="1">
+                <a:solidFill>
+                  <a:srgbClr val="008A80"/>
                 </a:solidFill>
                 <a:latin typeface="Arial"/>
                 <a:ea typeface="Arial"/>
@@ -4739,15 +4731,15 @@
               </a:defRPr>
             </a:pPr>
             <a:r>
-              <a:rPr sz="1725" b="1">
-                <a:solidFill>
-                  <a:srgbClr val="087F78"/>
-                </a:solidFill>
-                <a:latin typeface="Arial"/>
-                <a:ea typeface="Arial"/>
-                <a:cs typeface="Arial"/>
-              </a:rPr>
-              <a:t>отдельная норма m</a:t>
+              <a:rPr sz="1350" b="1">
+                <a:solidFill>
+                  <a:srgbClr val="008A80"/>
+                </a:solidFill>
+                <a:latin typeface="Arial"/>
+                <a:ea typeface="Arial"/>
+                <a:cs typeface="Arial"/>
+              </a:rPr>
+              <a:t>independent row scale m</a:t>
             </a:r>
           </a:p>
         </p:txBody>
@@ -4790,18 +4782,18 @@
         </p:spPr>
         <p:txBody>
           <a:bodyPr xmlns:a="http://schemas.openxmlformats.org/drawingml/2006/main" wrap="square" lIns="38100" tIns="19050" rIns="38100" bIns="19050" anchor="ctr">
-            <a:normAutofit fontScale="91210"/>
+            <a:noAutofit/>
           </a:bodyPr>
           <a:lstStyle xmlns:a="http://schemas.openxmlformats.org/drawingml/2006/main"/>
           <a:p xmlns:a="http://schemas.openxmlformats.org/drawingml/2006/main">
-            <a:pPr algn="l">
+            <a:pPr algn="ctr">
               <a:lnSpc>
                 <a:spcPct val="96000"/>
               </a:lnSpc>
               <a:buNone/>
-              <a:defRPr sz="1800" b="0">
-                <a:solidFill>
-                  <a:srgbClr val="5B6268"/>
+              <a:defRPr sz="1500" b="0">
+                <a:solidFill>
+                  <a:srgbClr val="5F6870"/>
                 </a:solidFill>
                 <a:latin typeface="Arial"/>
                 <a:ea typeface="Arial"/>
@@ -4809,35 +4801,35 @@
               </a:defRPr>
             </a:pPr>
             <a:r>
-              <a:rPr sz="1800" b="0">
-                <a:solidFill>
-                  <a:srgbClr val="5B6268"/>
-                </a:solidFill>
-                <a:latin typeface="Arial"/>
-                <a:ea typeface="Arial"/>
-                <a:cs typeface="Arial"/>
-              </a:rPr>
-              <a:t>Одинаковый rank r; у DoRA добавляется d_out magnitude-параметров.</a:t>
+              <a:rPr sz="1500" b="0">
+                <a:solidFill>
+                  <a:srgbClr val="5F6870"/>
+                </a:solidFill>
+                <a:latin typeface="Arial"/>
+                <a:ea typeface="Arial"/>
+                <a:cs typeface="Arial"/>
+              </a:rPr>
+              <a:t>Same rank r; DoRA adds d_out trainable magnitude parameters.</a:t>
             </a:r>
           </a:p>
         </p:txBody>
       </p:sp>
       <p:pic>
         <p:nvPicPr>
-          <p:cNvPr id="99" name=""/>
+          <p:cNvPr id="427" name=""/>
           <p:cNvPicPr>
             <a:picLocks xmlns:a="http://schemas.openxmlformats.org/drawingml/2006/main" noChangeAspect="1"/>
           </p:cNvPicPr>
           <p:nvPr/>
         </p:nvPicPr>
         <p:blipFill>
-          <a:blip xmlns:r="http://schemas.openxmlformats.org/officeDocument/2006/relationships" xmlns:a="http://schemas.openxmlformats.org/drawingml/2006/main" r:embed="Rb85b9e7012104491"/>
+          <a:blip xmlns:r="http://schemas.openxmlformats.org/officeDocument/2006/relationships" xmlns:a="http://schemas.openxmlformats.org/drawingml/2006/main" r:embed="R4e6405af2fc94ce2"/>
           <a:stretch xmlns:a="http://schemas.openxmlformats.org/drawingml/2006/main"/>
         </p:blipFill>
         <p:spPr>
-          <a:xfrm xmlns:a="http://schemas.openxmlformats.org/drawingml/2006/main">
-            <a:off x="11540395" y="16130343"/>
-            <a:ext cx="8328851" cy="4250353"/>
+          <a:xfrm xmlns:a="http://schemas.openxmlformats.org/drawingml/2006/main" flipH="0" flipV="0">
+            <a:off x="11540395" y="9240089"/>
+            <a:ext cx="8328851" cy="12552272"/>
           </a:xfrm>
           <a:prstGeom xmlns:a="http://schemas.openxmlformats.org/drawingml/2006/main" prst="rect">
             <a:avLst/>
@@ -4846,14 +4838,14 @@
       </p:pic>
       <p:pic>
         <p:nvPicPr>
-          <p:cNvPr id="100" name=""/>
+          <p:cNvPr id="428" name=""/>
           <p:cNvPicPr>
             <a:picLocks xmlns:a="http://schemas.openxmlformats.org/drawingml/2006/main" noChangeAspect="1"/>
           </p:cNvPicPr>
           <p:nvPr/>
         </p:nvPicPr>
         <p:blipFill>
-          <a:blip xmlns:r="http://schemas.openxmlformats.org/officeDocument/2006/relationships" xmlns:a="http://schemas.openxmlformats.org/drawingml/2006/main" r:embed="Re642377f71264de3"/>
+          <a:blip xmlns:r="http://schemas.openxmlformats.org/officeDocument/2006/relationships" xmlns:a="http://schemas.openxmlformats.org/drawingml/2006/main" r:embed="R4107f0ecd0d041a5"/>
           <a:stretch xmlns:a="http://schemas.openxmlformats.org/drawingml/2006/main"/>
         </p:blipFill>
         <p:spPr>

</xml_diff>